<commit_message>
Update deck to match final Power BI dashboard (product names, 3 pages, slicer demo)
Co-Authored-By: Claude Sonnet 5.5 <noreply@anthropic.com>
Claude-Session: https://claude.ai/code/session_017RLvirTSx84UWnroqbbqTM
</commit_message>
<xml_diff>
--- a/output/EverMart_UTS_BDASC.pptx
+++ b/output/EverMart_UTS_BDASC.pptx
@@ -21,9 +21,10 @@
     <p:sldId id="269" r:id="rId15"/>
     <p:sldId id="270" r:id="rId16"/>
     <p:sldId id="271" r:id="rId17"/>
+    <p:sldId id="272" r:id="rId18"/>
   </p:sldIdLst>
   <p:notesMasterIdLst>
-    <p:notesMasterId r:id="rId18"/>
+    <p:notesMasterId r:id="rId19"/>
   </p:notesMasterIdLst>
   <p:sldSz cx="12192000" cy="6858000"/>
   <p:notesSz cx="6858000" cy="12192000"/>
@@ -974,34 +975,34 @@
                 <c:ptCount val="10"/>
                 <c:lvl>
                   <c:pt idx="0">
-                    <c:v>P041 ComfortLiving Smartphone</c:v>
+                    <c:v>ActiveWear Cookware Set</c:v>
                   </c:pt>
                   <c:pt idx="1">
-                    <c:v>P019 ComfortLiving Sweater</c:v>
+                    <c:v>TechPro Textbook</c:v>
                   </c:pt>
                   <c:pt idx="2">
-                    <c:v>P083 ActiveWear Smartwatch</c:v>
+                    <c:v>BookWorld Sweater</c:v>
                   </c:pt>
                   <c:pt idx="3">
-                    <c:v>P039 TechPro Smartwatch</c:v>
+                    <c:v>BookWorld Cookbook</c:v>
                   </c:pt>
                   <c:pt idx="4">
-                    <c:v>P059 SoundWave Jeans</c:v>
+                    <c:v>TechPro Headphones</c:v>
                   </c:pt>
                   <c:pt idx="5">
-                    <c:v>P062 HomeSense Novel</c:v>
+                    <c:v>ActiveWear Rug</c:v>
                   </c:pt>
                   <c:pt idx="6">
-                    <c:v>P020 ActiveWear Jacket</c:v>
+                    <c:v>ActiveWear Jacket</c:v>
                   </c:pt>
                   <c:pt idx="7">
-                    <c:v>P048 TechPro Cookbook</c:v>
+                    <c:v>SoundWave Novel</c:v>
                   </c:pt>
                   <c:pt idx="8">
-                    <c:v>P079 ActiveWear Rug</c:v>
+                    <c:v>SoundWave Headphones</c:v>
                   </c:pt>
                   <c:pt idx="9">
-                    <c:v>P029 TechPro Headphones</c:v>
+                    <c:v>ActiveWear Smartwatch</c:v>
                   </c:pt>
                 </c:lvl>
               </c:multiLvlStrCache>
@@ -1014,34 +1015,34 @@
                 <c:formatCode>General</c:formatCode>
                 <c:ptCount val="10"/>
                 <c:pt idx="0">
-                  <c:v>13232.12</c:v>
+                  <c:v>18083.73</c:v>
                 </c:pt>
                 <c:pt idx="1">
-                  <c:v>13487.95</c:v>
+                  <c:v>18267.96</c:v>
                 </c:pt>
                 <c:pt idx="2">
-                  <c:v>13671.6</c:v>
+                  <c:v>18743.79</c:v>
                 </c:pt>
                 <c:pt idx="3">
-                  <c:v>13778.88</c:v>
+                  <c:v>19221.99</c:v>
                 </c:pt>
                 <c:pt idx="4">
-                  <c:v>13947.2</c:v>
+                  <c:v>19513.8</c:v>
                 </c:pt>
                 <c:pt idx="5">
-                  <c:v>14592.24</c:v>
+                  <c:v>22314.43</c:v>
                 </c:pt>
                 <c:pt idx="6">
-                  <c:v>15060.92</c:v>
+                  <c:v>22712.56</c:v>
                 </c:pt>
                 <c:pt idx="7">
-                  <c:v>17905.2</c:v>
+                  <c:v>24507.9</c:v>
                 </c:pt>
                 <c:pt idx="8">
-                  <c:v>17946.91</c:v>
+                  <c:v>25211.64</c:v>
                 </c:pt>
                 <c:pt idx="9">
-                  <c:v>19513.8</c:v>
+                  <c:v>39096.97</c:v>
                 </c:pt>
               </c:numCache>
             </c:numRef>
@@ -1840,7 +1841,7 @@
           <a:p>
             <a:r>
               <a:rPr lang="en-US" dirty="0"/>
-              <a:t/>
+              <a:t>Grafik ini mengikuti bar chart di dashboard, yang mengelompokkan per ProductName. Produk tunggal terlaris berdasarkan ProductID adalah P029 TechPro Headphones (19.514).</a:t>
             </a:r>
             <a:endParaRPr lang="en-US" dirty="0"/>
           </a:p>
@@ -2016,7 +2017,7 @@
           <a:p>
             <a:r>
               <a:rPr lang="en-US" dirty="0"/>
-              <a:t>Demo langsung: pilih satu Region di slicer lalu tunjukkan semua grafik ikut berubah.</a:t>
+              <a:t>Demo langsung: pilih satu Region di slicer lalu tunjukkan semua kartu dan tabel ikut berubah.</a:t>
             </a:r>
             <a:endParaRPr lang="en-US" dirty="0"/>
           </a:p>
@@ -2104,7 +2105,7 @@
           <a:p>
             <a:r>
               <a:rPr lang="en-US" dirty="0"/>
-              <a:t/>
+              <a:t>Tunjukkan langsung di Power BI: klik South America di slicer, lalu klik lagi untuk membatalkan.</a:t>
             </a:r>
             <a:endParaRPr lang="en-US" dirty="0"/>
           </a:p>
@@ -2216,6 +2217,94 @@
             <a:fld id="{F7021451-1387-4CA6-816F-3879F97B5CBC}" type="slidenum">
               <a:rPr lang="en-US"/>
               <a:t>16</a:t>
+            </a:fld>
+            <a:endParaRPr lang="en-US"/>
+          </a:p>
+        </p:txBody>
+      </p:sp>
+    </p:spTree>
+    <p:extLst>
+      <p:ext uri="{BB962C8B-B14F-4D97-AF65-F5344CB8AC3E}">
+        <p14:creationId xmlns:p14="http://schemas.microsoft.com/office/powerpoint/2010/main" val="1024086991"/>
+      </p:ext>
+    </p:extLst>
+  </p:cSld>
+  <p:clrMapOvr>
+    <a:masterClrMapping/>
+  </p:clrMapOvr>
+</p:notes>
+</file>
+
+<file path=ppt/notesSlides/notesSlide17.xml><?xml version="1.0" encoding="utf-8"?>
+<p:notes xmlns:a="http://schemas.openxmlformats.org/drawingml/2006/main" xmlns:r="http://schemas.openxmlformats.org/officeDocument/2006/relationships" xmlns:p="http://schemas.openxmlformats.org/presentationml/2006/main">
+  <p:cSld>
+    <p:spTree>
+      <p:nvGrpSpPr>
+        <p:cNvPr id="1" name=""/>
+        <p:cNvGrpSpPr/>
+        <p:nvPr/>
+      </p:nvGrpSpPr>
+      <p:grpSpPr>
+        <a:xfrm>
+          <a:off x="0" y="0"/>
+          <a:ext cx="0" cy="0"/>
+          <a:chOff x="0" y="0"/>
+          <a:chExt cx="0" cy="0"/>
+        </a:xfrm>
+      </p:grpSpPr>
+      <p:sp>
+        <p:nvSpPr>
+          <p:cNvPr id="2" name="Slide Image Placeholder 1"/>
+          <p:cNvSpPr>
+            <a:spLocks noGrp="1" noRot="1" noChangeAspect="1"/>
+          </p:cNvSpPr>
+          <p:nvPr>
+            <p:ph type="sldImg"/>
+          </p:nvPr>
+        </p:nvSpPr>
+        <p:spPr/>
+      </p:sp>
+      <p:sp>
+        <p:nvSpPr>
+          <p:cNvPr id="3" name="Notes Placeholder 2"/>
+          <p:cNvSpPr>
+            <a:spLocks noGrp="1"/>
+          </p:cNvSpPr>
+          <p:nvPr>
+            <p:ph type="body" idx="1"/>
+          </p:nvPr>
+        </p:nvSpPr>
+        <p:spPr/>
+        <p:txBody>
+          <a:bodyPr/>
+          <a:lstStyle/>
+          <a:p>
+            <a:r>
+              <a:rPr lang="en-US" dirty="0"/>
+              <a:t/>
+            </a:r>
+            <a:endParaRPr lang="en-US" dirty="0"/>
+          </a:p>
+        </p:txBody>
+      </p:sp>
+      <p:sp>
+        <p:nvSpPr>
+          <p:cNvPr id="4" name="Slide Number Placeholder 3"/>
+          <p:cNvSpPr>
+            <a:spLocks noGrp="1"/>
+          </p:cNvSpPr>
+          <p:nvPr>
+            <p:ph type="sldNum" sz="quarter" idx="10"/>
+          </p:nvPr>
+        </p:nvSpPr>
+        <p:spPr/>
+        <p:txBody>
+          <a:bodyPr/>
+          <a:lstStyle/>
+          <a:p>
+            <a:fld id="{F7021451-1387-4CA6-816F-3879F97B5CBC}" type="slidenum">
+              <a:rPr lang="en-US"/>
+              <a:t>17</a:t>
             </a:fld>
             <a:endParaRPr lang="en-US"/>
           </a:p>
@@ -4847,7 +4936,7 @@
                 <a:ea typeface="Cambria" pitchFamily="34" charset="-122"/>
                 <a:cs typeface="Cambria" pitchFamily="34" charset="-120"/>
               </a:rPr>
-              <a:t>10 produk dengan revenue tertinggi</a:t>
+              <a:t>10 nama produk dengan revenue tertinggi</a:t>
             </a:r>
             <a:endParaRPr lang="en-US" sz="3400" dirty="0"/>
           </a:p>
@@ -4968,7 +5057,7 @@
                 <a:ea typeface="Calibri" pitchFamily="34" charset="-122"/>
                 <a:cs typeface="Calibri" pitchFamily="34" charset="-120"/>
               </a:rPr>
-              <a:t>P029 TechPro Headphones teratas (19.514). Electronics muncul 4 kali di 10 besar, Clothing 3 kali, Books 2 kali, Home Decor 1 kali.</a:t>
+              <a:t>ActiveWear Smartwatch teratas dengan 39.097, karena nama itu dipakai 4 ProductID yang dijumlahkan. Electronics muncul 3 kali di 10 besar. Nama yang sama bisa mewakili beberapa produk.</a:t>
             </a:r>
             <a:endParaRPr lang="en-US" sz="1600" dirty="0"/>
           </a:p>
@@ -6124,11 +6213,11 @@
         <p:spPr>
           <a:xfrm>
             <a:off x="548640" y="1463040"/>
-            <a:ext cx="5394960" cy="4206240"/>
+            <a:ext cx="3566160" cy="4206240"/>
           </a:xfrm>
           <a:prstGeom prst="roundRect">
             <a:avLst>
-              <a:gd name="adj" fmla="val 2609"/>
+              <a:gd name="adj" fmla="val 3077"/>
             </a:avLst>
           </a:prstGeom>
           <a:solidFill>
@@ -6151,7 +6240,7 @@
         <p:spPr>
           <a:xfrm>
             <a:off x="777240" y="1645920"/>
-            <a:ext cx="4937760" cy="457200"/>
+            <a:ext cx="3108960" cy="457200"/>
           </a:xfrm>
           <a:prstGeom prst="rect">
             <a:avLst/>
@@ -6175,7 +6264,7 @@
                 <a:ea typeface="Cambria" pitchFamily="34" charset="-122"/>
                 <a:cs typeface="Cambria" pitchFamily="34" charset="-120"/>
               </a:rPr>
-              <a:t>Halaman 1: Revenue Report</a:t>
+              <a:t>1. Revenue Report</a:t>
             </a:r>
             <a:endParaRPr lang="en-US" sz="2000" dirty="0"/>
           </a:p>
@@ -6190,7 +6279,7 @@
         <p:spPr>
           <a:xfrm>
             <a:off x="777240" y="2148840"/>
-            <a:ext cx="4937760" cy="3337560"/>
+            <a:ext cx="3108960" cy="3337560"/>
           </a:xfrm>
           <a:prstGeom prst="rect">
             <a:avLst/>
@@ -6214,7 +6303,7 @@
                 <a:ea typeface="Calibri" pitchFamily="34" charset="-122"/>
                 <a:cs typeface="Calibri" pitchFamily="34" charset="-120"/>
               </a:rPr>
-              <a:t>Line chart Total Revenue per tanggal. Bar chart penjualan per produk. Donut chart penjualan per kategori. Tabel ringkasan: produk, pelanggan, transaksi, revenue.</a:t>
+              <a:t>Tabel ringkasan, line chart revenue per bulan, bar chart per produk, dan donut per kategori.</a:t>
             </a:r>
             <a:endParaRPr lang="en-US" sz="1600" dirty="0"/>
           </a:p>
@@ -6228,12 +6317,12 @@
         </p:nvSpPr>
         <p:spPr>
           <a:xfrm>
-            <a:off x="6217920" y="1463040"/>
-            <a:ext cx="5394960" cy="4206240"/>
+            <a:off x="4297680" y="1463040"/>
+            <a:ext cx="3566160" cy="4206240"/>
           </a:xfrm>
           <a:prstGeom prst="roundRect">
             <a:avLst>
-              <a:gd name="adj" fmla="val 2609"/>
+              <a:gd name="adj" fmla="val 3077"/>
             </a:avLst>
           </a:prstGeom>
           <a:solidFill>
@@ -6255,8 +6344,8 @@
         </p:nvSpPr>
         <p:spPr>
           <a:xfrm>
-            <a:off x="6446520" y="1645920"/>
-            <a:ext cx="4937760" cy="457200"/>
+            <a:off x="4526280" y="1645920"/>
+            <a:ext cx="3108960" cy="457200"/>
           </a:xfrm>
           <a:prstGeom prst="rect">
             <a:avLst/>
@@ -6280,7 +6369,7 @@
                 <a:ea typeface="Cambria" pitchFamily="34" charset="-122"/>
                 <a:cs typeface="Cambria" pitchFamily="34" charset="-120"/>
               </a:rPr>
-              <a:t>Halaman 2: Customer Behavior</a:t>
+              <a:t>2. Customer Behavior</a:t>
             </a:r>
             <a:endParaRPr lang="en-US" sz="2000" dirty="0"/>
           </a:p>
@@ -6294,8 +6383,8 @@
         </p:nvSpPr>
         <p:spPr>
           <a:xfrm>
-            <a:off x="6446520" y="2148840"/>
-            <a:ext cx="4937760" cy="3337560"/>
+            <a:off x="4526280" y="2148840"/>
+            <a:ext cx="3108960" cy="3337560"/>
           </a:xfrm>
           <a:prstGeom prst="rect">
             <a:avLst/>
@@ -6319,7 +6408,112 @@
                 <a:ea typeface="Calibri" pitchFamily="34" charset="-122"/>
                 <a:cs typeface="Calibri" pitchFamily="34" charset="-120"/>
               </a:rPr>
-              <a:t>Peta pelanggan per wilayah, tabel Share of Total, kolom dan line chart revenue per kategori. Slicer: Region, Price, TransactionDate (Year, Quarter, Month), dan Quantity.</a:t>
+              <a:t>Peta pelanggan per wilayah, tabel Share of Total, serta grafik revenue per kategori. Slicer: Region, Price, tanggal, Quantity.</a:t>
+            </a:r>
+            <a:endParaRPr lang="en-US" sz="1600" dirty="0"/>
+          </a:p>
+        </p:txBody>
+      </p:sp>
+      <p:sp>
+        <p:nvSpPr>
+          <p:cNvPr id="9" name="Shape 7"/>
+          <p:cNvSpPr/>
+          <p:nvPr/>
+        </p:nvSpPr>
+        <p:spPr>
+          <a:xfrm>
+            <a:off x="8046720" y="1463040"/>
+            <a:ext cx="3566160" cy="4206240"/>
+          </a:xfrm>
+          <a:prstGeom prst="roundRect">
+            <a:avLst>
+              <a:gd name="adj" fmla="val 3077"/>
+            </a:avLst>
+          </a:prstGeom>
+          <a:solidFill>
+            <a:srgbClr val="F3F6F8"/>
+          </a:solidFill>
+          <a:ln w="12700">
+            <a:solidFill>
+              <a:srgbClr val="F3F6F8"/>
+            </a:solidFill>
+            <a:prstDash val="solid"/>
+          </a:ln>
+        </p:spPr>
+      </p:sp>
+      <p:sp>
+        <p:nvSpPr>
+          <p:cNvPr id="10" name="Text 8"/>
+          <p:cNvSpPr txBox="1"/>
+          <p:nvPr/>
+        </p:nvSpPr>
+        <p:spPr>
+          <a:xfrm>
+            <a:off x="8275320" y="1645920"/>
+            <a:ext cx="3108960" cy="457200"/>
+          </a:xfrm>
+          <a:prstGeom prst="rect">
+            <a:avLst/>
+          </a:prstGeom>
+          <a:noFill/>
+          <a:ln/>
+        </p:spPr>
+        <p:txBody>
+          <a:bodyPr wrap="square" lIns="0" tIns="0" rIns="0" bIns="0" rtlCol="0" anchor="ctr"/>
+          <a:lstStyle/>
+          <a:p>
+            <a:pPr indent="0" marL="0">
+              <a:buNone/>
+            </a:pPr>
+            <a:r>
+              <a:rPr lang="en-US" sz="2000" b="1" dirty="0">
+                <a:solidFill>
+                  <a:srgbClr val="12304A"/>
+                </a:solidFill>
+                <a:latin typeface="Cambria" pitchFamily="34" charset="0"/>
+                <a:ea typeface="Cambria" pitchFamily="34" charset="-122"/>
+                <a:cs typeface="Cambria" pitchFamily="34" charset="-120"/>
+              </a:rPr>
+              <a:t>3. KPI Summary</a:t>
+            </a:r>
+            <a:endParaRPr lang="en-US" sz="2000" dirty="0"/>
+          </a:p>
+        </p:txBody>
+      </p:sp>
+      <p:sp>
+        <p:nvSpPr>
+          <p:cNvPr id="11" name="Text 9"/>
+          <p:cNvSpPr txBox="1"/>
+          <p:nvPr/>
+        </p:nvSpPr>
+        <p:spPr>
+          <a:xfrm>
+            <a:off x="8275320" y="2148840"/>
+            <a:ext cx="3108960" cy="3337560"/>
+          </a:xfrm>
+          <a:prstGeom prst="rect">
+            <a:avLst/>
+          </a:prstGeom>
+          <a:noFill/>
+          <a:ln/>
+        </p:spPr>
+        <p:txBody>
+          <a:bodyPr wrap="square" lIns="0" tIns="0" rIns="0" bIns="0" rtlCol="0" anchor="t"/>
+          <a:lstStyle/>
+          <a:p>
+            <a:pPr indent="0" marL="0">
+              <a:buNone/>
+            </a:pPr>
+            <a:r>
+              <a:rPr lang="en-US" sz="1600" dirty="0">
+                <a:solidFill>
+                  <a:srgbClr val="1E2A35"/>
+                </a:solidFill>
+                <a:latin typeface="Calibri" pitchFamily="34" charset="0"/>
+                <a:ea typeface="Calibri" pitchFamily="34" charset="-122"/>
+                <a:cs typeface="Calibri" pitchFamily="34" charset="-120"/>
+              </a:rPr>
+              <a:t>Empat kartu KPI dari measure DAX, slicer Region, dan tabel per wilayah dengan Revenue per Customer dan Revenue Share %.</a:t>
             </a:r>
             <a:endParaRPr lang="en-US" sz="1600" dirty="0"/>
           </a:p>
@@ -6390,6 +6584,494 @@
                 <a:ea typeface="Cambria" pitchFamily="34" charset="-122"/>
                 <a:cs typeface="Cambria" pitchFamily="34" charset="-120"/>
               </a:rPr>
+              <a:t>Contoh filter interaktif: South America</a:t>
+            </a:r>
+            <a:endParaRPr lang="en-US" sz="3400" dirty="0"/>
+          </a:p>
+        </p:txBody>
+      </p:sp>
+      <p:sp>
+        <p:nvSpPr>
+          <p:cNvPr id="3" name="Text 1"/>
+          <p:cNvSpPr txBox="1"/>
+          <p:nvPr/>
+        </p:nvSpPr>
+        <p:spPr>
+          <a:xfrm>
+            <a:off x="548640" y="1554480"/>
+            <a:ext cx="2651760" cy="822960"/>
+          </a:xfrm>
+          <a:prstGeom prst="rect">
+            <a:avLst/>
+          </a:prstGeom>
+          <a:noFill/>
+          <a:ln/>
+        </p:spPr>
+        <p:txBody>
+          <a:bodyPr wrap="square" lIns="0" tIns="0" rIns="0" bIns="0" rtlCol="0" anchor="ctr"/>
+          <a:lstStyle/>
+          <a:p>
+            <a:pPr indent="0" marL="0">
+              <a:buNone/>
+            </a:pPr>
+            <a:r>
+              <a:rPr lang="en-US" sz="4800" b="1" dirty="0">
+                <a:solidFill>
+                  <a:srgbClr val="1B7F8C"/>
+                </a:solidFill>
+                <a:latin typeface="Cambria" pitchFamily="34" charset="0"/>
+                <a:ea typeface="Cambria" pitchFamily="34" charset="-122"/>
+                <a:cs typeface="Cambria" pitchFamily="34" charset="-120"/>
+              </a:rPr>
+              <a:t>219.353</a:t>
+            </a:r>
+            <a:endParaRPr lang="en-US" sz="4800" dirty="0"/>
+          </a:p>
+        </p:txBody>
+      </p:sp>
+      <p:sp>
+        <p:nvSpPr>
+          <p:cNvPr id="4" name="Text 2"/>
+          <p:cNvSpPr txBox="1"/>
+          <p:nvPr/>
+        </p:nvSpPr>
+        <p:spPr>
+          <a:xfrm>
+            <a:off x="548640" y="2377440"/>
+            <a:ext cx="2651760" cy="365760"/>
+          </a:xfrm>
+          <a:prstGeom prst="rect">
+            <a:avLst/>
+          </a:prstGeom>
+          <a:noFill/>
+          <a:ln/>
+        </p:spPr>
+        <p:txBody>
+          <a:bodyPr wrap="square" lIns="0" tIns="0" rIns="0" bIns="0" rtlCol="0" anchor="ctr"/>
+          <a:lstStyle/>
+          <a:p>
+            <a:pPr indent="0" marL="0">
+              <a:buNone/>
+            </a:pPr>
+            <a:r>
+              <a:rPr lang="en-US" sz="1400" dirty="0">
+                <a:solidFill>
+                  <a:srgbClr val="5B6B79"/>
+                </a:solidFill>
+                <a:latin typeface="Calibri" pitchFamily="34" charset="0"/>
+                <a:ea typeface="Calibri" pitchFamily="34" charset="-122"/>
+                <a:cs typeface="Calibri" pitchFamily="34" charset="-120"/>
+              </a:rPr>
+              <a:t>Total Revenue</a:t>
+            </a:r>
+            <a:endParaRPr lang="en-US" sz="1400" dirty="0"/>
+          </a:p>
+        </p:txBody>
+      </p:sp>
+      <p:sp>
+        <p:nvSpPr>
+          <p:cNvPr id="5" name="Text 3"/>
+          <p:cNvSpPr txBox="1"/>
+          <p:nvPr/>
+        </p:nvSpPr>
+        <p:spPr>
+          <a:xfrm>
+            <a:off x="3383280" y="1554480"/>
+            <a:ext cx="2651760" cy="822960"/>
+          </a:xfrm>
+          <a:prstGeom prst="rect">
+            <a:avLst/>
+          </a:prstGeom>
+          <a:noFill/>
+          <a:ln/>
+        </p:spPr>
+        <p:txBody>
+          <a:bodyPr wrap="square" lIns="0" tIns="0" rIns="0" bIns="0" rtlCol="0" anchor="ctr"/>
+          <a:lstStyle/>
+          <a:p>
+            <a:pPr indent="0" marL="0">
+              <a:buNone/>
+            </a:pPr>
+            <a:r>
+              <a:rPr lang="en-US" sz="4800" b="1" dirty="0">
+                <a:solidFill>
+                  <a:srgbClr val="F28C28"/>
+                </a:solidFill>
+                <a:latin typeface="Cambria" pitchFamily="34" charset="0"/>
+                <a:ea typeface="Cambria" pitchFamily="34" charset="-122"/>
+                <a:cs typeface="Cambria" pitchFamily="34" charset="-120"/>
+              </a:rPr>
+              <a:t>304</a:t>
+            </a:r>
+            <a:endParaRPr lang="en-US" sz="4800" dirty="0"/>
+          </a:p>
+        </p:txBody>
+      </p:sp>
+      <p:sp>
+        <p:nvSpPr>
+          <p:cNvPr id="6" name="Text 4"/>
+          <p:cNvSpPr txBox="1"/>
+          <p:nvPr/>
+        </p:nvSpPr>
+        <p:spPr>
+          <a:xfrm>
+            <a:off x="3383280" y="2377440"/>
+            <a:ext cx="2651760" cy="365760"/>
+          </a:xfrm>
+          <a:prstGeom prst="rect">
+            <a:avLst/>
+          </a:prstGeom>
+          <a:noFill/>
+          <a:ln/>
+        </p:spPr>
+        <p:txBody>
+          <a:bodyPr wrap="square" lIns="0" tIns="0" rIns="0" bIns="0" rtlCol="0" anchor="ctr"/>
+          <a:lstStyle/>
+          <a:p>
+            <a:pPr indent="0" marL="0">
+              <a:buNone/>
+            </a:pPr>
+            <a:r>
+              <a:rPr lang="en-US" sz="1400" dirty="0">
+                <a:solidFill>
+                  <a:srgbClr val="5B6B79"/>
+                </a:solidFill>
+                <a:latin typeface="Calibri" pitchFamily="34" charset="0"/>
+                <a:ea typeface="Calibri" pitchFamily="34" charset="-122"/>
+                <a:cs typeface="Calibri" pitchFamily="34" charset="-120"/>
+              </a:rPr>
+              <a:t>Total Transactions</a:t>
+            </a:r>
+            <a:endParaRPr lang="en-US" sz="1400" dirty="0"/>
+          </a:p>
+        </p:txBody>
+      </p:sp>
+      <p:sp>
+        <p:nvSpPr>
+          <p:cNvPr id="7" name="Text 5"/>
+          <p:cNvSpPr txBox="1"/>
+          <p:nvPr/>
+        </p:nvSpPr>
+        <p:spPr>
+          <a:xfrm>
+            <a:off x="6217920" y="1554480"/>
+            <a:ext cx="2651760" cy="822960"/>
+          </a:xfrm>
+          <a:prstGeom prst="rect">
+            <a:avLst/>
+          </a:prstGeom>
+          <a:noFill/>
+          <a:ln/>
+        </p:spPr>
+        <p:txBody>
+          <a:bodyPr wrap="square" lIns="0" tIns="0" rIns="0" bIns="0" rtlCol="0" anchor="ctr"/>
+          <a:lstStyle/>
+          <a:p>
+            <a:pPr indent="0" marL="0">
+              <a:buNone/>
+            </a:pPr>
+            <a:r>
+              <a:rPr lang="en-US" sz="4800" b="1" dirty="0">
+                <a:solidFill>
+                  <a:srgbClr val="12304A"/>
+                </a:solidFill>
+                <a:latin typeface="Cambria" pitchFamily="34" charset="0"/>
+                <a:ea typeface="Cambria" pitchFamily="34" charset="-122"/>
+                <a:cs typeface="Cambria" pitchFamily="34" charset="-120"/>
+              </a:rPr>
+              <a:t>59</a:t>
+            </a:r>
+            <a:endParaRPr lang="en-US" sz="4800" dirty="0"/>
+          </a:p>
+        </p:txBody>
+      </p:sp>
+      <p:sp>
+        <p:nvSpPr>
+          <p:cNvPr id="8" name="Text 6"/>
+          <p:cNvSpPr txBox="1"/>
+          <p:nvPr/>
+        </p:nvSpPr>
+        <p:spPr>
+          <a:xfrm>
+            <a:off x="6217920" y="2377440"/>
+            <a:ext cx="2651760" cy="365760"/>
+          </a:xfrm>
+          <a:prstGeom prst="rect">
+            <a:avLst/>
+          </a:prstGeom>
+          <a:noFill/>
+          <a:ln/>
+        </p:spPr>
+        <p:txBody>
+          <a:bodyPr wrap="square" lIns="0" tIns="0" rIns="0" bIns="0" rtlCol="0" anchor="ctr"/>
+          <a:lstStyle/>
+          <a:p>
+            <a:pPr indent="0" marL="0">
+              <a:buNone/>
+            </a:pPr>
+            <a:r>
+              <a:rPr lang="en-US" sz="1400" dirty="0">
+                <a:solidFill>
+                  <a:srgbClr val="5B6B79"/>
+                </a:solidFill>
+                <a:latin typeface="Calibri" pitchFamily="34" charset="0"/>
+                <a:ea typeface="Calibri" pitchFamily="34" charset="-122"/>
+                <a:cs typeface="Calibri" pitchFamily="34" charset="-120"/>
+              </a:rPr>
+              <a:t>Total Unique Customers</a:t>
+            </a:r>
+            <a:endParaRPr lang="en-US" sz="1400" dirty="0"/>
+          </a:p>
+        </p:txBody>
+      </p:sp>
+      <p:sp>
+        <p:nvSpPr>
+          <p:cNvPr id="9" name="Text 7"/>
+          <p:cNvSpPr txBox="1"/>
+          <p:nvPr/>
+        </p:nvSpPr>
+        <p:spPr>
+          <a:xfrm>
+            <a:off x="9052560" y="1554480"/>
+            <a:ext cx="2651760" cy="822960"/>
+          </a:xfrm>
+          <a:prstGeom prst="rect">
+            <a:avLst/>
+          </a:prstGeom>
+          <a:noFill/>
+          <a:ln/>
+        </p:spPr>
+        <p:txBody>
+          <a:bodyPr wrap="square" lIns="0" tIns="0" rIns="0" bIns="0" rtlCol="0" anchor="ctr"/>
+          <a:lstStyle/>
+          <a:p>
+            <a:pPr indent="0" marL="0">
+              <a:buNone/>
+            </a:pPr>
+            <a:r>
+              <a:rPr lang="en-US" sz="4800" b="1" dirty="0">
+                <a:solidFill>
+                  <a:srgbClr val="1B7F8C"/>
+                </a:solidFill>
+                <a:latin typeface="Cambria" pitchFamily="34" charset="0"/>
+                <a:ea typeface="Cambria" pitchFamily="34" charset="-122"/>
+                <a:cs typeface="Cambria" pitchFamily="34" charset="-120"/>
+              </a:rPr>
+              <a:t>721,55</a:t>
+            </a:r>
+            <a:endParaRPr lang="en-US" sz="4800" dirty="0"/>
+          </a:p>
+        </p:txBody>
+      </p:sp>
+      <p:sp>
+        <p:nvSpPr>
+          <p:cNvPr id="10" name="Text 8"/>
+          <p:cNvSpPr txBox="1"/>
+          <p:nvPr/>
+        </p:nvSpPr>
+        <p:spPr>
+          <a:xfrm>
+            <a:off x="9052560" y="2377440"/>
+            <a:ext cx="2651760" cy="365760"/>
+          </a:xfrm>
+          <a:prstGeom prst="rect">
+            <a:avLst/>
+          </a:prstGeom>
+          <a:noFill/>
+          <a:ln/>
+        </p:spPr>
+        <p:txBody>
+          <a:bodyPr wrap="square" lIns="0" tIns="0" rIns="0" bIns="0" rtlCol="0" anchor="ctr"/>
+          <a:lstStyle/>
+          <a:p>
+            <a:pPr indent="0" marL="0">
+              <a:buNone/>
+            </a:pPr>
+            <a:r>
+              <a:rPr lang="en-US" sz="1400" dirty="0">
+                <a:solidFill>
+                  <a:srgbClr val="5B6B79"/>
+                </a:solidFill>
+                <a:latin typeface="Calibri" pitchFamily="34" charset="0"/>
+                <a:ea typeface="Calibri" pitchFamily="34" charset="-122"/>
+                <a:cs typeface="Calibri" pitchFamily="34" charset="-120"/>
+              </a:rPr>
+              <a:t>Avg Order Value</a:t>
+            </a:r>
+            <a:endParaRPr lang="en-US" sz="1400" dirty="0"/>
+          </a:p>
+        </p:txBody>
+      </p:sp>
+      <p:sp>
+        <p:nvSpPr>
+          <p:cNvPr id="11" name="Shape 9"/>
+          <p:cNvSpPr/>
+          <p:nvPr/>
+        </p:nvSpPr>
+        <p:spPr>
+          <a:xfrm>
+            <a:off x="548640" y="3383280"/>
+            <a:ext cx="11064240" cy="2377440"/>
+          </a:xfrm>
+          <a:prstGeom prst="roundRect">
+            <a:avLst>
+              <a:gd name="adj" fmla="val 4615"/>
+            </a:avLst>
+          </a:prstGeom>
+          <a:solidFill>
+            <a:srgbClr val="F3F6F8"/>
+          </a:solidFill>
+          <a:ln w="12700">
+            <a:solidFill>
+              <a:srgbClr val="F3F6F8"/>
+            </a:solidFill>
+            <a:prstDash val="solid"/>
+          </a:ln>
+        </p:spPr>
+      </p:sp>
+      <p:sp>
+        <p:nvSpPr>
+          <p:cNvPr id="12" name="Text 10"/>
+          <p:cNvSpPr txBox="1"/>
+          <p:nvPr/>
+        </p:nvSpPr>
+        <p:spPr>
+          <a:xfrm>
+            <a:off x="777240" y="3566160"/>
+            <a:ext cx="10607040" cy="457200"/>
+          </a:xfrm>
+          <a:prstGeom prst="rect">
+            <a:avLst/>
+          </a:prstGeom>
+          <a:noFill/>
+          <a:ln/>
+        </p:spPr>
+        <p:txBody>
+          <a:bodyPr wrap="square" lIns="0" tIns="0" rIns="0" bIns="0" rtlCol="0" anchor="ctr"/>
+          <a:lstStyle/>
+          <a:p>
+            <a:pPr indent="0" marL="0">
+              <a:buNone/>
+            </a:pPr>
+            <a:r>
+              <a:rPr lang="en-US" sz="2000" b="1" dirty="0">
+                <a:solidFill>
+                  <a:srgbClr val="12304A"/>
+                </a:solidFill>
+                <a:latin typeface="Cambria" pitchFamily="34" charset="0"/>
+                <a:ea typeface="Cambria" pitchFamily="34" charset="-122"/>
+                <a:cs typeface="Cambria" pitchFamily="34" charset="-120"/>
+              </a:rPr>
+              <a:t>Makna</a:t>
+            </a:r>
+            <a:endParaRPr lang="en-US" sz="2000" dirty="0"/>
+          </a:p>
+        </p:txBody>
+      </p:sp>
+      <p:sp>
+        <p:nvSpPr>
+          <p:cNvPr id="13" name="Text 11"/>
+          <p:cNvSpPr txBox="1"/>
+          <p:nvPr/>
+        </p:nvSpPr>
+        <p:spPr>
+          <a:xfrm>
+            <a:off x="777240" y="4069080"/>
+            <a:ext cx="10607040" cy="1508760"/>
+          </a:xfrm>
+          <a:prstGeom prst="rect">
+            <a:avLst/>
+          </a:prstGeom>
+          <a:noFill/>
+          <a:ln/>
+        </p:spPr>
+        <p:txBody>
+          <a:bodyPr wrap="square" lIns="0" tIns="0" rIns="0" bIns="0" rtlCol="0" anchor="t"/>
+          <a:lstStyle/>
+          <a:p>
+            <a:pPr indent="0" marL="0">
+              <a:buNone/>
+            </a:pPr>
+            <a:r>
+              <a:rPr lang="en-US" sz="1600" dirty="0">
+                <a:solidFill>
+                  <a:srgbClr val="1E2A35"/>
+                </a:solidFill>
+                <a:latin typeface="Calibri" pitchFamily="34" charset="0"/>
+                <a:ea typeface="Calibri" pitchFamily="34" charset="-122"/>
+                <a:cs typeface="Calibri" pitchFamily="34" charset="-120"/>
+              </a:rPr>
+              <a:t>Saat slicer Region dipilih South America, seluruh measure DAX dihitung ulang hanya untuk wilayah itu. Wilayah ini menyumbang 31,8% revenue dengan 59 pelanggan aktif dan nilai rata-rata per transaksi 721,55, lebih tinggi dari rata-rata keseluruhan 690,00.</a:t>
+            </a:r>
+            <a:endParaRPr lang="en-US" sz="1600" dirty="0"/>
+          </a:p>
+        </p:txBody>
+      </p:sp>
+    </p:spTree>
+  </p:cSld>
+  <p:clrMapOvr>
+    <a:masterClrMapping/>
+  </p:clrMapOvr>
+</p:sld>
+</file>
+
+<file path=ppt/slides/slide16.xml><?xml version="1.0" encoding="utf-8"?>
+<p:sld xmlns:a="http://schemas.openxmlformats.org/drawingml/2006/main" xmlns:r="http://schemas.openxmlformats.org/officeDocument/2006/relationships" xmlns:p="http://schemas.openxmlformats.org/presentationml/2006/main">
+  <p:cSld name="Slide 16">
+    <p:bg>
+      <p:bgPr>
+        <a:solidFill>
+          <a:srgbClr val="FFFFFF"/>
+        </a:solidFill>
+      </p:bgPr>
+    </p:bg>
+    <p:spTree>
+      <p:nvGrpSpPr>
+        <p:cNvPr id="1" name=""/>
+        <p:cNvGrpSpPr/>
+        <p:nvPr/>
+      </p:nvGrpSpPr>
+      <p:grpSpPr>
+        <a:xfrm>
+          <a:off x="0" y="0"/>
+          <a:ext cx="0" cy="0"/>
+          <a:chOff x="0" y="0"/>
+          <a:chExt cx="0" cy="0"/>
+        </a:xfrm>
+      </p:grpSpPr>
+      <p:sp>
+        <p:nvSpPr>
+          <p:cNvPr id="2" name="Text 0"/>
+          <p:cNvSpPr txBox="1"/>
+          <p:nvPr/>
+        </p:nvSpPr>
+        <p:spPr>
+          <a:xfrm>
+            <a:off x="548640" y="365760"/>
+            <a:ext cx="11064240" cy="731520"/>
+          </a:xfrm>
+          <a:prstGeom prst="rect">
+            <a:avLst/>
+          </a:prstGeom>
+          <a:noFill/>
+          <a:ln/>
+        </p:spPr>
+        <p:txBody>
+          <a:bodyPr wrap="square" lIns="0" tIns="0" rIns="0" bIns="0" rtlCol="0" anchor="ctr"/>
+          <a:lstStyle/>
+          <a:p>
+            <a:pPr indent="0" marL="0">
+              <a:buNone/>
+            </a:pPr>
+            <a:r>
+              <a:rPr lang="en-US" sz="3400" b="1" dirty="0">
+                <a:solidFill>
+                  <a:srgbClr val="12304A"/>
+                </a:solidFill>
+                <a:latin typeface="Cambria" pitchFamily="34" charset="0"/>
+                <a:ea typeface="Cambria" pitchFamily="34" charset="-122"/>
+                <a:cs typeface="Cambria" pitchFamily="34" charset="-120"/>
+              </a:rPr>
               <a:t>Interpretasi hasil</a:t>
             </a:r>
             <a:endParaRPr lang="en-US" sz="3400" dirty="0"/>
@@ -6719,9 +7401,9 @@
 </p:sld>
 </file>
 
-<file path=ppt/slides/slide16.xml><?xml version="1.0" encoding="utf-8"?>
+<file path=ppt/slides/slide17.xml><?xml version="1.0" encoding="utf-8"?>
 <p:sld xmlns:a="http://schemas.openxmlformats.org/drawingml/2006/main" xmlns:r="http://schemas.openxmlformats.org/officeDocument/2006/relationships" xmlns:p="http://schemas.openxmlformats.org/presentationml/2006/main">
-  <p:cSld name="Slide 16">
+  <p:cSld name="Slide 17">
     <p:bg>
       <p:bgPr>
         <a:solidFill>

</xml_diff>

<commit_message>
Add dashboard screenshots for the three Power BI pages to the deck
Co-Authored-By: Claude Sonnet 5.5 <noreply@anthropic.com>
Claude-Session: https://claude.ai/code/session_017RLvirTSx84UWnroqbbqTM
</commit_message>
<xml_diff>
--- a/output/EverMart_UTS_BDASC.pptx
+++ b/output/EverMart_UTS_BDASC.pptx
@@ -22,9 +22,12 @@
     <p:sldId id="270" r:id="rId16"/>
     <p:sldId id="271" r:id="rId17"/>
     <p:sldId id="272" r:id="rId18"/>
+    <p:sldId id="273" r:id="rId19"/>
+    <p:sldId id="274" r:id="rId20"/>
+    <p:sldId id="275" r:id="rId21"/>
   </p:sldIdLst>
   <p:notesMasterIdLst>
-    <p:notesMasterId r:id="rId19"/>
+    <p:notesMasterId r:id="rId22"/>
   </p:notesMasterIdLst>
   <p:sldSz cx="12192000" cy="6858000"/>
   <p:notesSz cx="6858000" cy="12192000"/>
@@ -2105,7 +2108,7 @@
           <a:p>
             <a:r>
               <a:rPr lang="en-US" dirty="0"/>
-              <a:t>Tunjukkan langsung di Power BI: klik South America di slicer, lalu klik lagi untuk membatalkan.</a:t>
+              <a:t>Screenshot dashboard Power BI. Tunjukkan interaksi langsung di Power BI saat presentasi.</a:t>
             </a:r>
             <a:endParaRPr lang="en-US" dirty="0"/>
           </a:p>
@@ -2193,7 +2196,7 @@
           <a:p>
             <a:r>
               <a:rPr lang="en-US" dirty="0"/>
-              <a:t/>
+              <a:t>Screenshot dashboard Power BI. Tunjukkan interaksi langsung di Power BI saat presentasi.</a:t>
             </a:r>
             <a:endParaRPr lang="en-US" dirty="0"/>
           </a:p>
@@ -2281,7 +2284,7 @@
           <a:p>
             <a:r>
               <a:rPr lang="en-US" dirty="0"/>
-              <a:t/>
+              <a:t>Screenshot dashboard Power BI. Tunjukkan interaksi langsung di Power BI saat presentasi.</a:t>
             </a:r>
             <a:endParaRPr lang="en-US" dirty="0"/>
           </a:p>
@@ -2305,6 +2308,182 @@
             <a:fld id="{F7021451-1387-4CA6-816F-3879F97B5CBC}" type="slidenum">
               <a:rPr lang="en-US"/>
               <a:t>17</a:t>
+            </a:fld>
+            <a:endParaRPr lang="en-US"/>
+          </a:p>
+        </p:txBody>
+      </p:sp>
+    </p:spTree>
+    <p:extLst>
+      <p:ext uri="{BB962C8B-B14F-4D97-AF65-F5344CB8AC3E}">
+        <p14:creationId xmlns:p14="http://schemas.microsoft.com/office/powerpoint/2010/main" val="1024086991"/>
+      </p:ext>
+    </p:extLst>
+  </p:cSld>
+  <p:clrMapOvr>
+    <a:masterClrMapping/>
+  </p:clrMapOvr>
+</p:notes>
+</file>
+
+<file path=ppt/notesSlides/notesSlide18.xml><?xml version="1.0" encoding="utf-8"?>
+<p:notes xmlns:a="http://schemas.openxmlformats.org/drawingml/2006/main" xmlns:r="http://schemas.openxmlformats.org/officeDocument/2006/relationships" xmlns:p="http://schemas.openxmlformats.org/presentationml/2006/main">
+  <p:cSld>
+    <p:spTree>
+      <p:nvGrpSpPr>
+        <p:cNvPr id="1" name=""/>
+        <p:cNvGrpSpPr/>
+        <p:nvPr/>
+      </p:nvGrpSpPr>
+      <p:grpSpPr>
+        <a:xfrm>
+          <a:off x="0" y="0"/>
+          <a:ext cx="0" cy="0"/>
+          <a:chOff x="0" y="0"/>
+          <a:chExt cx="0" cy="0"/>
+        </a:xfrm>
+      </p:grpSpPr>
+      <p:sp>
+        <p:nvSpPr>
+          <p:cNvPr id="2" name="Slide Image Placeholder 1"/>
+          <p:cNvSpPr>
+            <a:spLocks noGrp="1" noRot="1" noChangeAspect="1"/>
+          </p:cNvSpPr>
+          <p:nvPr>
+            <p:ph type="sldImg"/>
+          </p:nvPr>
+        </p:nvSpPr>
+        <p:spPr/>
+      </p:sp>
+      <p:sp>
+        <p:nvSpPr>
+          <p:cNvPr id="3" name="Notes Placeholder 2"/>
+          <p:cNvSpPr>
+            <a:spLocks noGrp="1"/>
+          </p:cNvSpPr>
+          <p:nvPr>
+            <p:ph type="body" idx="1"/>
+          </p:nvPr>
+        </p:nvSpPr>
+        <p:spPr/>
+        <p:txBody>
+          <a:bodyPr/>
+          <a:lstStyle/>
+          <a:p>
+            <a:r>
+              <a:rPr lang="en-US" dirty="0"/>
+              <a:t>Tunjukkan langsung di Power BI: klik South America di slicer, lalu klik lagi untuk membatalkan.</a:t>
+            </a:r>
+            <a:endParaRPr lang="en-US" dirty="0"/>
+          </a:p>
+        </p:txBody>
+      </p:sp>
+      <p:sp>
+        <p:nvSpPr>
+          <p:cNvPr id="4" name="Slide Number Placeholder 3"/>
+          <p:cNvSpPr>
+            <a:spLocks noGrp="1"/>
+          </p:cNvSpPr>
+          <p:nvPr>
+            <p:ph type="sldNum" sz="quarter" idx="10"/>
+          </p:nvPr>
+        </p:nvSpPr>
+        <p:spPr/>
+        <p:txBody>
+          <a:bodyPr/>
+          <a:lstStyle/>
+          <a:p>
+            <a:fld id="{F7021451-1387-4CA6-816F-3879F97B5CBC}" type="slidenum">
+              <a:rPr lang="en-US"/>
+              <a:t>18</a:t>
+            </a:fld>
+            <a:endParaRPr lang="en-US"/>
+          </a:p>
+        </p:txBody>
+      </p:sp>
+    </p:spTree>
+    <p:extLst>
+      <p:ext uri="{BB962C8B-B14F-4D97-AF65-F5344CB8AC3E}">
+        <p14:creationId xmlns:p14="http://schemas.microsoft.com/office/powerpoint/2010/main" val="1024086991"/>
+      </p:ext>
+    </p:extLst>
+  </p:cSld>
+  <p:clrMapOvr>
+    <a:masterClrMapping/>
+  </p:clrMapOvr>
+</p:notes>
+</file>
+
+<file path=ppt/notesSlides/notesSlide19.xml><?xml version="1.0" encoding="utf-8"?>
+<p:notes xmlns:a="http://schemas.openxmlformats.org/drawingml/2006/main" xmlns:r="http://schemas.openxmlformats.org/officeDocument/2006/relationships" xmlns:p="http://schemas.openxmlformats.org/presentationml/2006/main">
+  <p:cSld>
+    <p:spTree>
+      <p:nvGrpSpPr>
+        <p:cNvPr id="1" name=""/>
+        <p:cNvGrpSpPr/>
+        <p:nvPr/>
+      </p:nvGrpSpPr>
+      <p:grpSpPr>
+        <a:xfrm>
+          <a:off x="0" y="0"/>
+          <a:ext cx="0" cy="0"/>
+          <a:chOff x="0" y="0"/>
+          <a:chExt cx="0" cy="0"/>
+        </a:xfrm>
+      </p:grpSpPr>
+      <p:sp>
+        <p:nvSpPr>
+          <p:cNvPr id="2" name="Slide Image Placeholder 1"/>
+          <p:cNvSpPr>
+            <a:spLocks noGrp="1" noRot="1" noChangeAspect="1"/>
+          </p:cNvSpPr>
+          <p:nvPr>
+            <p:ph type="sldImg"/>
+          </p:nvPr>
+        </p:nvSpPr>
+        <p:spPr/>
+      </p:sp>
+      <p:sp>
+        <p:nvSpPr>
+          <p:cNvPr id="3" name="Notes Placeholder 2"/>
+          <p:cNvSpPr>
+            <a:spLocks noGrp="1"/>
+          </p:cNvSpPr>
+          <p:nvPr>
+            <p:ph type="body" idx="1"/>
+          </p:nvPr>
+        </p:nvSpPr>
+        <p:spPr/>
+        <p:txBody>
+          <a:bodyPr/>
+          <a:lstStyle/>
+          <a:p>
+            <a:r>
+              <a:rPr lang="en-US" dirty="0"/>
+              <a:t/>
+            </a:r>
+            <a:endParaRPr lang="en-US" dirty="0"/>
+          </a:p>
+        </p:txBody>
+      </p:sp>
+      <p:sp>
+        <p:nvSpPr>
+          <p:cNvPr id="4" name="Slide Number Placeholder 3"/>
+          <p:cNvSpPr>
+            <a:spLocks noGrp="1"/>
+          </p:cNvSpPr>
+          <p:nvPr>
+            <p:ph type="sldNum" sz="quarter" idx="10"/>
+          </p:nvPr>
+        </p:nvSpPr>
+        <p:spPr/>
+        <p:txBody>
+          <a:bodyPr/>
+          <a:lstStyle/>
+          <a:p>
+            <a:fld id="{F7021451-1387-4CA6-816F-3879F97B5CBC}" type="slidenum">
+              <a:rPr lang="en-US"/>
+              <a:t>19</a:t>
             </a:fld>
             <a:endParaRPr lang="en-US"/>
           </a:p>
@@ -2393,6 +2572,94 @@
             <a:fld id="{F7021451-1387-4CA6-816F-3879F97B5CBC}" type="slidenum">
               <a:rPr lang="en-US"/>
               <a:t>2</a:t>
+            </a:fld>
+            <a:endParaRPr lang="en-US"/>
+          </a:p>
+        </p:txBody>
+      </p:sp>
+    </p:spTree>
+    <p:extLst>
+      <p:ext uri="{BB962C8B-B14F-4D97-AF65-F5344CB8AC3E}">
+        <p14:creationId xmlns:p14="http://schemas.microsoft.com/office/powerpoint/2010/main" val="1024086991"/>
+      </p:ext>
+    </p:extLst>
+  </p:cSld>
+  <p:clrMapOvr>
+    <a:masterClrMapping/>
+  </p:clrMapOvr>
+</p:notes>
+</file>
+
+<file path=ppt/notesSlides/notesSlide20.xml><?xml version="1.0" encoding="utf-8"?>
+<p:notes xmlns:a="http://schemas.openxmlformats.org/drawingml/2006/main" xmlns:r="http://schemas.openxmlformats.org/officeDocument/2006/relationships" xmlns:p="http://schemas.openxmlformats.org/presentationml/2006/main">
+  <p:cSld>
+    <p:spTree>
+      <p:nvGrpSpPr>
+        <p:cNvPr id="1" name=""/>
+        <p:cNvGrpSpPr/>
+        <p:nvPr/>
+      </p:nvGrpSpPr>
+      <p:grpSpPr>
+        <a:xfrm>
+          <a:off x="0" y="0"/>
+          <a:ext cx="0" cy="0"/>
+          <a:chOff x="0" y="0"/>
+          <a:chExt cx="0" cy="0"/>
+        </a:xfrm>
+      </p:grpSpPr>
+      <p:sp>
+        <p:nvSpPr>
+          <p:cNvPr id="2" name="Slide Image Placeholder 1"/>
+          <p:cNvSpPr>
+            <a:spLocks noGrp="1" noRot="1" noChangeAspect="1"/>
+          </p:cNvSpPr>
+          <p:nvPr>
+            <p:ph type="sldImg"/>
+          </p:nvPr>
+        </p:nvSpPr>
+        <p:spPr/>
+      </p:sp>
+      <p:sp>
+        <p:nvSpPr>
+          <p:cNvPr id="3" name="Notes Placeholder 2"/>
+          <p:cNvSpPr>
+            <a:spLocks noGrp="1"/>
+          </p:cNvSpPr>
+          <p:nvPr>
+            <p:ph type="body" idx="1"/>
+          </p:nvPr>
+        </p:nvSpPr>
+        <p:spPr/>
+        <p:txBody>
+          <a:bodyPr/>
+          <a:lstStyle/>
+          <a:p>
+            <a:r>
+              <a:rPr lang="en-US" dirty="0"/>
+              <a:t/>
+            </a:r>
+            <a:endParaRPr lang="en-US" dirty="0"/>
+          </a:p>
+        </p:txBody>
+      </p:sp>
+      <p:sp>
+        <p:nvSpPr>
+          <p:cNvPr id="4" name="Slide Number Placeholder 3"/>
+          <p:cNvSpPr>
+            <a:spLocks noGrp="1"/>
+          </p:cNvSpPr>
+          <p:nvPr>
+            <p:ph type="sldNum" sz="quarter" idx="10"/>
+          </p:nvPr>
+        </p:nvSpPr>
+        <p:spPr/>
+        <p:txBody>
+          <a:bodyPr/>
+          <a:lstStyle/>
+          <a:p>
+            <a:fld id="{F7021451-1387-4CA6-816F-3879F97B5CBC}" type="slidenum">
+              <a:rPr lang="en-US"/>
+              <a:t>20</a:t>
             </a:fld>
             <a:endParaRPr lang="en-US"/>
           </a:p>
@@ -6584,338 +6851,49 @@
                 <a:ea typeface="Cambria" pitchFamily="34" charset="-122"/>
                 <a:cs typeface="Cambria" pitchFamily="34" charset="-120"/>
               </a:rPr>
-              <a:t>Contoh filter interaktif: South America</a:t>
+              <a:t>Halaman 1: Revenue Report</a:t>
             </a:r>
             <a:endParaRPr lang="en-US" sz="3400" dirty="0"/>
           </a:p>
         </p:txBody>
       </p:sp>
-      <p:sp>
-        <p:nvSpPr>
-          <p:cNvPr id="3" name="Text 1"/>
-          <p:cNvSpPr txBox="1"/>
+      <p:pic>
+        <p:nvPicPr>
+          <p:cNvPr id="3" name="Image 0" descr="/tmp/claude-0/-home-user-EXACOUNT/b3a0efd5-5ef2-5930-a9ef-1d7b86874e77/scratchpad/shot_rev.png">    </p:cNvPr>
+          <p:cNvPicPr>
+            <a:picLocks noChangeAspect="1"/>
+          </p:cNvPicPr>
           <p:nvPr/>
-        </p:nvSpPr>
+        </p:nvPicPr>
+        <p:blipFill>
+          <a:blip r:embed="rId1"/>
+          <a:srcRect l="0" r="0" t="0" b="0"/>
+          <a:stretch/>
+        </p:blipFill>
         <p:spPr>
           <a:xfrm>
-            <a:off x="548640" y="1554480"/>
-            <a:ext cx="2651760" cy="822960"/>
+            <a:off x="548640" y="1234440"/>
+            <a:ext cx="8503920" cy="4754880"/>
           </a:xfrm>
           <a:prstGeom prst="rect">
             <a:avLst/>
           </a:prstGeom>
-          <a:noFill/>
-          <a:ln/>
         </p:spPr>
-        <p:txBody>
-          <a:bodyPr wrap="square" lIns="0" tIns="0" rIns="0" bIns="0" rtlCol="0" anchor="ctr"/>
-          <a:lstStyle/>
-          <a:p>
-            <a:pPr indent="0" marL="0">
-              <a:buNone/>
-            </a:pPr>
-            <a:r>
-              <a:rPr lang="en-US" sz="4800" b="1" dirty="0">
-                <a:solidFill>
-                  <a:srgbClr val="1B7F8C"/>
-                </a:solidFill>
-                <a:latin typeface="Cambria" pitchFamily="34" charset="0"/>
-                <a:ea typeface="Cambria" pitchFamily="34" charset="-122"/>
-                <a:cs typeface="Cambria" pitchFamily="34" charset="-120"/>
-              </a:rPr>
-              <a:t>219.353</a:t>
-            </a:r>
-            <a:endParaRPr lang="en-US" sz="4800" dirty="0"/>
-          </a:p>
-        </p:txBody>
-      </p:sp>
-      <p:sp>
-        <p:nvSpPr>
-          <p:cNvPr id="4" name="Text 2"/>
-          <p:cNvSpPr txBox="1"/>
+      </p:pic>
+      <p:sp>
+        <p:nvSpPr>
+          <p:cNvPr id="4" name="Shape 1"/>
+          <p:cNvSpPr/>
           <p:nvPr/>
         </p:nvSpPr>
         <p:spPr>
           <a:xfrm>
-            <a:off x="548640" y="2377440"/>
-            <a:ext cx="2651760" cy="365760"/>
-          </a:xfrm>
-          <a:prstGeom prst="rect">
-            <a:avLst/>
-          </a:prstGeom>
-          <a:noFill/>
-          <a:ln/>
-        </p:spPr>
-        <p:txBody>
-          <a:bodyPr wrap="square" lIns="0" tIns="0" rIns="0" bIns="0" rtlCol="0" anchor="ctr"/>
-          <a:lstStyle/>
-          <a:p>
-            <a:pPr indent="0" marL="0">
-              <a:buNone/>
-            </a:pPr>
-            <a:r>
-              <a:rPr lang="en-US" sz="1400" dirty="0">
-                <a:solidFill>
-                  <a:srgbClr val="5B6B79"/>
-                </a:solidFill>
-                <a:latin typeface="Calibri" pitchFamily="34" charset="0"/>
-                <a:ea typeface="Calibri" pitchFamily="34" charset="-122"/>
-                <a:cs typeface="Calibri" pitchFamily="34" charset="-120"/>
-              </a:rPr>
-              <a:t>Total Revenue</a:t>
-            </a:r>
-            <a:endParaRPr lang="en-US" sz="1400" dirty="0"/>
-          </a:p>
-        </p:txBody>
-      </p:sp>
-      <p:sp>
-        <p:nvSpPr>
-          <p:cNvPr id="5" name="Text 3"/>
-          <p:cNvSpPr txBox="1"/>
-          <p:nvPr/>
-        </p:nvSpPr>
-        <p:spPr>
-          <a:xfrm>
-            <a:off x="3383280" y="1554480"/>
-            <a:ext cx="2651760" cy="822960"/>
-          </a:xfrm>
-          <a:prstGeom prst="rect">
-            <a:avLst/>
-          </a:prstGeom>
-          <a:noFill/>
-          <a:ln/>
-        </p:spPr>
-        <p:txBody>
-          <a:bodyPr wrap="square" lIns="0" tIns="0" rIns="0" bIns="0" rtlCol="0" anchor="ctr"/>
-          <a:lstStyle/>
-          <a:p>
-            <a:pPr indent="0" marL="0">
-              <a:buNone/>
-            </a:pPr>
-            <a:r>
-              <a:rPr lang="en-US" sz="4800" b="1" dirty="0">
-                <a:solidFill>
-                  <a:srgbClr val="F28C28"/>
-                </a:solidFill>
-                <a:latin typeface="Cambria" pitchFamily="34" charset="0"/>
-                <a:ea typeface="Cambria" pitchFamily="34" charset="-122"/>
-                <a:cs typeface="Cambria" pitchFamily="34" charset="-120"/>
-              </a:rPr>
-              <a:t>304</a:t>
-            </a:r>
-            <a:endParaRPr lang="en-US" sz="4800" dirty="0"/>
-          </a:p>
-        </p:txBody>
-      </p:sp>
-      <p:sp>
-        <p:nvSpPr>
-          <p:cNvPr id="6" name="Text 4"/>
-          <p:cNvSpPr txBox="1"/>
-          <p:nvPr/>
-        </p:nvSpPr>
-        <p:spPr>
-          <a:xfrm>
-            <a:off x="3383280" y="2377440"/>
-            <a:ext cx="2651760" cy="365760"/>
-          </a:xfrm>
-          <a:prstGeom prst="rect">
-            <a:avLst/>
-          </a:prstGeom>
-          <a:noFill/>
-          <a:ln/>
-        </p:spPr>
-        <p:txBody>
-          <a:bodyPr wrap="square" lIns="0" tIns="0" rIns="0" bIns="0" rtlCol="0" anchor="ctr"/>
-          <a:lstStyle/>
-          <a:p>
-            <a:pPr indent="0" marL="0">
-              <a:buNone/>
-            </a:pPr>
-            <a:r>
-              <a:rPr lang="en-US" sz="1400" dirty="0">
-                <a:solidFill>
-                  <a:srgbClr val="5B6B79"/>
-                </a:solidFill>
-                <a:latin typeface="Calibri" pitchFamily="34" charset="0"/>
-                <a:ea typeface="Calibri" pitchFamily="34" charset="-122"/>
-                <a:cs typeface="Calibri" pitchFamily="34" charset="-120"/>
-              </a:rPr>
-              <a:t>Total Transactions</a:t>
-            </a:r>
-            <a:endParaRPr lang="en-US" sz="1400" dirty="0"/>
-          </a:p>
-        </p:txBody>
-      </p:sp>
-      <p:sp>
-        <p:nvSpPr>
-          <p:cNvPr id="7" name="Text 5"/>
-          <p:cNvSpPr txBox="1"/>
-          <p:nvPr/>
-        </p:nvSpPr>
-        <p:spPr>
-          <a:xfrm>
-            <a:off x="6217920" y="1554480"/>
-            <a:ext cx="2651760" cy="822960"/>
-          </a:xfrm>
-          <a:prstGeom prst="rect">
-            <a:avLst/>
-          </a:prstGeom>
-          <a:noFill/>
-          <a:ln/>
-        </p:spPr>
-        <p:txBody>
-          <a:bodyPr wrap="square" lIns="0" tIns="0" rIns="0" bIns="0" rtlCol="0" anchor="ctr"/>
-          <a:lstStyle/>
-          <a:p>
-            <a:pPr indent="0" marL="0">
-              <a:buNone/>
-            </a:pPr>
-            <a:r>
-              <a:rPr lang="en-US" sz="4800" b="1" dirty="0">
-                <a:solidFill>
-                  <a:srgbClr val="12304A"/>
-                </a:solidFill>
-                <a:latin typeface="Cambria" pitchFamily="34" charset="0"/>
-                <a:ea typeface="Cambria" pitchFamily="34" charset="-122"/>
-                <a:cs typeface="Cambria" pitchFamily="34" charset="-120"/>
-              </a:rPr>
-              <a:t>59</a:t>
-            </a:r>
-            <a:endParaRPr lang="en-US" sz="4800" dirty="0"/>
-          </a:p>
-        </p:txBody>
-      </p:sp>
-      <p:sp>
-        <p:nvSpPr>
-          <p:cNvPr id="8" name="Text 6"/>
-          <p:cNvSpPr txBox="1"/>
-          <p:nvPr/>
-        </p:nvSpPr>
-        <p:spPr>
-          <a:xfrm>
-            <a:off x="6217920" y="2377440"/>
-            <a:ext cx="2651760" cy="365760"/>
-          </a:xfrm>
-          <a:prstGeom prst="rect">
-            <a:avLst/>
-          </a:prstGeom>
-          <a:noFill/>
-          <a:ln/>
-        </p:spPr>
-        <p:txBody>
-          <a:bodyPr wrap="square" lIns="0" tIns="0" rIns="0" bIns="0" rtlCol="0" anchor="ctr"/>
-          <a:lstStyle/>
-          <a:p>
-            <a:pPr indent="0" marL="0">
-              <a:buNone/>
-            </a:pPr>
-            <a:r>
-              <a:rPr lang="en-US" sz="1400" dirty="0">
-                <a:solidFill>
-                  <a:srgbClr val="5B6B79"/>
-                </a:solidFill>
-                <a:latin typeface="Calibri" pitchFamily="34" charset="0"/>
-                <a:ea typeface="Calibri" pitchFamily="34" charset="-122"/>
-                <a:cs typeface="Calibri" pitchFamily="34" charset="-120"/>
-              </a:rPr>
-              <a:t>Total Unique Customers</a:t>
-            </a:r>
-            <a:endParaRPr lang="en-US" sz="1400" dirty="0"/>
-          </a:p>
-        </p:txBody>
-      </p:sp>
-      <p:sp>
-        <p:nvSpPr>
-          <p:cNvPr id="9" name="Text 7"/>
-          <p:cNvSpPr txBox="1"/>
-          <p:nvPr/>
-        </p:nvSpPr>
-        <p:spPr>
-          <a:xfrm>
-            <a:off x="9052560" y="1554480"/>
-            <a:ext cx="2651760" cy="822960"/>
-          </a:xfrm>
-          <a:prstGeom prst="rect">
-            <a:avLst/>
-          </a:prstGeom>
-          <a:noFill/>
-          <a:ln/>
-        </p:spPr>
-        <p:txBody>
-          <a:bodyPr wrap="square" lIns="0" tIns="0" rIns="0" bIns="0" rtlCol="0" anchor="ctr"/>
-          <a:lstStyle/>
-          <a:p>
-            <a:pPr indent="0" marL="0">
-              <a:buNone/>
-            </a:pPr>
-            <a:r>
-              <a:rPr lang="en-US" sz="4800" b="1" dirty="0">
-                <a:solidFill>
-                  <a:srgbClr val="1B7F8C"/>
-                </a:solidFill>
-                <a:latin typeface="Cambria" pitchFamily="34" charset="0"/>
-                <a:ea typeface="Cambria" pitchFamily="34" charset="-122"/>
-                <a:cs typeface="Cambria" pitchFamily="34" charset="-120"/>
-              </a:rPr>
-              <a:t>721,55</a:t>
-            </a:r>
-            <a:endParaRPr lang="en-US" sz="4800" dirty="0"/>
-          </a:p>
-        </p:txBody>
-      </p:sp>
-      <p:sp>
-        <p:nvSpPr>
-          <p:cNvPr id="10" name="Text 8"/>
-          <p:cNvSpPr txBox="1"/>
-          <p:nvPr/>
-        </p:nvSpPr>
-        <p:spPr>
-          <a:xfrm>
-            <a:off x="9052560" y="2377440"/>
-            <a:ext cx="2651760" cy="365760"/>
-          </a:xfrm>
-          <a:prstGeom prst="rect">
-            <a:avLst/>
-          </a:prstGeom>
-          <a:noFill/>
-          <a:ln/>
-        </p:spPr>
-        <p:txBody>
-          <a:bodyPr wrap="square" lIns="0" tIns="0" rIns="0" bIns="0" rtlCol="0" anchor="ctr"/>
-          <a:lstStyle/>
-          <a:p>
-            <a:pPr indent="0" marL="0">
-              <a:buNone/>
-            </a:pPr>
-            <a:r>
-              <a:rPr lang="en-US" sz="1400" dirty="0">
-                <a:solidFill>
-                  <a:srgbClr val="5B6B79"/>
-                </a:solidFill>
-                <a:latin typeface="Calibri" pitchFamily="34" charset="0"/>
-                <a:ea typeface="Calibri" pitchFamily="34" charset="-122"/>
-                <a:cs typeface="Calibri" pitchFamily="34" charset="-120"/>
-              </a:rPr>
-              <a:t>Avg Order Value</a:t>
-            </a:r>
-            <a:endParaRPr lang="en-US" sz="1400" dirty="0"/>
-          </a:p>
-        </p:txBody>
-      </p:sp>
-      <p:sp>
-        <p:nvSpPr>
-          <p:cNvPr id="11" name="Shape 9"/>
-          <p:cNvSpPr/>
-          <p:nvPr/>
-        </p:nvSpPr>
-        <p:spPr>
-          <a:xfrm>
-            <a:off x="548640" y="3383280"/>
-            <a:ext cx="11064240" cy="2377440"/>
+            <a:off x="9235440" y="1463040"/>
+            <a:ext cx="2468880" cy="4023360"/>
           </a:xfrm>
           <a:prstGeom prst="roundRect">
             <a:avLst>
-              <a:gd name="adj" fmla="val 4615"/>
+              <a:gd name="adj" fmla="val 4444"/>
             </a:avLst>
           </a:prstGeom>
           <a:solidFill>
@@ -6931,14 +6909,14 @@
       </p:sp>
       <p:sp>
         <p:nvSpPr>
-          <p:cNvPr id="12" name="Text 10"/>
+          <p:cNvPr id="5" name="Text 2"/>
           <p:cNvSpPr txBox="1"/>
           <p:nvPr/>
         </p:nvSpPr>
         <p:spPr>
           <a:xfrm>
-            <a:off x="777240" y="3566160"/>
-            <a:ext cx="10607040" cy="457200"/>
+            <a:off x="9464040" y="1645920"/>
+            <a:ext cx="2011680" cy="457200"/>
           </a:xfrm>
           <a:prstGeom prst="rect">
             <a:avLst/>
@@ -6962,7 +6940,7 @@
                 <a:ea typeface="Cambria" pitchFamily="34" charset="-122"/>
                 <a:cs typeface="Cambria" pitchFamily="34" charset="-120"/>
               </a:rPr>
-              <a:t>Makna</a:t>
+              <a:t>Isi halaman</a:t>
             </a:r>
             <a:endParaRPr lang="en-US" sz="2000" dirty="0"/>
           </a:p>
@@ -6970,14 +6948,14 @@
       </p:sp>
       <p:sp>
         <p:nvSpPr>
-          <p:cNvPr id="13" name="Text 11"/>
+          <p:cNvPr id="6" name="Text 3"/>
           <p:cNvSpPr txBox="1"/>
           <p:nvPr/>
         </p:nvSpPr>
         <p:spPr>
           <a:xfrm>
-            <a:off x="777240" y="4069080"/>
-            <a:ext cx="10607040" cy="1508760"/>
+            <a:off x="9464040" y="2148840"/>
+            <a:ext cx="2011680" cy="3154680"/>
           </a:xfrm>
           <a:prstGeom prst="rect">
             <a:avLst/>
@@ -7001,7 +6979,7 @@
                 <a:ea typeface="Calibri" pitchFamily="34" charset="-122"/>
                 <a:cs typeface="Calibri" pitchFamily="34" charset="-120"/>
               </a:rPr>
-              <a:t>Saat slicer Region dipilih South America, seluruh measure DAX dihitung ulang hanya untuk wilayah itu. Wilayah ini menyumbang 31,8% revenue dengan 59 pelanggan aktif dan nilai rata-rata per transaksi 721,55, lebih tinggi dari rata-rata keseluruhan 690,00.</a:t>
+              <a:t>Tabel ringkasan, tren revenue per bulan, penjualan per produk, dan per kategori.</a:t>
             </a:r>
             <a:endParaRPr lang="en-US" sz="1600" dirty="0"/>
           </a:p>
@@ -7072,6 +7050,892 @@
                 <a:ea typeface="Cambria" pitchFamily="34" charset="-122"/>
                 <a:cs typeface="Cambria" pitchFamily="34" charset="-120"/>
               </a:rPr>
+              <a:t>Halaman 2: Customer Behavior</a:t>
+            </a:r>
+            <a:endParaRPr lang="en-US" sz="3400" dirty="0"/>
+          </a:p>
+        </p:txBody>
+      </p:sp>
+      <p:pic>
+        <p:nvPicPr>
+          <p:cNvPr id="3" name="Image 0" descr="/tmp/claude-0/-home-user-EXACOUNT/b3a0efd5-5ef2-5930-a9ef-1d7b86874e77/scratchpad/shot_beh.png">    </p:cNvPr>
+          <p:cNvPicPr>
+            <a:picLocks noChangeAspect="1"/>
+          </p:cNvPicPr>
+          <p:nvPr/>
+        </p:nvPicPr>
+        <p:blipFill>
+          <a:blip r:embed="rId1"/>
+          <a:srcRect l="0" r="0" t="0" b="0"/>
+          <a:stretch/>
+        </p:blipFill>
+        <p:spPr>
+          <a:xfrm>
+            <a:off x="548640" y="1234440"/>
+            <a:ext cx="8503920" cy="4754880"/>
+          </a:xfrm>
+          <a:prstGeom prst="rect">
+            <a:avLst/>
+          </a:prstGeom>
+        </p:spPr>
+      </p:pic>
+      <p:sp>
+        <p:nvSpPr>
+          <p:cNvPr id="4" name="Shape 1"/>
+          <p:cNvSpPr/>
+          <p:nvPr/>
+        </p:nvSpPr>
+        <p:spPr>
+          <a:xfrm>
+            <a:off x="9235440" y="1463040"/>
+            <a:ext cx="2468880" cy="4023360"/>
+          </a:xfrm>
+          <a:prstGeom prst="roundRect">
+            <a:avLst>
+              <a:gd name="adj" fmla="val 4444"/>
+            </a:avLst>
+          </a:prstGeom>
+          <a:solidFill>
+            <a:srgbClr val="F3F6F8"/>
+          </a:solidFill>
+          <a:ln w="12700">
+            <a:solidFill>
+              <a:srgbClr val="F3F6F8"/>
+            </a:solidFill>
+            <a:prstDash val="solid"/>
+          </a:ln>
+        </p:spPr>
+      </p:sp>
+      <p:sp>
+        <p:nvSpPr>
+          <p:cNvPr id="5" name="Text 2"/>
+          <p:cNvSpPr txBox="1"/>
+          <p:nvPr/>
+        </p:nvSpPr>
+        <p:spPr>
+          <a:xfrm>
+            <a:off x="9464040" y="1645920"/>
+            <a:ext cx="2011680" cy="457200"/>
+          </a:xfrm>
+          <a:prstGeom prst="rect">
+            <a:avLst/>
+          </a:prstGeom>
+          <a:noFill/>
+          <a:ln/>
+        </p:spPr>
+        <p:txBody>
+          <a:bodyPr wrap="square" lIns="0" tIns="0" rIns="0" bIns="0" rtlCol="0" anchor="ctr"/>
+          <a:lstStyle/>
+          <a:p>
+            <a:pPr indent="0" marL="0">
+              <a:buNone/>
+            </a:pPr>
+            <a:r>
+              <a:rPr lang="en-US" sz="2000" b="1" dirty="0">
+                <a:solidFill>
+                  <a:srgbClr val="12304A"/>
+                </a:solidFill>
+                <a:latin typeface="Cambria" pitchFamily="34" charset="0"/>
+                <a:ea typeface="Cambria" pitchFamily="34" charset="-122"/>
+                <a:cs typeface="Cambria" pitchFamily="34" charset="-120"/>
+              </a:rPr>
+              <a:t>Isi halaman</a:t>
+            </a:r>
+            <a:endParaRPr lang="en-US" sz="2000" dirty="0"/>
+          </a:p>
+        </p:txBody>
+      </p:sp>
+      <p:sp>
+        <p:nvSpPr>
+          <p:cNvPr id="6" name="Text 3"/>
+          <p:cNvSpPr txBox="1"/>
+          <p:nvPr/>
+        </p:nvSpPr>
+        <p:spPr>
+          <a:xfrm>
+            <a:off x="9464040" y="2148840"/>
+            <a:ext cx="2011680" cy="3154680"/>
+          </a:xfrm>
+          <a:prstGeom prst="rect">
+            <a:avLst/>
+          </a:prstGeom>
+          <a:noFill/>
+          <a:ln/>
+        </p:spPr>
+        <p:txBody>
+          <a:bodyPr wrap="square" lIns="0" tIns="0" rIns="0" bIns="0" rtlCol="0" anchor="t"/>
+          <a:lstStyle/>
+          <a:p>
+            <a:pPr indent="0" marL="0">
+              <a:buNone/>
+            </a:pPr>
+            <a:r>
+              <a:rPr lang="en-US" sz="1600" dirty="0">
+                <a:solidFill>
+                  <a:srgbClr val="1E2A35"/>
+                </a:solidFill>
+                <a:latin typeface="Calibri" pitchFamily="34" charset="0"/>
+                <a:ea typeface="Calibri" pitchFamily="34" charset="-122"/>
+                <a:cs typeface="Calibri" pitchFamily="34" charset="-120"/>
+              </a:rPr>
+              <a:t>Slicer Region dan tanggal (tahun, kuartal, bulan), serta revenue per kategori.</a:t>
+            </a:r>
+            <a:endParaRPr lang="en-US" sz="1600" dirty="0"/>
+          </a:p>
+        </p:txBody>
+      </p:sp>
+    </p:spTree>
+  </p:cSld>
+  <p:clrMapOvr>
+    <a:masterClrMapping/>
+  </p:clrMapOvr>
+</p:sld>
+</file>
+
+<file path=ppt/slides/slide17.xml><?xml version="1.0" encoding="utf-8"?>
+<p:sld xmlns:a="http://schemas.openxmlformats.org/drawingml/2006/main" xmlns:r="http://schemas.openxmlformats.org/officeDocument/2006/relationships" xmlns:p="http://schemas.openxmlformats.org/presentationml/2006/main">
+  <p:cSld name="Slide 17">
+    <p:bg>
+      <p:bgPr>
+        <a:solidFill>
+          <a:srgbClr val="FFFFFF"/>
+        </a:solidFill>
+      </p:bgPr>
+    </p:bg>
+    <p:spTree>
+      <p:nvGrpSpPr>
+        <p:cNvPr id="1" name=""/>
+        <p:cNvGrpSpPr/>
+        <p:nvPr/>
+      </p:nvGrpSpPr>
+      <p:grpSpPr>
+        <a:xfrm>
+          <a:off x="0" y="0"/>
+          <a:ext cx="0" cy="0"/>
+          <a:chOff x="0" y="0"/>
+          <a:chExt cx="0" cy="0"/>
+        </a:xfrm>
+      </p:grpSpPr>
+      <p:sp>
+        <p:nvSpPr>
+          <p:cNvPr id="2" name="Text 0"/>
+          <p:cNvSpPr txBox="1"/>
+          <p:nvPr/>
+        </p:nvSpPr>
+        <p:spPr>
+          <a:xfrm>
+            <a:off x="548640" y="365760"/>
+            <a:ext cx="11064240" cy="731520"/>
+          </a:xfrm>
+          <a:prstGeom prst="rect">
+            <a:avLst/>
+          </a:prstGeom>
+          <a:noFill/>
+          <a:ln/>
+        </p:spPr>
+        <p:txBody>
+          <a:bodyPr wrap="square" lIns="0" tIns="0" rIns="0" bIns="0" rtlCol="0" anchor="ctr"/>
+          <a:lstStyle/>
+          <a:p>
+            <a:pPr indent="0" marL="0">
+              <a:buNone/>
+            </a:pPr>
+            <a:r>
+              <a:rPr lang="en-US" sz="3400" b="1" dirty="0">
+                <a:solidFill>
+                  <a:srgbClr val="12304A"/>
+                </a:solidFill>
+                <a:latin typeface="Cambria" pitchFamily="34" charset="0"/>
+                <a:ea typeface="Cambria" pitchFamily="34" charset="-122"/>
+                <a:cs typeface="Cambria" pitchFamily="34" charset="-120"/>
+              </a:rPr>
+              <a:t>Halaman 3: KPI Summary</a:t>
+            </a:r>
+            <a:endParaRPr lang="en-US" sz="3400" dirty="0"/>
+          </a:p>
+        </p:txBody>
+      </p:sp>
+      <p:pic>
+        <p:nvPicPr>
+          <p:cNvPr id="3" name="Image 0" descr="/tmp/claude-0/-home-user-EXACOUNT/b3a0efd5-5ef2-5930-a9ef-1d7b86874e77/scratchpad/shot_kpi.png">    </p:cNvPr>
+          <p:cNvPicPr>
+            <a:picLocks noChangeAspect="1"/>
+          </p:cNvPicPr>
+          <p:nvPr/>
+        </p:nvPicPr>
+        <p:blipFill>
+          <a:blip r:embed="rId1"/>
+          <a:srcRect l="0" r="0" t="0" b="0"/>
+          <a:stretch/>
+        </p:blipFill>
+        <p:spPr>
+          <a:xfrm>
+            <a:off x="548640" y="1234440"/>
+            <a:ext cx="8503920" cy="4754880"/>
+          </a:xfrm>
+          <a:prstGeom prst="rect">
+            <a:avLst/>
+          </a:prstGeom>
+        </p:spPr>
+      </p:pic>
+      <p:sp>
+        <p:nvSpPr>
+          <p:cNvPr id="4" name="Shape 1"/>
+          <p:cNvSpPr/>
+          <p:nvPr/>
+        </p:nvSpPr>
+        <p:spPr>
+          <a:xfrm>
+            <a:off x="9235440" y="1463040"/>
+            <a:ext cx="2468880" cy="4023360"/>
+          </a:xfrm>
+          <a:prstGeom prst="roundRect">
+            <a:avLst>
+              <a:gd name="adj" fmla="val 4444"/>
+            </a:avLst>
+          </a:prstGeom>
+          <a:solidFill>
+            <a:srgbClr val="F3F6F8"/>
+          </a:solidFill>
+          <a:ln w="12700">
+            <a:solidFill>
+              <a:srgbClr val="F3F6F8"/>
+            </a:solidFill>
+            <a:prstDash val="solid"/>
+          </a:ln>
+        </p:spPr>
+      </p:sp>
+      <p:sp>
+        <p:nvSpPr>
+          <p:cNvPr id="5" name="Text 2"/>
+          <p:cNvSpPr txBox="1"/>
+          <p:nvPr/>
+        </p:nvSpPr>
+        <p:spPr>
+          <a:xfrm>
+            <a:off x="9464040" y="1645920"/>
+            <a:ext cx="2011680" cy="457200"/>
+          </a:xfrm>
+          <a:prstGeom prst="rect">
+            <a:avLst/>
+          </a:prstGeom>
+          <a:noFill/>
+          <a:ln/>
+        </p:spPr>
+        <p:txBody>
+          <a:bodyPr wrap="square" lIns="0" tIns="0" rIns="0" bIns="0" rtlCol="0" anchor="ctr"/>
+          <a:lstStyle/>
+          <a:p>
+            <a:pPr indent="0" marL="0">
+              <a:buNone/>
+            </a:pPr>
+            <a:r>
+              <a:rPr lang="en-US" sz="2000" b="1" dirty="0">
+                <a:solidFill>
+                  <a:srgbClr val="12304A"/>
+                </a:solidFill>
+                <a:latin typeface="Cambria" pitchFamily="34" charset="0"/>
+                <a:ea typeface="Cambria" pitchFamily="34" charset="-122"/>
+                <a:cs typeface="Cambria" pitchFamily="34" charset="-120"/>
+              </a:rPr>
+              <a:t>Isi halaman</a:t>
+            </a:r>
+            <a:endParaRPr lang="en-US" sz="2000" dirty="0"/>
+          </a:p>
+        </p:txBody>
+      </p:sp>
+      <p:sp>
+        <p:nvSpPr>
+          <p:cNvPr id="6" name="Text 3"/>
+          <p:cNvSpPr txBox="1"/>
+          <p:nvPr/>
+        </p:nvSpPr>
+        <p:spPr>
+          <a:xfrm>
+            <a:off x="9464040" y="2148840"/>
+            <a:ext cx="2011680" cy="3154680"/>
+          </a:xfrm>
+          <a:prstGeom prst="rect">
+            <a:avLst/>
+          </a:prstGeom>
+          <a:noFill/>
+          <a:ln/>
+        </p:spPr>
+        <p:txBody>
+          <a:bodyPr wrap="square" lIns="0" tIns="0" rIns="0" bIns="0" rtlCol="0" anchor="t"/>
+          <a:lstStyle/>
+          <a:p>
+            <a:pPr indent="0" marL="0">
+              <a:buNone/>
+            </a:pPr>
+            <a:r>
+              <a:rPr lang="en-US" sz="1600" dirty="0">
+                <a:solidFill>
+                  <a:srgbClr val="1E2A35"/>
+                </a:solidFill>
+                <a:latin typeface="Calibri" pitchFamily="34" charset="0"/>
+                <a:ea typeface="Calibri" pitchFamily="34" charset="-122"/>
+                <a:cs typeface="Calibri" pitchFamily="34" charset="-120"/>
+              </a:rPr>
+              <a:t>4 kartu KPI, slicer, tabel per wilayah, dan dua grafik. Semua memakai measure DAX.</a:t>
+            </a:r>
+            <a:endParaRPr lang="en-US" sz="1600" dirty="0"/>
+          </a:p>
+        </p:txBody>
+      </p:sp>
+    </p:spTree>
+  </p:cSld>
+  <p:clrMapOvr>
+    <a:masterClrMapping/>
+  </p:clrMapOvr>
+</p:sld>
+</file>
+
+<file path=ppt/slides/slide18.xml><?xml version="1.0" encoding="utf-8"?>
+<p:sld xmlns:a="http://schemas.openxmlformats.org/drawingml/2006/main" xmlns:r="http://schemas.openxmlformats.org/officeDocument/2006/relationships" xmlns:p="http://schemas.openxmlformats.org/presentationml/2006/main">
+  <p:cSld name="Slide 18">
+    <p:bg>
+      <p:bgPr>
+        <a:solidFill>
+          <a:srgbClr val="FFFFFF"/>
+        </a:solidFill>
+      </p:bgPr>
+    </p:bg>
+    <p:spTree>
+      <p:nvGrpSpPr>
+        <p:cNvPr id="1" name=""/>
+        <p:cNvGrpSpPr/>
+        <p:nvPr/>
+      </p:nvGrpSpPr>
+      <p:grpSpPr>
+        <a:xfrm>
+          <a:off x="0" y="0"/>
+          <a:ext cx="0" cy="0"/>
+          <a:chOff x="0" y="0"/>
+          <a:chExt cx="0" cy="0"/>
+        </a:xfrm>
+      </p:grpSpPr>
+      <p:sp>
+        <p:nvSpPr>
+          <p:cNvPr id="2" name="Text 0"/>
+          <p:cNvSpPr txBox="1"/>
+          <p:nvPr/>
+        </p:nvSpPr>
+        <p:spPr>
+          <a:xfrm>
+            <a:off x="548640" y="365760"/>
+            <a:ext cx="11064240" cy="731520"/>
+          </a:xfrm>
+          <a:prstGeom prst="rect">
+            <a:avLst/>
+          </a:prstGeom>
+          <a:noFill/>
+          <a:ln/>
+        </p:spPr>
+        <p:txBody>
+          <a:bodyPr wrap="square" lIns="0" tIns="0" rIns="0" bIns="0" rtlCol="0" anchor="ctr"/>
+          <a:lstStyle/>
+          <a:p>
+            <a:pPr indent="0" marL="0">
+              <a:buNone/>
+            </a:pPr>
+            <a:r>
+              <a:rPr lang="en-US" sz="3400" b="1" dirty="0">
+                <a:solidFill>
+                  <a:srgbClr val="12304A"/>
+                </a:solidFill>
+                <a:latin typeface="Cambria" pitchFamily="34" charset="0"/>
+                <a:ea typeface="Cambria" pitchFamily="34" charset="-122"/>
+                <a:cs typeface="Cambria" pitchFamily="34" charset="-120"/>
+              </a:rPr>
+              <a:t>Contoh filter interaktif: South America</a:t>
+            </a:r>
+            <a:endParaRPr lang="en-US" sz="3400" dirty="0"/>
+          </a:p>
+        </p:txBody>
+      </p:sp>
+      <p:sp>
+        <p:nvSpPr>
+          <p:cNvPr id="3" name="Text 1"/>
+          <p:cNvSpPr txBox="1"/>
+          <p:nvPr/>
+        </p:nvSpPr>
+        <p:spPr>
+          <a:xfrm>
+            <a:off x="548640" y="1554480"/>
+            <a:ext cx="2651760" cy="822960"/>
+          </a:xfrm>
+          <a:prstGeom prst="rect">
+            <a:avLst/>
+          </a:prstGeom>
+          <a:noFill/>
+          <a:ln/>
+        </p:spPr>
+        <p:txBody>
+          <a:bodyPr wrap="square" lIns="0" tIns="0" rIns="0" bIns="0" rtlCol="0" anchor="ctr"/>
+          <a:lstStyle/>
+          <a:p>
+            <a:pPr indent="0" marL="0">
+              <a:buNone/>
+            </a:pPr>
+            <a:r>
+              <a:rPr lang="en-US" sz="4800" b="1" dirty="0">
+                <a:solidFill>
+                  <a:srgbClr val="1B7F8C"/>
+                </a:solidFill>
+                <a:latin typeface="Cambria" pitchFamily="34" charset="0"/>
+                <a:ea typeface="Cambria" pitchFamily="34" charset="-122"/>
+                <a:cs typeface="Cambria" pitchFamily="34" charset="-120"/>
+              </a:rPr>
+              <a:t>219.353</a:t>
+            </a:r>
+            <a:endParaRPr lang="en-US" sz="4800" dirty="0"/>
+          </a:p>
+        </p:txBody>
+      </p:sp>
+      <p:sp>
+        <p:nvSpPr>
+          <p:cNvPr id="4" name="Text 2"/>
+          <p:cNvSpPr txBox="1"/>
+          <p:nvPr/>
+        </p:nvSpPr>
+        <p:spPr>
+          <a:xfrm>
+            <a:off x="548640" y="2377440"/>
+            <a:ext cx="2651760" cy="365760"/>
+          </a:xfrm>
+          <a:prstGeom prst="rect">
+            <a:avLst/>
+          </a:prstGeom>
+          <a:noFill/>
+          <a:ln/>
+        </p:spPr>
+        <p:txBody>
+          <a:bodyPr wrap="square" lIns="0" tIns="0" rIns="0" bIns="0" rtlCol="0" anchor="ctr"/>
+          <a:lstStyle/>
+          <a:p>
+            <a:pPr indent="0" marL="0">
+              <a:buNone/>
+            </a:pPr>
+            <a:r>
+              <a:rPr lang="en-US" sz="1400" dirty="0">
+                <a:solidFill>
+                  <a:srgbClr val="5B6B79"/>
+                </a:solidFill>
+                <a:latin typeface="Calibri" pitchFamily="34" charset="0"/>
+                <a:ea typeface="Calibri" pitchFamily="34" charset="-122"/>
+                <a:cs typeface="Calibri" pitchFamily="34" charset="-120"/>
+              </a:rPr>
+              <a:t>Total Revenue</a:t>
+            </a:r>
+            <a:endParaRPr lang="en-US" sz="1400" dirty="0"/>
+          </a:p>
+        </p:txBody>
+      </p:sp>
+      <p:sp>
+        <p:nvSpPr>
+          <p:cNvPr id="5" name="Text 3"/>
+          <p:cNvSpPr txBox="1"/>
+          <p:nvPr/>
+        </p:nvSpPr>
+        <p:spPr>
+          <a:xfrm>
+            <a:off x="3383280" y="1554480"/>
+            <a:ext cx="2651760" cy="822960"/>
+          </a:xfrm>
+          <a:prstGeom prst="rect">
+            <a:avLst/>
+          </a:prstGeom>
+          <a:noFill/>
+          <a:ln/>
+        </p:spPr>
+        <p:txBody>
+          <a:bodyPr wrap="square" lIns="0" tIns="0" rIns="0" bIns="0" rtlCol="0" anchor="ctr"/>
+          <a:lstStyle/>
+          <a:p>
+            <a:pPr indent="0" marL="0">
+              <a:buNone/>
+            </a:pPr>
+            <a:r>
+              <a:rPr lang="en-US" sz="4800" b="1" dirty="0">
+                <a:solidFill>
+                  <a:srgbClr val="F28C28"/>
+                </a:solidFill>
+                <a:latin typeface="Cambria" pitchFamily="34" charset="0"/>
+                <a:ea typeface="Cambria" pitchFamily="34" charset="-122"/>
+                <a:cs typeface="Cambria" pitchFamily="34" charset="-120"/>
+              </a:rPr>
+              <a:t>304</a:t>
+            </a:r>
+            <a:endParaRPr lang="en-US" sz="4800" dirty="0"/>
+          </a:p>
+        </p:txBody>
+      </p:sp>
+      <p:sp>
+        <p:nvSpPr>
+          <p:cNvPr id="6" name="Text 4"/>
+          <p:cNvSpPr txBox="1"/>
+          <p:nvPr/>
+        </p:nvSpPr>
+        <p:spPr>
+          <a:xfrm>
+            <a:off x="3383280" y="2377440"/>
+            <a:ext cx="2651760" cy="365760"/>
+          </a:xfrm>
+          <a:prstGeom prst="rect">
+            <a:avLst/>
+          </a:prstGeom>
+          <a:noFill/>
+          <a:ln/>
+        </p:spPr>
+        <p:txBody>
+          <a:bodyPr wrap="square" lIns="0" tIns="0" rIns="0" bIns="0" rtlCol="0" anchor="ctr"/>
+          <a:lstStyle/>
+          <a:p>
+            <a:pPr indent="0" marL="0">
+              <a:buNone/>
+            </a:pPr>
+            <a:r>
+              <a:rPr lang="en-US" sz="1400" dirty="0">
+                <a:solidFill>
+                  <a:srgbClr val="5B6B79"/>
+                </a:solidFill>
+                <a:latin typeface="Calibri" pitchFamily="34" charset="0"/>
+                <a:ea typeface="Calibri" pitchFamily="34" charset="-122"/>
+                <a:cs typeface="Calibri" pitchFamily="34" charset="-120"/>
+              </a:rPr>
+              <a:t>Total Transactions</a:t>
+            </a:r>
+            <a:endParaRPr lang="en-US" sz="1400" dirty="0"/>
+          </a:p>
+        </p:txBody>
+      </p:sp>
+      <p:sp>
+        <p:nvSpPr>
+          <p:cNvPr id="7" name="Text 5"/>
+          <p:cNvSpPr txBox="1"/>
+          <p:nvPr/>
+        </p:nvSpPr>
+        <p:spPr>
+          <a:xfrm>
+            <a:off x="6217920" y="1554480"/>
+            <a:ext cx="2651760" cy="822960"/>
+          </a:xfrm>
+          <a:prstGeom prst="rect">
+            <a:avLst/>
+          </a:prstGeom>
+          <a:noFill/>
+          <a:ln/>
+        </p:spPr>
+        <p:txBody>
+          <a:bodyPr wrap="square" lIns="0" tIns="0" rIns="0" bIns="0" rtlCol="0" anchor="ctr"/>
+          <a:lstStyle/>
+          <a:p>
+            <a:pPr indent="0" marL="0">
+              <a:buNone/>
+            </a:pPr>
+            <a:r>
+              <a:rPr lang="en-US" sz="4800" b="1" dirty="0">
+                <a:solidFill>
+                  <a:srgbClr val="12304A"/>
+                </a:solidFill>
+                <a:latin typeface="Cambria" pitchFamily="34" charset="0"/>
+                <a:ea typeface="Cambria" pitchFamily="34" charset="-122"/>
+                <a:cs typeface="Cambria" pitchFamily="34" charset="-120"/>
+              </a:rPr>
+              <a:t>59</a:t>
+            </a:r>
+            <a:endParaRPr lang="en-US" sz="4800" dirty="0"/>
+          </a:p>
+        </p:txBody>
+      </p:sp>
+      <p:sp>
+        <p:nvSpPr>
+          <p:cNvPr id="8" name="Text 6"/>
+          <p:cNvSpPr txBox="1"/>
+          <p:nvPr/>
+        </p:nvSpPr>
+        <p:spPr>
+          <a:xfrm>
+            <a:off x="6217920" y="2377440"/>
+            <a:ext cx="2651760" cy="365760"/>
+          </a:xfrm>
+          <a:prstGeom prst="rect">
+            <a:avLst/>
+          </a:prstGeom>
+          <a:noFill/>
+          <a:ln/>
+        </p:spPr>
+        <p:txBody>
+          <a:bodyPr wrap="square" lIns="0" tIns="0" rIns="0" bIns="0" rtlCol="0" anchor="ctr"/>
+          <a:lstStyle/>
+          <a:p>
+            <a:pPr indent="0" marL="0">
+              <a:buNone/>
+            </a:pPr>
+            <a:r>
+              <a:rPr lang="en-US" sz="1400" dirty="0">
+                <a:solidFill>
+                  <a:srgbClr val="5B6B79"/>
+                </a:solidFill>
+                <a:latin typeface="Calibri" pitchFamily="34" charset="0"/>
+                <a:ea typeface="Calibri" pitchFamily="34" charset="-122"/>
+                <a:cs typeface="Calibri" pitchFamily="34" charset="-120"/>
+              </a:rPr>
+              <a:t>Total Unique Customers</a:t>
+            </a:r>
+            <a:endParaRPr lang="en-US" sz="1400" dirty="0"/>
+          </a:p>
+        </p:txBody>
+      </p:sp>
+      <p:sp>
+        <p:nvSpPr>
+          <p:cNvPr id="9" name="Text 7"/>
+          <p:cNvSpPr txBox="1"/>
+          <p:nvPr/>
+        </p:nvSpPr>
+        <p:spPr>
+          <a:xfrm>
+            <a:off x="9052560" y="1554480"/>
+            <a:ext cx="2651760" cy="822960"/>
+          </a:xfrm>
+          <a:prstGeom prst="rect">
+            <a:avLst/>
+          </a:prstGeom>
+          <a:noFill/>
+          <a:ln/>
+        </p:spPr>
+        <p:txBody>
+          <a:bodyPr wrap="square" lIns="0" tIns="0" rIns="0" bIns="0" rtlCol="0" anchor="ctr"/>
+          <a:lstStyle/>
+          <a:p>
+            <a:pPr indent="0" marL="0">
+              <a:buNone/>
+            </a:pPr>
+            <a:r>
+              <a:rPr lang="en-US" sz="4800" b="1" dirty="0">
+                <a:solidFill>
+                  <a:srgbClr val="1B7F8C"/>
+                </a:solidFill>
+                <a:latin typeface="Cambria" pitchFamily="34" charset="0"/>
+                <a:ea typeface="Cambria" pitchFamily="34" charset="-122"/>
+                <a:cs typeface="Cambria" pitchFamily="34" charset="-120"/>
+              </a:rPr>
+              <a:t>721,55</a:t>
+            </a:r>
+            <a:endParaRPr lang="en-US" sz="4800" dirty="0"/>
+          </a:p>
+        </p:txBody>
+      </p:sp>
+      <p:sp>
+        <p:nvSpPr>
+          <p:cNvPr id="10" name="Text 8"/>
+          <p:cNvSpPr txBox="1"/>
+          <p:nvPr/>
+        </p:nvSpPr>
+        <p:spPr>
+          <a:xfrm>
+            <a:off x="9052560" y="2377440"/>
+            <a:ext cx="2651760" cy="365760"/>
+          </a:xfrm>
+          <a:prstGeom prst="rect">
+            <a:avLst/>
+          </a:prstGeom>
+          <a:noFill/>
+          <a:ln/>
+        </p:spPr>
+        <p:txBody>
+          <a:bodyPr wrap="square" lIns="0" tIns="0" rIns="0" bIns="0" rtlCol="0" anchor="ctr"/>
+          <a:lstStyle/>
+          <a:p>
+            <a:pPr indent="0" marL="0">
+              <a:buNone/>
+            </a:pPr>
+            <a:r>
+              <a:rPr lang="en-US" sz="1400" dirty="0">
+                <a:solidFill>
+                  <a:srgbClr val="5B6B79"/>
+                </a:solidFill>
+                <a:latin typeface="Calibri" pitchFamily="34" charset="0"/>
+                <a:ea typeface="Calibri" pitchFamily="34" charset="-122"/>
+                <a:cs typeface="Calibri" pitchFamily="34" charset="-120"/>
+              </a:rPr>
+              <a:t>Avg Order Value</a:t>
+            </a:r>
+            <a:endParaRPr lang="en-US" sz="1400" dirty="0"/>
+          </a:p>
+        </p:txBody>
+      </p:sp>
+      <p:sp>
+        <p:nvSpPr>
+          <p:cNvPr id="11" name="Shape 9"/>
+          <p:cNvSpPr/>
+          <p:nvPr/>
+        </p:nvSpPr>
+        <p:spPr>
+          <a:xfrm>
+            <a:off x="548640" y="3383280"/>
+            <a:ext cx="11064240" cy="2377440"/>
+          </a:xfrm>
+          <a:prstGeom prst="roundRect">
+            <a:avLst>
+              <a:gd name="adj" fmla="val 4615"/>
+            </a:avLst>
+          </a:prstGeom>
+          <a:solidFill>
+            <a:srgbClr val="F3F6F8"/>
+          </a:solidFill>
+          <a:ln w="12700">
+            <a:solidFill>
+              <a:srgbClr val="F3F6F8"/>
+            </a:solidFill>
+            <a:prstDash val="solid"/>
+          </a:ln>
+        </p:spPr>
+      </p:sp>
+      <p:sp>
+        <p:nvSpPr>
+          <p:cNvPr id="12" name="Text 10"/>
+          <p:cNvSpPr txBox="1"/>
+          <p:nvPr/>
+        </p:nvSpPr>
+        <p:spPr>
+          <a:xfrm>
+            <a:off x="777240" y="3566160"/>
+            <a:ext cx="10607040" cy="457200"/>
+          </a:xfrm>
+          <a:prstGeom prst="rect">
+            <a:avLst/>
+          </a:prstGeom>
+          <a:noFill/>
+          <a:ln/>
+        </p:spPr>
+        <p:txBody>
+          <a:bodyPr wrap="square" lIns="0" tIns="0" rIns="0" bIns="0" rtlCol="0" anchor="ctr"/>
+          <a:lstStyle/>
+          <a:p>
+            <a:pPr indent="0" marL="0">
+              <a:buNone/>
+            </a:pPr>
+            <a:r>
+              <a:rPr lang="en-US" sz="2000" b="1" dirty="0">
+                <a:solidFill>
+                  <a:srgbClr val="12304A"/>
+                </a:solidFill>
+                <a:latin typeface="Cambria" pitchFamily="34" charset="0"/>
+                <a:ea typeface="Cambria" pitchFamily="34" charset="-122"/>
+                <a:cs typeface="Cambria" pitchFamily="34" charset="-120"/>
+              </a:rPr>
+              <a:t>Makna</a:t>
+            </a:r>
+            <a:endParaRPr lang="en-US" sz="2000" dirty="0"/>
+          </a:p>
+        </p:txBody>
+      </p:sp>
+      <p:sp>
+        <p:nvSpPr>
+          <p:cNvPr id="13" name="Text 11"/>
+          <p:cNvSpPr txBox="1"/>
+          <p:nvPr/>
+        </p:nvSpPr>
+        <p:spPr>
+          <a:xfrm>
+            <a:off x="777240" y="4069080"/>
+            <a:ext cx="10607040" cy="1508760"/>
+          </a:xfrm>
+          <a:prstGeom prst="rect">
+            <a:avLst/>
+          </a:prstGeom>
+          <a:noFill/>
+          <a:ln/>
+        </p:spPr>
+        <p:txBody>
+          <a:bodyPr wrap="square" lIns="0" tIns="0" rIns="0" bIns="0" rtlCol="0" anchor="t"/>
+          <a:lstStyle/>
+          <a:p>
+            <a:pPr indent="0" marL="0">
+              <a:buNone/>
+            </a:pPr>
+            <a:r>
+              <a:rPr lang="en-US" sz="1600" dirty="0">
+                <a:solidFill>
+                  <a:srgbClr val="1E2A35"/>
+                </a:solidFill>
+                <a:latin typeface="Calibri" pitchFamily="34" charset="0"/>
+                <a:ea typeface="Calibri" pitchFamily="34" charset="-122"/>
+                <a:cs typeface="Calibri" pitchFamily="34" charset="-120"/>
+              </a:rPr>
+              <a:t>Saat slicer Region dipilih South America, seluruh measure DAX dihitung ulang hanya untuk wilayah itu. Wilayah ini menyumbang 31,8% revenue dengan 59 pelanggan aktif dan nilai rata-rata per transaksi 721,55, lebih tinggi dari rata-rata keseluruhan 690,00.</a:t>
+            </a:r>
+            <a:endParaRPr lang="en-US" sz="1600" dirty="0"/>
+          </a:p>
+        </p:txBody>
+      </p:sp>
+    </p:spTree>
+  </p:cSld>
+  <p:clrMapOvr>
+    <a:masterClrMapping/>
+  </p:clrMapOvr>
+</p:sld>
+</file>
+
+<file path=ppt/slides/slide19.xml><?xml version="1.0" encoding="utf-8"?>
+<p:sld xmlns:a="http://schemas.openxmlformats.org/drawingml/2006/main" xmlns:r="http://schemas.openxmlformats.org/officeDocument/2006/relationships" xmlns:p="http://schemas.openxmlformats.org/presentationml/2006/main">
+  <p:cSld name="Slide 19">
+    <p:bg>
+      <p:bgPr>
+        <a:solidFill>
+          <a:srgbClr val="FFFFFF"/>
+        </a:solidFill>
+      </p:bgPr>
+    </p:bg>
+    <p:spTree>
+      <p:nvGrpSpPr>
+        <p:cNvPr id="1" name=""/>
+        <p:cNvGrpSpPr/>
+        <p:nvPr/>
+      </p:nvGrpSpPr>
+      <p:grpSpPr>
+        <a:xfrm>
+          <a:off x="0" y="0"/>
+          <a:ext cx="0" cy="0"/>
+          <a:chOff x="0" y="0"/>
+          <a:chExt cx="0" cy="0"/>
+        </a:xfrm>
+      </p:grpSpPr>
+      <p:sp>
+        <p:nvSpPr>
+          <p:cNvPr id="2" name="Text 0"/>
+          <p:cNvSpPr txBox="1"/>
+          <p:nvPr/>
+        </p:nvSpPr>
+        <p:spPr>
+          <a:xfrm>
+            <a:off x="548640" y="365760"/>
+            <a:ext cx="11064240" cy="731520"/>
+          </a:xfrm>
+          <a:prstGeom prst="rect">
+            <a:avLst/>
+          </a:prstGeom>
+          <a:noFill/>
+          <a:ln/>
+        </p:spPr>
+        <p:txBody>
+          <a:bodyPr wrap="square" lIns="0" tIns="0" rIns="0" bIns="0" rtlCol="0" anchor="ctr"/>
+          <a:lstStyle/>
+          <a:p>
+            <a:pPr indent="0" marL="0">
+              <a:buNone/>
+            </a:pPr>
+            <a:r>
+              <a:rPr lang="en-US" sz="3400" b="1" dirty="0">
+                <a:solidFill>
+                  <a:srgbClr val="12304A"/>
+                </a:solidFill>
+                <a:latin typeface="Cambria" pitchFamily="34" charset="0"/>
+                <a:ea typeface="Cambria" pitchFamily="34" charset="-122"/>
+                <a:cs typeface="Cambria" pitchFamily="34" charset="-120"/>
+              </a:rPr>
               <a:t>Interpretasi hasil</a:t>
             </a:r>
             <a:endParaRPr lang="en-US" sz="3400" dirty="0"/>
@@ -7390,536 +8254,6 @@
               <a:t>South America unggul dalam revenue dan jumlah pelanggan. Pendapatan menyebar: 20 pelanggan teratas hanya 20%.</a:t>
             </a:r>
             <a:endParaRPr lang="en-US" sz="1600" dirty="0"/>
-          </a:p>
-        </p:txBody>
-      </p:sp>
-    </p:spTree>
-  </p:cSld>
-  <p:clrMapOvr>
-    <a:masterClrMapping/>
-  </p:clrMapOvr>
-</p:sld>
-</file>
-
-<file path=ppt/slides/slide17.xml><?xml version="1.0" encoding="utf-8"?>
-<p:sld xmlns:a="http://schemas.openxmlformats.org/drawingml/2006/main" xmlns:r="http://schemas.openxmlformats.org/officeDocument/2006/relationships" xmlns:p="http://schemas.openxmlformats.org/presentationml/2006/main">
-  <p:cSld name="Slide 17">
-    <p:bg>
-      <p:bgPr>
-        <a:solidFill>
-          <a:srgbClr val="12304A"/>
-        </a:solidFill>
-      </p:bgPr>
-    </p:bg>
-    <p:spTree>
-      <p:nvGrpSpPr>
-        <p:cNvPr id="1" name=""/>
-        <p:cNvGrpSpPr/>
-        <p:nvPr/>
-      </p:nvGrpSpPr>
-      <p:grpSpPr>
-        <a:xfrm>
-          <a:off x="0" y="0"/>
-          <a:ext cx="0" cy="0"/>
-          <a:chOff x="0" y="0"/>
-          <a:chExt cx="0" cy="0"/>
-        </a:xfrm>
-      </p:grpSpPr>
-      <p:sp>
-        <p:nvSpPr>
-          <p:cNvPr id="2" name="Text 0"/>
-          <p:cNvSpPr txBox="1"/>
-          <p:nvPr/>
-        </p:nvSpPr>
-        <p:spPr>
-          <a:xfrm>
-            <a:off x="548640" y="365760"/>
-            <a:ext cx="11064240" cy="731520"/>
-          </a:xfrm>
-          <a:prstGeom prst="rect">
-            <a:avLst/>
-          </a:prstGeom>
-          <a:noFill/>
-          <a:ln/>
-        </p:spPr>
-        <p:txBody>
-          <a:bodyPr wrap="square" lIns="0" tIns="0" rIns="0" bIns="0" rtlCol="0" anchor="ctr"/>
-          <a:lstStyle/>
-          <a:p>
-            <a:pPr indent="0" marL="0">
-              <a:buNone/>
-            </a:pPr>
-            <a:r>
-              <a:rPr lang="en-US" sz="3400" b="1" dirty="0">
-                <a:solidFill>
-                  <a:srgbClr val="FFFFFF"/>
-                </a:solidFill>
-                <a:latin typeface="Cambria" pitchFamily="34" charset="0"/>
-                <a:ea typeface="Cambria" pitchFamily="34" charset="-122"/>
-                <a:cs typeface="Cambria" pitchFamily="34" charset="-120"/>
-              </a:rPr>
-              <a:t>Rekomendasi keputusan</a:t>
-            </a:r>
-            <a:endParaRPr lang="en-US" sz="3400" dirty="0"/>
-          </a:p>
-        </p:txBody>
-      </p:sp>
-      <p:sp>
-        <p:nvSpPr>
-          <p:cNvPr id="3" name="Shape 1"/>
-          <p:cNvSpPr/>
-          <p:nvPr/>
-        </p:nvSpPr>
-        <p:spPr>
-          <a:xfrm>
-            <a:off x="548640" y="1463040"/>
-            <a:ext cx="5394960" cy="1828800"/>
-          </a:xfrm>
-          <a:prstGeom prst="roundRect">
-            <a:avLst>
-              <a:gd name="adj" fmla="val 6000"/>
-            </a:avLst>
-          </a:prstGeom>
-          <a:solidFill>
-            <a:srgbClr val="1D4468"/>
-          </a:solidFill>
-          <a:ln w="12700">
-            <a:solidFill>
-              <a:srgbClr val="1D4468"/>
-            </a:solidFill>
-            <a:prstDash val="solid"/>
-          </a:ln>
-        </p:spPr>
-      </p:sp>
-      <p:sp>
-        <p:nvSpPr>
-          <p:cNvPr id="4" name="Text 2"/>
-          <p:cNvSpPr txBox="1"/>
-          <p:nvPr/>
-        </p:nvSpPr>
-        <p:spPr>
-          <a:xfrm>
-            <a:off x="822960" y="1645920"/>
-            <a:ext cx="4846320" cy="457200"/>
-          </a:xfrm>
-          <a:prstGeom prst="rect">
-            <a:avLst/>
-          </a:prstGeom>
-          <a:noFill/>
-          <a:ln/>
-        </p:spPr>
-        <p:txBody>
-          <a:bodyPr wrap="square" lIns="0" tIns="0" rIns="0" bIns="0" rtlCol="0" anchor="ctr"/>
-          <a:lstStyle/>
-          <a:p>
-            <a:pPr indent="0" marL="0">
-              <a:buNone/>
-            </a:pPr>
-            <a:r>
-              <a:rPr lang="en-US" sz="2000" b="1" dirty="0">
-                <a:solidFill>
-                  <a:srgbClr val="F28C28"/>
-                </a:solidFill>
-                <a:latin typeface="Cambria" pitchFamily="34" charset="0"/>
-                <a:ea typeface="Cambria" pitchFamily="34" charset="-122"/>
-                <a:cs typeface="Cambria" pitchFamily="34" charset="-120"/>
-              </a:rPr>
-              <a:t>Prioritaskan South America</a:t>
-            </a:r>
-            <a:endParaRPr lang="en-US" sz="2000" dirty="0"/>
-          </a:p>
-        </p:txBody>
-      </p:sp>
-      <p:sp>
-        <p:nvSpPr>
-          <p:cNvPr id="5" name="Text 3"/>
-          <p:cNvSpPr txBox="1"/>
-          <p:nvPr/>
-        </p:nvSpPr>
-        <p:spPr>
-          <a:xfrm>
-            <a:off x="822960" y="2148840"/>
-            <a:ext cx="4846320" cy="1005840"/>
-          </a:xfrm>
-          <a:prstGeom prst="rect">
-            <a:avLst/>
-          </a:prstGeom>
-          <a:noFill/>
-          <a:ln/>
-        </p:spPr>
-        <p:txBody>
-          <a:bodyPr wrap="square" lIns="0" tIns="0" rIns="0" bIns="0" rtlCol="0" anchor="t"/>
-          <a:lstStyle/>
-          <a:p>
-            <a:pPr indent="0" marL="0">
-              <a:buNone/>
-            </a:pPr>
-            <a:r>
-              <a:rPr lang="en-US" sz="1500" dirty="0">
-                <a:solidFill>
-                  <a:srgbClr val="FFFFFF"/>
-                </a:solidFill>
-                <a:latin typeface="Calibri" pitchFamily="34" charset="0"/>
-                <a:ea typeface="Calibri" pitchFamily="34" charset="-122"/>
-                <a:cs typeface="Calibri" pitchFamily="34" charset="-120"/>
-              </a:rPr>
-              <a:t>Alokasikan anggaran promosi dan stok lebih besar ke wilayah dengan 31,8% revenue dan revenue per pelanggan tertinggi.</a:t>
-            </a:r>
-            <a:endParaRPr lang="en-US" sz="1500" dirty="0"/>
-          </a:p>
-        </p:txBody>
-      </p:sp>
-      <p:sp>
-        <p:nvSpPr>
-          <p:cNvPr id="6" name="Shape 4"/>
-          <p:cNvSpPr/>
-          <p:nvPr/>
-        </p:nvSpPr>
-        <p:spPr>
-          <a:xfrm>
-            <a:off x="6217920" y="1463040"/>
-            <a:ext cx="5394960" cy="1828800"/>
-          </a:xfrm>
-          <a:prstGeom prst="roundRect">
-            <a:avLst>
-              <a:gd name="adj" fmla="val 6000"/>
-            </a:avLst>
-          </a:prstGeom>
-          <a:solidFill>
-            <a:srgbClr val="1D4468"/>
-          </a:solidFill>
-          <a:ln w="12700">
-            <a:solidFill>
-              <a:srgbClr val="1D4468"/>
-            </a:solidFill>
-            <a:prstDash val="solid"/>
-          </a:ln>
-        </p:spPr>
-      </p:sp>
-      <p:sp>
-        <p:nvSpPr>
-          <p:cNvPr id="7" name="Text 5"/>
-          <p:cNvSpPr txBox="1"/>
-          <p:nvPr/>
-        </p:nvSpPr>
-        <p:spPr>
-          <a:xfrm>
-            <a:off x="6492240" y="1645920"/>
-            <a:ext cx="4846320" cy="457200"/>
-          </a:xfrm>
-          <a:prstGeom prst="rect">
-            <a:avLst/>
-          </a:prstGeom>
-          <a:noFill/>
-          <a:ln/>
-        </p:spPr>
-        <p:txBody>
-          <a:bodyPr wrap="square" lIns="0" tIns="0" rIns="0" bIns="0" rtlCol="0" anchor="ctr"/>
-          <a:lstStyle/>
-          <a:p>
-            <a:pPr indent="0" marL="0">
-              <a:buNone/>
-            </a:pPr>
-            <a:r>
-              <a:rPr lang="en-US" sz="2000" b="1" dirty="0">
-                <a:solidFill>
-                  <a:srgbClr val="F28C28"/>
-                </a:solidFill>
-                <a:latin typeface="Cambria" pitchFamily="34" charset="0"/>
-                <a:ea typeface="Cambria" pitchFamily="34" charset="-122"/>
-                <a:cs typeface="Cambria" pitchFamily="34" charset="-120"/>
-              </a:rPr>
-              <a:t>Dorong Books dan Electronics</a:t>
-            </a:r>
-            <a:endParaRPr lang="en-US" sz="2000" dirty="0"/>
-          </a:p>
-        </p:txBody>
-      </p:sp>
-      <p:sp>
-        <p:nvSpPr>
-          <p:cNvPr id="8" name="Text 6"/>
-          <p:cNvSpPr txBox="1"/>
-          <p:nvPr/>
-        </p:nvSpPr>
-        <p:spPr>
-          <a:xfrm>
-            <a:off x="6492240" y="2148840"/>
-            <a:ext cx="4846320" cy="1005840"/>
-          </a:xfrm>
-          <a:prstGeom prst="rect">
-            <a:avLst/>
-          </a:prstGeom>
-          <a:noFill/>
-          <a:ln/>
-        </p:spPr>
-        <p:txBody>
-          <a:bodyPr wrap="square" lIns="0" tIns="0" rIns="0" bIns="0" rtlCol="0" anchor="t"/>
-          <a:lstStyle/>
-          <a:p>
-            <a:pPr indent="0" marL="0">
-              <a:buNone/>
-            </a:pPr>
-            <a:r>
-              <a:rPr lang="en-US" sz="1500" dirty="0">
-                <a:solidFill>
-                  <a:srgbClr val="FFFFFF"/>
-                </a:solidFill>
-                <a:latin typeface="Calibri" pitchFamily="34" charset="0"/>
-                <a:ea typeface="Calibri" pitchFamily="34" charset="-122"/>
-                <a:cs typeface="Calibri" pitchFamily="34" charset="-120"/>
-              </a:rPr>
-              <a:t>Jaga stok produk terlaris seperti P029, P048, P039. Beri bundling atau diskon untuk Home Decor yang tertinggal.</a:t>
-            </a:r>
-            <a:endParaRPr lang="en-US" sz="1500" dirty="0"/>
-          </a:p>
-        </p:txBody>
-      </p:sp>
-      <p:sp>
-        <p:nvSpPr>
-          <p:cNvPr id="9" name="Shape 7"/>
-          <p:cNvSpPr/>
-          <p:nvPr/>
-        </p:nvSpPr>
-        <p:spPr>
-          <a:xfrm>
-            <a:off x="548640" y="3566160"/>
-            <a:ext cx="5394960" cy="1828800"/>
-          </a:xfrm>
-          <a:prstGeom prst="roundRect">
-            <a:avLst>
-              <a:gd name="adj" fmla="val 6000"/>
-            </a:avLst>
-          </a:prstGeom>
-          <a:solidFill>
-            <a:srgbClr val="1D4468"/>
-          </a:solidFill>
-          <a:ln w="12700">
-            <a:solidFill>
-              <a:srgbClr val="1D4468"/>
-            </a:solidFill>
-            <a:prstDash val="solid"/>
-          </a:ln>
-        </p:spPr>
-      </p:sp>
-      <p:sp>
-        <p:nvSpPr>
-          <p:cNvPr id="10" name="Text 8"/>
-          <p:cNvSpPr txBox="1"/>
-          <p:nvPr/>
-        </p:nvSpPr>
-        <p:spPr>
-          <a:xfrm>
-            <a:off x="822960" y="3749040"/>
-            <a:ext cx="4846320" cy="457200"/>
-          </a:xfrm>
-          <a:prstGeom prst="rect">
-            <a:avLst/>
-          </a:prstGeom>
-          <a:noFill/>
-          <a:ln/>
-        </p:spPr>
-        <p:txBody>
-          <a:bodyPr wrap="square" lIns="0" tIns="0" rIns="0" bIns="0" rtlCol="0" anchor="ctr"/>
-          <a:lstStyle/>
-          <a:p>
-            <a:pPr indent="0" marL="0">
-              <a:buNone/>
-            </a:pPr>
-            <a:r>
-              <a:rPr lang="en-US" sz="2000" b="1" dirty="0">
-                <a:solidFill>
-                  <a:srgbClr val="F28C28"/>
-                </a:solidFill>
-                <a:latin typeface="Cambria" pitchFamily="34" charset="0"/>
-                <a:ea typeface="Cambria" pitchFamily="34" charset="-122"/>
-                <a:cs typeface="Cambria" pitchFamily="34" charset="-120"/>
-              </a:rPr>
-              <a:t>Antisipasi musim sepi</a:t>
-            </a:r>
-            <a:endParaRPr lang="en-US" sz="2000" dirty="0"/>
-          </a:p>
-        </p:txBody>
-      </p:sp>
-      <p:sp>
-        <p:nvSpPr>
-          <p:cNvPr id="11" name="Text 9"/>
-          <p:cNvSpPr txBox="1"/>
-          <p:nvPr/>
-        </p:nvSpPr>
-        <p:spPr>
-          <a:xfrm>
-            <a:off x="822960" y="4251960"/>
-            <a:ext cx="4846320" cy="1005840"/>
-          </a:xfrm>
-          <a:prstGeom prst="rect">
-            <a:avLst/>
-          </a:prstGeom>
-          <a:noFill/>
-          <a:ln/>
-        </p:spPr>
-        <p:txBody>
-          <a:bodyPr wrap="square" lIns="0" tIns="0" rIns="0" bIns="0" rtlCol="0" anchor="t"/>
-          <a:lstStyle/>
-          <a:p>
-            <a:pPr indent="0" marL="0">
-              <a:buNone/>
-            </a:pPr>
-            <a:r>
-              <a:rPr lang="en-US" sz="1500" dirty="0">
-                <a:solidFill>
-                  <a:srgbClr val="FFFFFF"/>
-                </a:solidFill>
-                <a:latin typeface="Calibri" pitchFamily="34" charset="0"/>
-                <a:ea typeface="Calibri" pitchFamily="34" charset="-122"/>
-                <a:cs typeface="Calibri" pitchFamily="34" charset="-120"/>
-              </a:rPr>
-              <a:t>Siapkan promo untuk Oktober dan November saat revenue turun, dan perkuat kampanye menjelang Juli dan September.</a:t>
-            </a:r>
-            <a:endParaRPr lang="en-US" sz="1500" dirty="0"/>
-          </a:p>
-        </p:txBody>
-      </p:sp>
-      <p:sp>
-        <p:nvSpPr>
-          <p:cNvPr id="12" name="Shape 10"/>
-          <p:cNvSpPr/>
-          <p:nvPr/>
-        </p:nvSpPr>
-        <p:spPr>
-          <a:xfrm>
-            <a:off x="6217920" y="3566160"/>
-            <a:ext cx="5394960" cy="1828800"/>
-          </a:xfrm>
-          <a:prstGeom prst="roundRect">
-            <a:avLst>
-              <a:gd name="adj" fmla="val 6000"/>
-            </a:avLst>
-          </a:prstGeom>
-          <a:solidFill>
-            <a:srgbClr val="1D4468"/>
-          </a:solidFill>
-          <a:ln w="12700">
-            <a:solidFill>
-              <a:srgbClr val="1D4468"/>
-            </a:solidFill>
-            <a:prstDash val="solid"/>
-          </a:ln>
-        </p:spPr>
-      </p:sp>
-      <p:sp>
-        <p:nvSpPr>
-          <p:cNvPr id="13" name="Text 11"/>
-          <p:cNvSpPr txBox="1"/>
-          <p:nvPr/>
-        </p:nvSpPr>
-        <p:spPr>
-          <a:xfrm>
-            <a:off x="6492240" y="3749040"/>
-            <a:ext cx="4846320" cy="457200"/>
-          </a:xfrm>
-          <a:prstGeom prst="rect">
-            <a:avLst/>
-          </a:prstGeom>
-          <a:noFill/>
-          <a:ln/>
-        </p:spPr>
-        <p:txBody>
-          <a:bodyPr wrap="square" lIns="0" tIns="0" rIns="0" bIns="0" rtlCol="0" anchor="ctr"/>
-          <a:lstStyle/>
-          <a:p>
-            <a:pPr indent="0" marL="0">
-              <a:buNone/>
-            </a:pPr>
-            <a:r>
-              <a:rPr lang="en-US" sz="2000" b="1" dirty="0">
-                <a:solidFill>
-                  <a:srgbClr val="F28C28"/>
-                </a:solidFill>
-                <a:latin typeface="Cambria" pitchFamily="34" charset="0"/>
-                <a:ea typeface="Cambria" pitchFamily="34" charset="-122"/>
-                <a:cs typeface="Cambria" pitchFamily="34" charset="-120"/>
-              </a:rPr>
-              <a:t>Bangun loyalitas pelanggan</a:t>
-            </a:r>
-            <a:endParaRPr lang="en-US" sz="2000" dirty="0"/>
-          </a:p>
-        </p:txBody>
-      </p:sp>
-      <p:sp>
-        <p:nvSpPr>
-          <p:cNvPr id="14" name="Text 12"/>
-          <p:cNvSpPr txBox="1"/>
-          <p:nvPr/>
-        </p:nvSpPr>
-        <p:spPr>
-          <a:xfrm>
-            <a:off x="6492240" y="4251960"/>
-            <a:ext cx="4846320" cy="1005840"/>
-          </a:xfrm>
-          <a:prstGeom prst="rect">
-            <a:avLst/>
-          </a:prstGeom>
-          <a:noFill/>
-          <a:ln/>
-        </p:spPr>
-        <p:txBody>
-          <a:bodyPr wrap="square" lIns="0" tIns="0" rIns="0" bIns="0" rtlCol="0" anchor="t"/>
-          <a:lstStyle/>
-          <a:p>
-            <a:pPr indent="0" marL="0">
-              <a:buNone/>
-            </a:pPr>
-            <a:r>
-              <a:rPr lang="en-US" sz="1500" dirty="0">
-                <a:solidFill>
-                  <a:srgbClr val="FFFFFF"/>
-                </a:solidFill>
-                <a:latin typeface="Calibri" pitchFamily="34" charset="0"/>
-                <a:ea typeface="Calibri" pitchFamily="34" charset="-122"/>
-                <a:cs typeface="Calibri" pitchFamily="34" charset="-120"/>
-              </a:rPr>
-              <a:t>Beri program loyalitas bagi pelanggan teratas dan aktifkan satu pelanggan yang belum pernah membeli. Rapikan nama produk agar sesuai kategori.</a:t>
-            </a:r>
-            <a:endParaRPr lang="en-US" sz="1500" dirty="0"/>
-          </a:p>
-        </p:txBody>
-      </p:sp>
-      <p:sp>
-        <p:nvSpPr>
-          <p:cNvPr id="15" name="Text 13"/>
-          <p:cNvSpPr txBox="1"/>
-          <p:nvPr/>
-        </p:nvSpPr>
-        <p:spPr>
-          <a:xfrm>
-            <a:off x="548640" y="5852160"/>
-            <a:ext cx="11064240" cy="548640"/>
-          </a:xfrm>
-          <a:prstGeom prst="rect">
-            <a:avLst/>
-          </a:prstGeom>
-          <a:noFill/>
-          <a:ln/>
-        </p:spPr>
-        <p:txBody>
-          <a:bodyPr wrap="square" lIns="0" tIns="0" rIns="0" bIns="0" rtlCol="0" anchor="ctr"/>
-          <a:lstStyle/>
-          <a:p>
-            <a:pPr indent="0" marL="0">
-              <a:buNone/>
-            </a:pPr>
-            <a:r>
-              <a:rPr lang="en-US" sz="2400" dirty="0">
-                <a:solidFill>
-                  <a:srgbClr val="CADCFC"/>
-                </a:solidFill>
-                <a:latin typeface="Cambria" pitchFamily="34" charset="0"/>
-                <a:ea typeface="Cambria" pitchFamily="34" charset="-122"/>
-                <a:cs typeface="Cambria" pitchFamily="34" charset="-120"/>
-              </a:rPr>
-              <a:t>Terima kasih</a:t>
-            </a:r>
-            <a:endParaRPr lang="en-US" sz="2400" dirty="0"/>
           </a:p>
         </p:txBody>
       </p:sp>
@@ -8345,6 +8679,536 @@
               <a:t>EverMart adalah toko online dengan pelanggan di 4 wilayah dan 4 kategori produk.</a:t>
             </a:r>
             <a:endParaRPr lang="en-US" sz="1600" dirty="0"/>
+          </a:p>
+        </p:txBody>
+      </p:sp>
+    </p:spTree>
+  </p:cSld>
+  <p:clrMapOvr>
+    <a:masterClrMapping/>
+  </p:clrMapOvr>
+</p:sld>
+</file>
+
+<file path=ppt/slides/slide20.xml><?xml version="1.0" encoding="utf-8"?>
+<p:sld xmlns:a="http://schemas.openxmlformats.org/drawingml/2006/main" xmlns:r="http://schemas.openxmlformats.org/officeDocument/2006/relationships" xmlns:p="http://schemas.openxmlformats.org/presentationml/2006/main">
+  <p:cSld name="Slide 20">
+    <p:bg>
+      <p:bgPr>
+        <a:solidFill>
+          <a:srgbClr val="12304A"/>
+        </a:solidFill>
+      </p:bgPr>
+    </p:bg>
+    <p:spTree>
+      <p:nvGrpSpPr>
+        <p:cNvPr id="1" name=""/>
+        <p:cNvGrpSpPr/>
+        <p:nvPr/>
+      </p:nvGrpSpPr>
+      <p:grpSpPr>
+        <a:xfrm>
+          <a:off x="0" y="0"/>
+          <a:ext cx="0" cy="0"/>
+          <a:chOff x="0" y="0"/>
+          <a:chExt cx="0" cy="0"/>
+        </a:xfrm>
+      </p:grpSpPr>
+      <p:sp>
+        <p:nvSpPr>
+          <p:cNvPr id="2" name="Text 0"/>
+          <p:cNvSpPr txBox="1"/>
+          <p:nvPr/>
+        </p:nvSpPr>
+        <p:spPr>
+          <a:xfrm>
+            <a:off x="548640" y="365760"/>
+            <a:ext cx="11064240" cy="731520"/>
+          </a:xfrm>
+          <a:prstGeom prst="rect">
+            <a:avLst/>
+          </a:prstGeom>
+          <a:noFill/>
+          <a:ln/>
+        </p:spPr>
+        <p:txBody>
+          <a:bodyPr wrap="square" lIns="0" tIns="0" rIns="0" bIns="0" rtlCol="0" anchor="ctr"/>
+          <a:lstStyle/>
+          <a:p>
+            <a:pPr indent="0" marL="0">
+              <a:buNone/>
+            </a:pPr>
+            <a:r>
+              <a:rPr lang="en-US" sz="3400" b="1" dirty="0">
+                <a:solidFill>
+                  <a:srgbClr val="FFFFFF"/>
+                </a:solidFill>
+                <a:latin typeface="Cambria" pitchFamily="34" charset="0"/>
+                <a:ea typeface="Cambria" pitchFamily="34" charset="-122"/>
+                <a:cs typeface="Cambria" pitchFamily="34" charset="-120"/>
+              </a:rPr>
+              <a:t>Rekomendasi keputusan</a:t>
+            </a:r>
+            <a:endParaRPr lang="en-US" sz="3400" dirty="0"/>
+          </a:p>
+        </p:txBody>
+      </p:sp>
+      <p:sp>
+        <p:nvSpPr>
+          <p:cNvPr id="3" name="Shape 1"/>
+          <p:cNvSpPr/>
+          <p:nvPr/>
+        </p:nvSpPr>
+        <p:spPr>
+          <a:xfrm>
+            <a:off x="548640" y="1463040"/>
+            <a:ext cx="5394960" cy="1828800"/>
+          </a:xfrm>
+          <a:prstGeom prst="roundRect">
+            <a:avLst>
+              <a:gd name="adj" fmla="val 6000"/>
+            </a:avLst>
+          </a:prstGeom>
+          <a:solidFill>
+            <a:srgbClr val="1D4468"/>
+          </a:solidFill>
+          <a:ln w="12700">
+            <a:solidFill>
+              <a:srgbClr val="1D4468"/>
+            </a:solidFill>
+            <a:prstDash val="solid"/>
+          </a:ln>
+        </p:spPr>
+      </p:sp>
+      <p:sp>
+        <p:nvSpPr>
+          <p:cNvPr id="4" name="Text 2"/>
+          <p:cNvSpPr txBox="1"/>
+          <p:nvPr/>
+        </p:nvSpPr>
+        <p:spPr>
+          <a:xfrm>
+            <a:off x="822960" y="1645920"/>
+            <a:ext cx="4846320" cy="457200"/>
+          </a:xfrm>
+          <a:prstGeom prst="rect">
+            <a:avLst/>
+          </a:prstGeom>
+          <a:noFill/>
+          <a:ln/>
+        </p:spPr>
+        <p:txBody>
+          <a:bodyPr wrap="square" lIns="0" tIns="0" rIns="0" bIns="0" rtlCol="0" anchor="ctr"/>
+          <a:lstStyle/>
+          <a:p>
+            <a:pPr indent="0" marL="0">
+              <a:buNone/>
+            </a:pPr>
+            <a:r>
+              <a:rPr lang="en-US" sz="2000" b="1" dirty="0">
+                <a:solidFill>
+                  <a:srgbClr val="F28C28"/>
+                </a:solidFill>
+                <a:latin typeface="Cambria" pitchFamily="34" charset="0"/>
+                <a:ea typeface="Cambria" pitchFamily="34" charset="-122"/>
+                <a:cs typeface="Cambria" pitchFamily="34" charset="-120"/>
+              </a:rPr>
+              <a:t>Prioritaskan South America</a:t>
+            </a:r>
+            <a:endParaRPr lang="en-US" sz="2000" dirty="0"/>
+          </a:p>
+        </p:txBody>
+      </p:sp>
+      <p:sp>
+        <p:nvSpPr>
+          <p:cNvPr id="5" name="Text 3"/>
+          <p:cNvSpPr txBox="1"/>
+          <p:nvPr/>
+        </p:nvSpPr>
+        <p:spPr>
+          <a:xfrm>
+            <a:off x="822960" y="2148840"/>
+            <a:ext cx="4846320" cy="1005840"/>
+          </a:xfrm>
+          <a:prstGeom prst="rect">
+            <a:avLst/>
+          </a:prstGeom>
+          <a:noFill/>
+          <a:ln/>
+        </p:spPr>
+        <p:txBody>
+          <a:bodyPr wrap="square" lIns="0" tIns="0" rIns="0" bIns="0" rtlCol="0" anchor="t"/>
+          <a:lstStyle/>
+          <a:p>
+            <a:pPr indent="0" marL="0">
+              <a:buNone/>
+            </a:pPr>
+            <a:r>
+              <a:rPr lang="en-US" sz="1500" dirty="0">
+                <a:solidFill>
+                  <a:srgbClr val="FFFFFF"/>
+                </a:solidFill>
+                <a:latin typeface="Calibri" pitchFamily="34" charset="0"/>
+                <a:ea typeface="Calibri" pitchFamily="34" charset="-122"/>
+                <a:cs typeface="Calibri" pitchFamily="34" charset="-120"/>
+              </a:rPr>
+              <a:t>Alokasikan anggaran promosi dan stok lebih besar ke wilayah dengan 31,8% revenue dan revenue per pelanggan tertinggi.</a:t>
+            </a:r>
+            <a:endParaRPr lang="en-US" sz="1500" dirty="0"/>
+          </a:p>
+        </p:txBody>
+      </p:sp>
+      <p:sp>
+        <p:nvSpPr>
+          <p:cNvPr id="6" name="Shape 4"/>
+          <p:cNvSpPr/>
+          <p:nvPr/>
+        </p:nvSpPr>
+        <p:spPr>
+          <a:xfrm>
+            <a:off x="6217920" y="1463040"/>
+            <a:ext cx="5394960" cy="1828800"/>
+          </a:xfrm>
+          <a:prstGeom prst="roundRect">
+            <a:avLst>
+              <a:gd name="adj" fmla="val 6000"/>
+            </a:avLst>
+          </a:prstGeom>
+          <a:solidFill>
+            <a:srgbClr val="1D4468"/>
+          </a:solidFill>
+          <a:ln w="12700">
+            <a:solidFill>
+              <a:srgbClr val="1D4468"/>
+            </a:solidFill>
+            <a:prstDash val="solid"/>
+          </a:ln>
+        </p:spPr>
+      </p:sp>
+      <p:sp>
+        <p:nvSpPr>
+          <p:cNvPr id="7" name="Text 5"/>
+          <p:cNvSpPr txBox="1"/>
+          <p:nvPr/>
+        </p:nvSpPr>
+        <p:spPr>
+          <a:xfrm>
+            <a:off x="6492240" y="1645920"/>
+            <a:ext cx="4846320" cy="457200"/>
+          </a:xfrm>
+          <a:prstGeom prst="rect">
+            <a:avLst/>
+          </a:prstGeom>
+          <a:noFill/>
+          <a:ln/>
+        </p:spPr>
+        <p:txBody>
+          <a:bodyPr wrap="square" lIns="0" tIns="0" rIns="0" bIns="0" rtlCol="0" anchor="ctr"/>
+          <a:lstStyle/>
+          <a:p>
+            <a:pPr indent="0" marL="0">
+              <a:buNone/>
+            </a:pPr>
+            <a:r>
+              <a:rPr lang="en-US" sz="2000" b="1" dirty="0">
+                <a:solidFill>
+                  <a:srgbClr val="F28C28"/>
+                </a:solidFill>
+                <a:latin typeface="Cambria" pitchFamily="34" charset="0"/>
+                <a:ea typeface="Cambria" pitchFamily="34" charset="-122"/>
+                <a:cs typeface="Cambria" pitchFamily="34" charset="-120"/>
+              </a:rPr>
+              <a:t>Dorong Books dan Electronics</a:t>
+            </a:r>
+            <a:endParaRPr lang="en-US" sz="2000" dirty="0"/>
+          </a:p>
+        </p:txBody>
+      </p:sp>
+      <p:sp>
+        <p:nvSpPr>
+          <p:cNvPr id="8" name="Text 6"/>
+          <p:cNvSpPr txBox="1"/>
+          <p:nvPr/>
+        </p:nvSpPr>
+        <p:spPr>
+          <a:xfrm>
+            <a:off x="6492240" y="2148840"/>
+            <a:ext cx="4846320" cy="1005840"/>
+          </a:xfrm>
+          <a:prstGeom prst="rect">
+            <a:avLst/>
+          </a:prstGeom>
+          <a:noFill/>
+          <a:ln/>
+        </p:spPr>
+        <p:txBody>
+          <a:bodyPr wrap="square" lIns="0" tIns="0" rIns="0" bIns="0" rtlCol="0" anchor="t"/>
+          <a:lstStyle/>
+          <a:p>
+            <a:pPr indent="0" marL="0">
+              <a:buNone/>
+            </a:pPr>
+            <a:r>
+              <a:rPr lang="en-US" sz="1500" dirty="0">
+                <a:solidFill>
+                  <a:srgbClr val="FFFFFF"/>
+                </a:solidFill>
+                <a:latin typeface="Calibri" pitchFamily="34" charset="0"/>
+                <a:ea typeface="Calibri" pitchFamily="34" charset="-122"/>
+                <a:cs typeface="Calibri" pitchFamily="34" charset="-120"/>
+              </a:rPr>
+              <a:t>Jaga stok produk terlaris seperti P029, P048, P039. Beri bundling atau diskon untuk Home Decor yang tertinggal.</a:t>
+            </a:r>
+            <a:endParaRPr lang="en-US" sz="1500" dirty="0"/>
+          </a:p>
+        </p:txBody>
+      </p:sp>
+      <p:sp>
+        <p:nvSpPr>
+          <p:cNvPr id="9" name="Shape 7"/>
+          <p:cNvSpPr/>
+          <p:nvPr/>
+        </p:nvSpPr>
+        <p:spPr>
+          <a:xfrm>
+            <a:off x="548640" y="3566160"/>
+            <a:ext cx="5394960" cy="1828800"/>
+          </a:xfrm>
+          <a:prstGeom prst="roundRect">
+            <a:avLst>
+              <a:gd name="adj" fmla="val 6000"/>
+            </a:avLst>
+          </a:prstGeom>
+          <a:solidFill>
+            <a:srgbClr val="1D4468"/>
+          </a:solidFill>
+          <a:ln w="12700">
+            <a:solidFill>
+              <a:srgbClr val="1D4468"/>
+            </a:solidFill>
+            <a:prstDash val="solid"/>
+          </a:ln>
+        </p:spPr>
+      </p:sp>
+      <p:sp>
+        <p:nvSpPr>
+          <p:cNvPr id="10" name="Text 8"/>
+          <p:cNvSpPr txBox="1"/>
+          <p:nvPr/>
+        </p:nvSpPr>
+        <p:spPr>
+          <a:xfrm>
+            <a:off x="822960" y="3749040"/>
+            <a:ext cx="4846320" cy="457200"/>
+          </a:xfrm>
+          <a:prstGeom prst="rect">
+            <a:avLst/>
+          </a:prstGeom>
+          <a:noFill/>
+          <a:ln/>
+        </p:spPr>
+        <p:txBody>
+          <a:bodyPr wrap="square" lIns="0" tIns="0" rIns="0" bIns="0" rtlCol="0" anchor="ctr"/>
+          <a:lstStyle/>
+          <a:p>
+            <a:pPr indent="0" marL="0">
+              <a:buNone/>
+            </a:pPr>
+            <a:r>
+              <a:rPr lang="en-US" sz="2000" b="1" dirty="0">
+                <a:solidFill>
+                  <a:srgbClr val="F28C28"/>
+                </a:solidFill>
+                <a:latin typeface="Cambria" pitchFamily="34" charset="0"/>
+                <a:ea typeface="Cambria" pitchFamily="34" charset="-122"/>
+                <a:cs typeface="Cambria" pitchFamily="34" charset="-120"/>
+              </a:rPr>
+              <a:t>Antisipasi musim sepi</a:t>
+            </a:r>
+            <a:endParaRPr lang="en-US" sz="2000" dirty="0"/>
+          </a:p>
+        </p:txBody>
+      </p:sp>
+      <p:sp>
+        <p:nvSpPr>
+          <p:cNvPr id="11" name="Text 9"/>
+          <p:cNvSpPr txBox="1"/>
+          <p:nvPr/>
+        </p:nvSpPr>
+        <p:spPr>
+          <a:xfrm>
+            <a:off x="822960" y="4251960"/>
+            <a:ext cx="4846320" cy="1005840"/>
+          </a:xfrm>
+          <a:prstGeom prst="rect">
+            <a:avLst/>
+          </a:prstGeom>
+          <a:noFill/>
+          <a:ln/>
+        </p:spPr>
+        <p:txBody>
+          <a:bodyPr wrap="square" lIns="0" tIns="0" rIns="0" bIns="0" rtlCol="0" anchor="t"/>
+          <a:lstStyle/>
+          <a:p>
+            <a:pPr indent="0" marL="0">
+              <a:buNone/>
+            </a:pPr>
+            <a:r>
+              <a:rPr lang="en-US" sz="1500" dirty="0">
+                <a:solidFill>
+                  <a:srgbClr val="FFFFFF"/>
+                </a:solidFill>
+                <a:latin typeface="Calibri" pitchFamily="34" charset="0"/>
+                <a:ea typeface="Calibri" pitchFamily="34" charset="-122"/>
+                <a:cs typeface="Calibri" pitchFamily="34" charset="-120"/>
+              </a:rPr>
+              <a:t>Siapkan promo untuk Oktober dan November saat revenue turun, dan perkuat kampanye menjelang Juli dan September.</a:t>
+            </a:r>
+            <a:endParaRPr lang="en-US" sz="1500" dirty="0"/>
+          </a:p>
+        </p:txBody>
+      </p:sp>
+      <p:sp>
+        <p:nvSpPr>
+          <p:cNvPr id="12" name="Shape 10"/>
+          <p:cNvSpPr/>
+          <p:nvPr/>
+        </p:nvSpPr>
+        <p:spPr>
+          <a:xfrm>
+            <a:off x="6217920" y="3566160"/>
+            <a:ext cx="5394960" cy="1828800"/>
+          </a:xfrm>
+          <a:prstGeom prst="roundRect">
+            <a:avLst>
+              <a:gd name="adj" fmla="val 6000"/>
+            </a:avLst>
+          </a:prstGeom>
+          <a:solidFill>
+            <a:srgbClr val="1D4468"/>
+          </a:solidFill>
+          <a:ln w="12700">
+            <a:solidFill>
+              <a:srgbClr val="1D4468"/>
+            </a:solidFill>
+            <a:prstDash val="solid"/>
+          </a:ln>
+        </p:spPr>
+      </p:sp>
+      <p:sp>
+        <p:nvSpPr>
+          <p:cNvPr id="13" name="Text 11"/>
+          <p:cNvSpPr txBox="1"/>
+          <p:nvPr/>
+        </p:nvSpPr>
+        <p:spPr>
+          <a:xfrm>
+            <a:off x="6492240" y="3749040"/>
+            <a:ext cx="4846320" cy="457200"/>
+          </a:xfrm>
+          <a:prstGeom prst="rect">
+            <a:avLst/>
+          </a:prstGeom>
+          <a:noFill/>
+          <a:ln/>
+        </p:spPr>
+        <p:txBody>
+          <a:bodyPr wrap="square" lIns="0" tIns="0" rIns="0" bIns="0" rtlCol="0" anchor="ctr"/>
+          <a:lstStyle/>
+          <a:p>
+            <a:pPr indent="0" marL="0">
+              <a:buNone/>
+            </a:pPr>
+            <a:r>
+              <a:rPr lang="en-US" sz="2000" b="1" dirty="0">
+                <a:solidFill>
+                  <a:srgbClr val="F28C28"/>
+                </a:solidFill>
+                <a:latin typeface="Cambria" pitchFamily="34" charset="0"/>
+                <a:ea typeface="Cambria" pitchFamily="34" charset="-122"/>
+                <a:cs typeface="Cambria" pitchFamily="34" charset="-120"/>
+              </a:rPr>
+              <a:t>Bangun loyalitas pelanggan</a:t>
+            </a:r>
+            <a:endParaRPr lang="en-US" sz="2000" dirty="0"/>
+          </a:p>
+        </p:txBody>
+      </p:sp>
+      <p:sp>
+        <p:nvSpPr>
+          <p:cNvPr id="14" name="Text 12"/>
+          <p:cNvSpPr txBox="1"/>
+          <p:nvPr/>
+        </p:nvSpPr>
+        <p:spPr>
+          <a:xfrm>
+            <a:off x="6492240" y="4251960"/>
+            <a:ext cx="4846320" cy="1005840"/>
+          </a:xfrm>
+          <a:prstGeom prst="rect">
+            <a:avLst/>
+          </a:prstGeom>
+          <a:noFill/>
+          <a:ln/>
+        </p:spPr>
+        <p:txBody>
+          <a:bodyPr wrap="square" lIns="0" tIns="0" rIns="0" bIns="0" rtlCol="0" anchor="t"/>
+          <a:lstStyle/>
+          <a:p>
+            <a:pPr indent="0" marL="0">
+              <a:buNone/>
+            </a:pPr>
+            <a:r>
+              <a:rPr lang="en-US" sz="1500" dirty="0">
+                <a:solidFill>
+                  <a:srgbClr val="FFFFFF"/>
+                </a:solidFill>
+                <a:latin typeface="Calibri" pitchFamily="34" charset="0"/>
+                <a:ea typeface="Calibri" pitchFamily="34" charset="-122"/>
+                <a:cs typeface="Calibri" pitchFamily="34" charset="-120"/>
+              </a:rPr>
+              <a:t>Beri program loyalitas bagi pelanggan teratas dan aktifkan satu pelanggan yang belum pernah membeli. Rapikan nama produk agar sesuai kategori.</a:t>
+            </a:r>
+            <a:endParaRPr lang="en-US" sz="1500" dirty="0"/>
+          </a:p>
+        </p:txBody>
+      </p:sp>
+      <p:sp>
+        <p:nvSpPr>
+          <p:cNvPr id="15" name="Text 13"/>
+          <p:cNvSpPr txBox="1"/>
+          <p:nvPr/>
+        </p:nvSpPr>
+        <p:spPr>
+          <a:xfrm>
+            <a:off x="548640" y="5852160"/>
+            <a:ext cx="11064240" cy="548640"/>
+          </a:xfrm>
+          <a:prstGeom prst="rect">
+            <a:avLst/>
+          </a:prstGeom>
+          <a:noFill/>
+          <a:ln/>
+        </p:spPr>
+        <p:txBody>
+          <a:bodyPr wrap="square" lIns="0" tIns="0" rIns="0" bIns="0" rtlCol="0" anchor="ctr"/>
+          <a:lstStyle/>
+          <a:p>
+            <a:pPr indent="0" marL="0">
+              <a:buNone/>
+            </a:pPr>
+            <a:r>
+              <a:rPr lang="en-US" sz="2400" dirty="0">
+                <a:solidFill>
+                  <a:srgbClr val="CADCFC"/>
+                </a:solidFill>
+                <a:latin typeface="Cambria" pitchFamily="34" charset="0"/>
+                <a:ea typeface="Cambria" pitchFamily="34" charset="-122"/>
+                <a:cs typeface="Cambria" pitchFamily="34" charset="-120"/>
+              </a:rPr>
+              <a:t>Terima kasih</a:t>
+            </a:r>
+            <a:endParaRPr lang="en-US" sz="2400" dirty="0"/>
           </a:p>
         </p:txBody>
       </p:sp>

</xml_diff>

<commit_message>
Use Power Query screenshots with Applied Steps for all three tables
Co-Authored-By: Claude Sonnet 5.5 <noreply@anthropic.com>
Claude-Session: https://claude.ai/code/session_017RLvirTSx84UWnroqbbqTM
</commit_message>
<xml_diff>
--- a/output/EverMart_UTS_BDASC.pptx
+++ b/output/EverMart_UTS_BDASC.pptx
@@ -3342,7 +3342,7 @@
           <a:p>
             <a:r>
               <a:rPr lang="en-US" dirty="0"/>
-              <a:t>Tunjukkan Applied Steps: Source, Navigation, Promoted Headers, Changed Type.</a:t>
+              <a:t>Tunjukkan Applied Steps: Source, Navigation, Promoted Headers, Changed Type. Customers 200 baris, Products 100 baris, Transactions 1.000 baris.</a:t>
             </a:r>
             <a:endParaRPr lang="en-US" dirty="0"/>
           </a:p>
@@ -15368,9 +15368,48 @@
           </a:p>
         </p:txBody>
       </p:sp>
+      <p:sp>
+        <p:nvSpPr>
+          <p:cNvPr id="3" name="Text 1"/>
+          <p:cNvSpPr txBox="1"/>
+          <p:nvPr/>
+        </p:nvSpPr>
+        <p:spPr>
+          <a:xfrm>
+            <a:off x="548640" y="1234440"/>
+            <a:ext cx="3657600" cy="320040"/>
+          </a:xfrm>
+          <a:prstGeom prst="rect">
+            <a:avLst/>
+          </a:prstGeom>
+          <a:noFill/>
+          <a:ln/>
+        </p:spPr>
+        <p:txBody>
+          <a:bodyPr wrap="square" lIns="0" tIns="0" rIns="0" bIns="0" rtlCol="0" anchor="ctr"/>
+          <a:lstStyle/>
+          <a:p>
+            <a:pPr indent="0" marL="0">
+              <a:buNone/>
+            </a:pPr>
+            <a:r>
+              <a:rPr lang="en-US" sz="1600" b="1" dirty="0">
+                <a:solidFill>
+                  <a:srgbClr val="12304A"/>
+                </a:solidFill>
+                <a:latin typeface="Calibri" pitchFamily="34" charset="0"/>
+                <a:ea typeface="Calibri" pitchFamily="34" charset="-122"/>
+                <a:cs typeface="Calibri" pitchFamily="34" charset="-120"/>
+              </a:rPr>
+              <a:t>Customers</a:t>
+            </a:r>
+            <a:endParaRPr lang="en-US" sz="1600" dirty="0"/>
+          </a:p>
+        </p:txBody>
+      </p:sp>
       <p:pic>
         <p:nvPicPr>
-          <p:cNvPr id="3" name="Image 0" descr="/tmp/claude-0/-home-user-EXACOUNT/b3a0efd5-5ef2-5930-a9ef-1d7b86874e77/scratchpad/rep/pq_steps.png">    </p:cNvPr>
+          <p:cNvPr id="4" name="Image 0" descr="/tmp/claude-0/-home-user-EXACOUNT/b3a0efd5-5ef2-5930-a9ef-1d7b86874e77/images/94.png">    </p:cNvPr>
           <p:cNvPicPr>
             <a:picLocks noChangeAspect="1"/>
           </p:cNvPicPr>
@@ -15384,8 +15423,8 @@
         </p:blipFill>
         <p:spPr>
           <a:xfrm>
-            <a:off x="548640" y="1371600"/>
-            <a:ext cx="7498080" cy="1618488"/>
+            <a:off x="548640" y="1600200"/>
+            <a:ext cx="3657600" cy="1920240"/>
           </a:xfrm>
           <a:prstGeom prst="rect">
             <a:avLst/>
@@ -15394,18 +15433,144 @@
       </p:pic>
       <p:sp>
         <p:nvSpPr>
-          <p:cNvPr id="4" name="Shape 1"/>
+          <p:cNvPr id="5" name="Text 2"/>
+          <p:cNvSpPr txBox="1"/>
+          <p:nvPr/>
+        </p:nvSpPr>
+        <p:spPr>
+          <a:xfrm>
+            <a:off x="4206240" y="1234440"/>
+            <a:ext cx="3657600" cy="320040"/>
+          </a:xfrm>
+          <a:prstGeom prst="rect">
+            <a:avLst/>
+          </a:prstGeom>
+          <a:noFill/>
+          <a:ln/>
+        </p:spPr>
+        <p:txBody>
+          <a:bodyPr wrap="square" lIns="0" tIns="0" rIns="0" bIns="0" rtlCol="0" anchor="ctr"/>
+          <a:lstStyle/>
+          <a:p>
+            <a:pPr indent="0" marL="0">
+              <a:buNone/>
+            </a:pPr>
+            <a:r>
+              <a:rPr lang="en-US" sz="1600" b="1" dirty="0">
+                <a:solidFill>
+                  <a:srgbClr val="12304A"/>
+                </a:solidFill>
+                <a:latin typeface="Calibri" pitchFamily="34" charset="0"/>
+                <a:ea typeface="Calibri" pitchFamily="34" charset="-122"/>
+                <a:cs typeface="Calibri" pitchFamily="34" charset="-120"/>
+              </a:rPr>
+              <a:t>Products</a:t>
+            </a:r>
+            <a:endParaRPr lang="en-US" sz="1600" dirty="0"/>
+          </a:p>
+        </p:txBody>
+      </p:sp>
+      <p:pic>
+        <p:nvPicPr>
+          <p:cNvPr id="6" name="Image 1" descr="/tmp/claude-0/-home-user-EXACOUNT/b3a0efd5-5ef2-5930-a9ef-1d7b86874e77/images/95.png">    </p:cNvPr>
+          <p:cNvPicPr>
+            <a:picLocks noChangeAspect="1"/>
+          </p:cNvPicPr>
+          <p:nvPr/>
+        </p:nvPicPr>
+        <p:blipFill>
+          <a:blip r:embed="rId2"/>
+          <a:stretch>
+            <a:fillRect/>
+          </a:stretch>
+        </p:blipFill>
+        <p:spPr>
+          <a:xfrm>
+            <a:off x="4206240" y="1600200"/>
+            <a:ext cx="3657600" cy="1920240"/>
+          </a:xfrm>
+          <a:prstGeom prst="rect">
+            <a:avLst/>
+          </a:prstGeom>
+        </p:spPr>
+      </p:pic>
+      <p:sp>
+        <p:nvSpPr>
+          <p:cNvPr id="7" name="Text 3"/>
+          <p:cNvSpPr txBox="1"/>
+          <p:nvPr/>
+        </p:nvSpPr>
+        <p:spPr>
+          <a:xfrm>
+            <a:off x="7863840" y="1234440"/>
+            <a:ext cx="3657600" cy="320040"/>
+          </a:xfrm>
+          <a:prstGeom prst="rect">
+            <a:avLst/>
+          </a:prstGeom>
+          <a:noFill/>
+          <a:ln/>
+        </p:spPr>
+        <p:txBody>
+          <a:bodyPr wrap="square" lIns="0" tIns="0" rIns="0" bIns="0" rtlCol="0" anchor="ctr"/>
+          <a:lstStyle/>
+          <a:p>
+            <a:pPr indent="0" marL="0">
+              <a:buNone/>
+            </a:pPr>
+            <a:r>
+              <a:rPr lang="en-US" sz="1600" b="1" dirty="0">
+                <a:solidFill>
+                  <a:srgbClr val="12304A"/>
+                </a:solidFill>
+                <a:latin typeface="Calibri" pitchFamily="34" charset="0"/>
+                <a:ea typeface="Calibri" pitchFamily="34" charset="-122"/>
+                <a:cs typeface="Calibri" pitchFamily="34" charset="-120"/>
+              </a:rPr>
+              <a:t>Transactions</a:t>
+            </a:r>
+            <a:endParaRPr lang="en-US" sz="1600" dirty="0"/>
+          </a:p>
+        </p:txBody>
+      </p:sp>
+      <p:pic>
+        <p:nvPicPr>
+          <p:cNvPr id="8" name="Image 2" descr="/tmp/claude-0/-home-user-EXACOUNT/b3a0efd5-5ef2-5930-a9ef-1d7b86874e77/images/96.png">    </p:cNvPr>
+          <p:cNvPicPr>
+            <a:picLocks noChangeAspect="1"/>
+          </p:cNvPicPr>
+          <p:nvPr/>
+        </p:nvPicPr>
+        <p:blipFill>
+          <a:blip r:embed="rId3"/>
+          <a:stretch>
+            <a:fillRect/>
+          </a:stretch>
+        </p:blipFill>
+        <p:spPr>
+          <a:xfrm>
+            <a:off x="7863840" y="1600200"/>
+            <a:ext cx="3657600" cy="1920240"/>
+          </a:xfrm>
+          <a:prstGeom prst="rect">
+            <a:avLst/>
+          </a:prstGeom>
+        </p:spPr>
+      </p:pic>
+      <p:sp>
+        <p:nvSpPr>
+          <p:cNvPr id="9" name="Shape 4"/>
           <p:cNvSpPr/>
           <p:nvPr/>
         </p:nvSpPr>
         <p:spPr>
           <a:xfrm>
-            <a:off x="548640" y="3657600"/>
-            <a:ext cx="11064240" cy="2377440"/>
+            <a:off x="548640" y="3749040"/>
+            <a:ext cx="11064240" cy="2286000"/>
           </a:xfrm>
           <a:prstGeom prst="roundRect">
             <a:avLst>
-              <a:gd name="adj" fmla="val 4615"/>
+              <a:gd name="adj" fmla="val 4800"/>
             </a:avLst>
           </a:prstGeom>
           <a:solidFill>
@@ -15421,13 +15586,13 @@
       </p:sp>
       <p:sp>
         <p:nvSpPr>
-          <p:cNvPr id="5" name="Text 2"/>
+          <p:cNvPr id="10" name="Text 5"/>
           <p:cNvSpPr txBox="1"/>
           <p:nvPr/>
         </p:nvSpPr>
         <p:spPr>
           <a:xfrm>
-            <a:off x="777240" y="3840480"/>
+            <a:off x="777240" y="3931920"/>
             <a:ext cx="10607040" cy="457200"/>
           </a:xfrm>
           <a:prstGeom prst="rect">
@@ -15460,14 +15625,14 @@
       </p:sp>
       <p:sp>
         <p:nvSpPr>
-          <p:cNvPr id="6" name="Text 3"/>
+          <p:cNvPr id="11" name="Text 6"/>
           <p:cNvSpPr txBox="1"/>
           <p:nvPr/>
         </p:nvSpPr>
         <p:spPr>
           <a:xfrm>
-            <a:off x="777240" y="4343400"/>
-            <a:ext cx="10607040" cy="1508760"/>
+            <a:off x="777240" y="4434840"/>
+            <a:ext cx="10607040" cy="1417320"/>
           </a:xfrm>
           <a:prstGeom prst="rect">
             <a:avLst/>
@@ -15491,112 +15656,7 @@
                 <a:ea typeface="Calibri" pitchFamily="34" charset="-122"/>
                 <a:cs typeface="Calibri" pitchFamily="34" charset="-120"/>
               </a:rPr>
-              <a:t>Source: membuka berkas Excel. Navigation: memilih sheet. Promoted Headers: baris pertama menjadi nama kolom. Changed Type: ID menjadi teks, tanggal menjadi date atau datetime, Quantity bilangan bulat, harga dan nilai desimal. Profil kualitas: Valid 100%, Error 0%, Empty 0%.</a:t>
-            </a:r>
-            <a:endParaRPr lang="en-US" sz="1600" dirty="0"/>
-          </a:p>
-        </p:txBody>
-      </p:sp>
-      <p:sp>
-        <p:nvSpPr>
-          <p:cNvPr id="7" name="Shape 4"/>
-          <p:cNvSpPr/>
-          <p:nvPr/>
-        </p:nvSpPr>
-        <p:spPr>
-          <a:xfrm>
-            <a:off x="8229600" y="1371600"/>
-            <a:ext cx="3383280" cy="2103120"/>
-          </a:xfrm>
-          <a:prstGeom prst="roundRect">
-            <a:avLst>
-              <a:gd name="adj" fmla="val 5217"/>
-            </a:avLst>
-          </a:prstGeom>
-          <a:solidFill>
-            <a:srgbClr val="F3F6F8"/>
-          </a:solidFill>
-          <a:ln w="12700">
-            <a:solidFill>
-              <a:srgbClr val="F3F6F8"/>
-            </a:solidFill>
-            <a:prstDash val="solid"/>
-          </a:ln>
-        </p:spPr>
-      </p:sp>
-      <p:sp>
-        <p:nvSpPr>
-          <p:cNvPr id="8" name="Text 5"/>
-          <p:cNvSpPr txBox="1"/>
-          <p:nvPr/>
-        </p:nvSpPr>
-        <p:spPr>
-          <a:xfrm>
-            <a:off x="8458200" y="1554480"/>
-            <a:ext cx="2926080" cy="457200"/>
-          </a:xfrm>
-          <a:prstGeom prst="rect">
-            <a:avLst/>
-          </a:prstGeom>
-          <a:noFill/>
-          <a:ln/>
-        </p:spPr>
-        <p:txBody>
-          <a:bodyPr wrap="square" lIns="0" tIns="0" rIns="0" bIns="0" rtlCol="0" anchor="ctr"/>
-          <a:lstStyle/>
-          <a:p>
-            <a:pPr indent="0" marL="0">
-              <a:buNone/>
-            </a:pPr>
-            <a:r>
-              <a:rPr lang="en-US" sz="2000" b="1" dirty="0">
-                <a:solidFill>
-                  <a:srgbClr val="12304A"/>
-                </a:solidFill>
-                <a:latin typeface="Cambria" pitchFamily="34" charset="0"/>
-                <a:ea typeface="Cambria" pitchFamily="34" charset="-122"/>
-                <a:cs typeface="Cambria" pitchFamily="34" charset="-120"/>
-              </a:rPr>
-              <a:t>Hasil</a:t>
-            </a:r>
-            <a:endParaRPr lang="en-US" sz="2000" dirty="0"/>
-          </a:p>
-        </p:txBody>
-      </p:sp>
-      <p:sp>
-        <p:nvSpPr>
-          <p:cNvPr id="9" name="Text 6"/>
-          <p:cNvSpPr txBox="1"/>
-          <p:nvPr/>
-        </p:nvSpPr>
-        <p:spPr>
-          <a:xfrm>
-            <a:off x="8458200" y="2057400"/>
-            <a:ext cx="2926080" cy="1234440"/>
-          </a:xfrm>
-          <a:prstGeom prst="rect">
-            <a:avLst/>
-          </a:prstGeom>
-          <a:noFill/>
-          <a:ln/>
-        </p:spPr>
-        <p:txBody>
-          <a:bodyPr wrap="square" lIns="0" tIns="0" rIns="0" bIns="0" rtlCol="0" anchor="t"/>
-          <a:lstStyle/>
-          <a:p>
-            <a:pPr indent="0" marL="0">
-              <a:buNone/>
-            </a:pPr>
-            <a:r>
-              <a:rPr lang="en-US" sz="1600" dirty="0">
-                <a:solidFill>
-                  <a:srgbClr val="1E2A35"/>
-                </a:solidFill>
-                <a:latin typeface="Calibri" pitchFamily="34" charset="0"/>
-                <a:ea typeface="Calibri" pitchFamily="34" charset="-122"/>
-                <a:cs typeface="Calibri" pitchFamily="34" charset="-120"/>
-              </a:rPr>
-              <a:t>4 langkah, tanpa error dan tanpa nilai kosong.</a:t>
+              <a:t>Source: membuka berkas Excel. Navigation: memilih sheet. Promoted Headers: baris pertama menjadi nama kolom. Changed Type: ID menjadi teks, tanggal menjadi date atau datetime, Quantity bilangan bulat, harga dan nilai desimal. Profil kualitas ketiga tabel: Valid 100%, Error 0%, Empty 0%.</a:t>
             </a:r>
             <a:endParaRPr lang="en-US" sz="1600" dirty="0"/>
           </a:p>

</xml_diff>

<commit_message>
Align dashboard slide text with actual pbix (no slicers on Revenue Report)
Co-Authored-By: Claude Sonnet 5.5 <noreply@anthropic.com>
Claude-Session: https://claude.ai/code/session_017RLvirTSx84UWnroqbbqTM
</commit_message>
<xml_diff>
--- a/output/EverMart_UTS_BDASC.pptx
+++ b/output/EverMart_UTS_BDASC.pptx
@@ -23010,7 +23010,7 @@
                 <a:ea typeface="Calibri" pitchFamily="34" charset="-122"/>
                 <a:cs typeface="Calibri" pitchFamily="34" charset="-120"/>
               </a:rPr>
-              <a:t>Menjawab: kapan, produk apa, dan kategori apa yang paling menghasilkan. Isinya grafik garis revenue per bulan, bar chart per produk, dan donut per kategori. Slicer Year dan Region menyaring seluruh visual.</a:t>
+              <a:t>Menjawab: kapan, produk apa, dan kategori apa yang paling menghasilkan. Isinya grafik garis revenue per bulan, bar chart per produk, dan donut per kategori. Klik pada grafik menyaring visual lainnya (cross-filtering).</a:t>
             </a:r>
             <a:endParaRPr lang="en-US" sz="1500" dirty="0"/>
           </a:p>
@@ -23883,7 +23883,7 @@
                 <a:ea typeface="Calibri" pitchFamily="34" charset="-122"/>
                 <a:cs typeface="Calibri" pitchFamily="34" charset="-120"/>
               </a:rPr>
-              <a:t>Grafik garis Total Revenue by Month: puncak Juli, dasar November.</a:t>
+              <a:t>Grafik garis Total Revenue by Month (hanya tahun 2024): puncak Juli, dasar November.</a:t>
             </a:r>
             <a:endParaRPr lang="en-US" sz="1300" dirty="0"/>
           </a:p>
@@ -23946,7 +23946,7 @@
                 <a:ea typeface="Calibri" pitchFamily="34" charset="-122"/>
                 <a:cs typeface="Calibri" pitchFamily="34" charset="-120"/>
               </a:rPr>
-              <a:t>Slicer Year dan Region menyaring semua visual.</a:t>
+              <a:t>Halaman ini tidak memakai slicer; interaktivitas lewat klik pada grafik.</a:t>
             </a:r>
             <a:endParaRPr lang="en-US" sz="1300" dirty="0"/>
           </a:p>
@@ -23967,7 +23967,7 @@
                 <a:ea typeface="Calibri" pitchFamily="34" charset="-122"/>
                 <a:cs typeface="Calibri" pitchFamily="34" charset="-120"/>
               </a:rPr>
-              <a:t>Klik satu titik atau batang untuk menyaring visual lain (cross-filtering).</a:t>
+              <a:t>Klik satu titik, batang, atau irisan untuk menyaring visual lain (cross-filtering).</a:t>
             </a:r>
             <a:endParaRPr lang="en-US" sz="1300" dirty="0"/>
           </a:p>

</xml_diff>

<commit_message>
Slide 4: table with description column and explanation below
Co-Authored-By: Claude Sonnet 5.5 <noreply@anthropic.com>
Claude-Session: https://claude.ai/code/session_017RLvirTSx84UWnroqbbqTM
</commit_message>
<xml_diff>
--- a/output/EverMart_UTS_BDASC.pptx
+++ b/output/EverMart_UTS_BDASC.pptx
@@ -4506,7 +4506,7 @@
           <a:p>
             <a:r>
               <a:rPr lang="en-US" dirty="0"/>
-              <a:t>Dataset terdiri dari 3 tabel dan 15 kolom. Karena CustomerID, ProductID, dan Price muncul di dua tabel, variabel unik berjumlah 12. Ada 1.000 transaksi pada periode 30 Desember 2023 sampai 28 Desember 2024.</a:t>
+              <a:t>Dataset terdiri dari 3 tabel dan 15 kolom. Karena CustomerID, ProductID, dan Price muncul di dua tabel, variabel unik berjumlah 12. Ada 1.000 transaksi pada periode 30 Desember 2023 sampai 28 Desember 2024. Pelanggan: 200 terdaftar, 199 bertransaksi, 1 belum (C0180).</a:t>
             </a:r>
             <a:endParaRPr lang="en-US" dirty="0"/>
           </a:p>
@@ -33478,18 +33478,19 @@
             <a:tbl>
               <a:tblPr/>
               <a:tblGrid>
-                <a:gridCol w="1828800"/>
-                <a:gridCol w="1554480"/>
-                <a:gridCol w="1554480"/>
-                <a:gridCol w="6126480"/>
+                <a:gridCol w="1463040"/>
+                <a:gridCol w="1097280"/>
+                <a:gridCol w="1188720"/>
+                <a:gridCol w="3657600"/>
+                <a:gridCol w="3657600"/>
               </a:tblGrid>
-              <a:tr h="502920">
+              <a:tr h="566928">
                 <a:tc>
                   <a:txBody>
                     <a:bodyPr/>
                     <a:lstStyle/>
                     <a:p>
-                      <a:pPr indent="0" marL="0">
+                      <a:pPr algn="l" indent="0" marL="0">
                         <a:buNone/>
                       </a:pPr>
                       <a:r>
@@ -33557,7 +33558,7 @@
                     <a:bodyPr/>
                     <a:lstStyle/>
                     <a:p>
-                      <a:pPr indent="0" marL="0">
+                      <a:pPr algn="l" indent="0" marL="0">
                         <a:buNone/>
                       </a:pPr>
                       <a:r>
@@ -33625,7 +33626,7 @@
                     <a:bodyPr/>
                     <a:lstStyle/>
                     <a:p>
-                      <a:pPr indent="0" marL="0">
+                      <a:pPr algn="l" indent="0" marL="0">
                         <a:buNone/>
                       </a:pPr>
                       <a:r>
@@ -33693,7 +33694,7 @@
                     <a:bodyPr/>
                     <a:lstStyle/>
                     <a:p>
-                      <a:pPr indent="0" marL="0">
+                      <a:pPr algn="l" indent="0" marL="0">
                         <a:buNone/>
                       </a:pPr>
                       <a:r>
@@ -33756,18 +33757,86 @@
                     </a:solidFill>
                   </a:tcPr>
                 </a:tc>
-              </a:tr>
-              <a:tr h="502920">
                 <a:tc>
                   <a:txBody>
                     <a:bodyPr/>
                     <a:lstStyle/>
                     <a:p>
-                      <a:pPr indent="0" marL="0">
+                      <a:pPr algn="l" indent="0" marL="0">
                         <a:buNone/>
                       </a:pPr>
                       <a:r>
-                        <a:rPr lang="en-US" sz="1300" dirty="0">
+                        <a:rPr lang="en-US" sz="1300" b="1" dirty="0">
+                          <a:solidFill>
+                            <a:srgbClr val="FFFFFF"/>
+                          </a:solidFill>
+                          <a:latin typeface="Calibri" pitchFamily="34" charset="0"/>
+                          <a:ea typeface="Calibri" pitchFamily="34" charset="-122"/>
+                          <a:cs typeface="Calibri" pitchFamily="34" charset="-120"/>
+                        </a:rPr>
+                        <a:t>Keterangan</a:t>
+                      </a:r>
+                      <a:endParaRPr lang="en-US" sz="1300" dirty="0">
+                        <a:latin typeface="Calibri" charset="0"/>
+                        <a:ea typeface="Calibri" charset="0"/>
+                        <a:cs typeface="Calibri" charset="0"/>
+                      </a:endParaRPr>
+                    </a:p>
+                  </a:txBody>
+                  <a:tcPr marL="91440" marR="91440" marT="45720" marB="45720" anchor="ctr">
+                    <a:lnL w="9525" cap="flat" cmpd="sng" algn="ctr">
+                      <a:solidFill>
+                        <a:srgbClr val="D5DDE3"/>
+                      </a:solidFill>
+                      <a:prstDash val="solid"/>
+                      <a:round/>
+                      <a:headEnd type="none" w="med" len="med"/>
+                      <a:tailEnd type="none" w="med" len="med"/>
+                    </a:lnL>
+                    <a:lnR w="9525" cap="flat" cmpd="sng" algn="ctr">
+                      <a:solidFill>
+                        <a:srgbClr val="D5DDE3"/>
+                      </a:solidFill>
+                      <a:prstDash val="solid"/>
+                      <a:round/>
+                      <a:headEnd type="none" w="med" len="med"/>
+                      <a:tailEnd type="none" w="med" len="med"/>
+                    </a:lnR>
+                    <a:lnT w="9525" cap="flat" cmpd="sng" algn="ctr">
+                      <a:solidFill>
+                        <a:srgbClr val="D5DDE3"/>
+                      </a:solidFill>
+                      <a:prstDash val="solid"/>
+                      <a:round/>
+                      <a:headEnd type="none" w="med" len="med"/>
+                      <a:tailEnd type="none" w="med" len="med"/>
+                    </a:lnT>
+                    <a:lnB w="9525" cap="flat" cmpd="sng" algn="ctr">
+                      <a:solidFill>
+                        <a:srgbClr val="D5DDE3"/>
+                      </a:solidFill>
+                      <a:prstDash val="solid"/>
+                      <a:round/>
+                      <a:headEnd type="none" w="med" len="med"/>
+                      <a:tailEnd type="none" w="med" len="med"/>
+                    </a:lnB>
+                    <a:solidFill>
+                      <a:srgbClr val="1B9AAA"/>
+                    </a:solidFill>
+                  </a:tcPr>
+                </a:tc>
+              </a:tr>
+              <a:tr h="566928">
+                <a:tc>
+                  <a:txBody>
+                    <a:bodyPr/>
+                    <a:lstStyle/>
+                    <a:p>
+                      <a:pPr algn="l" indent="0" marL="0">
+                        <a:buNone/>
+                      </a:pPr>
+                      <a:r>
+                        <a:rPr lang="en-US" sz="1300" b="1" dirty="0">
                           <a:solidFill>
                             <a:srgbClr val="1E2A35"/>
                           </a:solidFill>
@@ -33828,7 +33897,7 @@
                     <a:bodyPr/>
                     <a:lstStyle/>
                     <a:p>
-                      <a:pPr indent="0" marL="0">
+                      <a:pPr algn="l" indent="0" marL="0">
                         <a:buNone/>
                       </a:pPr>
                       <a:r>
@@ -33893,7 +33962,7 @@
                     <a:bodyPr/>
                     <a:lstStyle/>
                     <a:p>
-                      <a:pPr indent="0" marL="0">
+                      <a:pPr algn="l" indent="0" marL="0">
                         <a:buNone/>
                       </a:pPr>
                       <a:r>
@@ -33958,7 +34027,7 @@
                     <a:bodyPr/>
                     <a:lstStyle/>
                     <a:p>
-                      <a:pPr indent="0" marL="0">
+                      <a:pPr algn="l" indent="0" marL="0">
                         <a:buNone/>
                       </a:pPr>
                       <a:r>
@@ -34018,18 +34087,83 @@
                     </a:lnB>
                   </a:tcPr>
                 </a:tc>
-              </a:tr>
-              <a:tr h="502920">
                 <a:tc>
                   <a:txBody>
                     <a:bodyPr/>
                     <a:lstStyle/>
                     <a:p>
-                      <a:pPr indent="0" marL="0">
+                      <a:pPr algn="l" indent="0" marL="0">
                         <a:buNone/>
                       </a:pPr>
                       <a:r>
                         <a:rPr lang="en-US" sz="1300" dirty="0">
+                          <a:solidFill>
+                            <a:srgbClr val="1E2A35"/>
+                          </a:solidFill>
+                          <a:latin typeface="Calibri" pitchFamily="34" charset="0"/>
+                          <a:ea typeface="Calibri" pitchFamily="34" charset="-122"/>
+                          <a:cs typeface="Calibri" pitchFamily="34" charset="-120"/>
+                        </a:rPr>
+                        <a:t>Data pelanggan: 200 terdaftar, 199 bertransaksi, 1 belum bertransaksi</a:t>
+                      </a:r>
+                      <a:endParaRPr lang="en-US" sz="1300" dirty="0">
+                        <a:latin typeface="Calibri" charset="0"/>
+                        <a:ea typeface="Calibri" charset="0"/>
+                        <a:cs typeface="Calibri" charset="0"/>
+                      </a:endParaRPr>
+                    </a:p>
+                  </a:txBody>
+                  <a:tcPr marL="91440" marR="91440" marT="45720" marB="45720" anchor="ctr">
+                    <a:lnL w="9525" cap="flat" cmpd="sng" algn="ctr">
+                      <a:solidFill>
+                        <a:srgbClr val="D5DDE3"/>
+                      </a:solidFill>
+                      <a:prstDash val="solid"/>
+                      <a:round/>
+                      <a:headEnd type="none" w="med" len="med"/>
+                      <a:tailEnd type="none" w="med" len="med"/>
+                    </a:lnL>
+                    <a:lnR w="9525" cap="flat" cmpd="sng" algn="ctr">
+                      <a:solidFill>
+                        <a:srgbClr val="D5DDE3"/>
+                      </a:solidFill>
+                      <a:prstDash val="solid"/>
+                      <a:round/>
+                      <a:headEnd type="none" w="med" len="med"/>
+                      <a:tailEnd type="none" w="med" len="med"/>
+                    </a:lnR>
+                    <a:lnT w="9525" cap="flat" cmpd="sng" algn="ctr">
+                      <a:solidFill>
+                        <a:srgbClr val="D5DDE3"/>
+                      </a:solidFill>
+                      <a:prstDash val="solid"/>
+                      <a:round/>
+                      <a:headEnd type="none" w="med" len="med"/>
+                      <a:tailEnd type="none" w="med" len="med"/>
+                    </a:lnT>
+                    <a:lnB w="9525" cap="flat" cmpd="sng" algn="ctr">
+                      <a:solidFill>
+                        <a:srgbClr val="D5DDE3"/>
+                      </a:solidFill>
+                      <a:prstDash val="solid"/>
+                      <a:round/>
+                      <a:headEnd type="none" w="med" len="med"/>
+                      <a:tailEnd type="none" w="med" len="med"/>
+                    </a:lnB>
+                  </a:tcPr>
+                </a:tc>
+              </a:tr>
+              <a:tr h="566928">
+                <a:tc>
+                  <a:txBody>
+                    <a:bodyPr/>
+                    <a:lstStyle/>
+                    <a:p>
+                      <a:pPr algn="l" indent="0" marL="0">
+                        <a:buNone/>
+                      </a:pPr>
+                      <a:r>
+                        <a:rPr lang="en-US" sz="1300" b="1" dirty="0">
                           <a:solidFill>
                             <a:srgbClr val="1E2A35"/>
                           </a:solidFill>
@@ -34090,7 +34224,7 @@
                     <a:bodyPr/>
                     <a:lstStyle/>
                     <a:p>
-                      <a:pPr indent="0" marL="0">
+                      <a:pPr algn="l" indent="0" marL="0">
                         <a:buNone/>
                       </a:pPr>
                       <a:r>
@@ -34155,7 +34289,7 @@
                     <a:bodyPr/>
                     <a:lstStyle/>
                     <a:p>
-                      <a:pPr indent="0" marL="0">
+                      <a:pPr algn="l" indent="0" marL="0">
                         <a:buNone/>
                       </a:pPr>
                       <a:r>
@@ -34220,7 +34354,7 @@
                     <a:bodyPr/>
                     <a:lstStyle/>
                     <a:p>
-                      <a:pPr indent="0" marL="0">
+                      <a:pPr algn="l" indent="0" marL="0">
                         <a:buNone/>
                       </a:pPr>
                       <a:r>
@@ -34280,18 +34414,83 @@
                     </a:lnB>
                   </a:tcPr>
                 </a:tc>
-              </a:tr>
-              <a:tr h="502920">
                 <a:tc>
                   <a:txBody>
                     <a:bodyPr/>
                     <a:lstStyle/>
                     <a:p>
-                      <a:pPr indent="0" marL="0">
+                      <a:pPr algn="l" indent="0" marL="0">
                         <a:buNone/>
                       </a:pPr>
                       <a:r>
                         <a:rPr lang="en-US" sz="1300" dirty="0">
+                          <a:solidFill>
+                            <a:srgbClr val="1E2A35"/>
+                          </a:solidFill>
+                          <a:latin typeface="Calibri" pitchFamily="34" charset="0"/>
+                          <a:ea typeface="Calibri" pitchFamily="34" charset="-122"/>
+                          <a:cs typeface="Calibri" pitchFamily="34" charset="-120"/>
+                        </a:rPr>
+                        <a:t>Data produk: 100 produk dalam 4 kategori</a:t>
+                      </a:r>
+                      <a:endParaRPr lang="en-US" sz="1300" dirty="0">
+                        <a:latin typeface="Calibri" charset="0"/>
+                        <a:ea typeface="Calibri" charset="0"/>
+                        <a:cs typeface="Calibri" charset="0"/>
+                      </a:endParaRPr>
+                    </a:p>
+                  </a:txBody>
+                  <a:tcPr marL="91440" marR="91440" marT="45720" marB="45720" anchor="ctr">
+                    <a:lnL w="9525" cap="flat" cmpd="sng" algn="ctr">
+                      <a:solidFill>
+                        <a:srgbClr val="D5DDE3"/>
+                      </a:solidFill>
+                      <a:prstDash val="solid"/>
+                      <a:round/>
+                      <a:headEnd type="none" w="med" len="med"/>
+                      <a:tailEnd type="none" w="med" len="med"/>
+                    </a:lnL>
+                    <a:lnR w="9525" cap="flat" cmpd="sng" algn="ctr">
+                      <a:solidFill>
+                        <a:srgbClr val="D5DDE3"/>
+                      </a:solidFill>
+                      <a:prstDash val="solid"/>
+                      <a:round/>
+                      <a:headEnd type="none" w="med" len="med"/>
+                      <a:tailEnd type="none" w="med" len="med"/>
+                    </a:lnR>
+                    <a:lnT w="9525" cap="flat" cmpd="sng" algn="ctr">
+                      <a:solidFill>
+                        <a:srgbClr val="D5DDE3"/>
+                      </a:solidFill>
+                      <a:prstDash val="solid"/>
+                      <a:round/>
+                      <a:headEnd type="none" w="med" len="med"/>
+                      <a:tailEnd type="none" w="med" len="med"/>
+                    </a:lnT>
+                    <a:lnB w="9525" cap="flat" cmpd="sng" algn="ctr">
+                      <a:solidFill>
+                        <a:srgbClr val="D5DDE3"/>
+                      </a:solidFill>
+                      <a:prstDash val="solid"/>
+                      <a:round/>
+                      <a:headEnd type="none" w="med" len="med"/>
+                      <a:tailEnd type="none" w="med" len="med"/>
+                    </a:lnB>
+                  </a:tcPr>
+                </a:tc>
+              </a:tr>
+              <a:tr h="566928">
+                <a:tc>
+                  <a:txBody>
+                    <a:bodyPr/>
+                    <a:lstStyle/>
+                    <a:p>
+                      <a:pPr algn="l" indent="0" marL="0">
+                        <a:buNone/>
+                      </a:pPr>
+                      <a:r>
+                        <a:rPr lang="en-US" sz="1300" b="1" dirty="0">
                           <a:solidFill>
                             <a:srgbClr val="1E2A35"/>
                           </a:solidFill>
@@ -34352,7 +34551,7 @@
                     <a:bodyPr/>
                     <a:lstStyle/>
                     <a:p>
-                      <a:pPr indent="0" marL="0">
+                      <a:pPr algn="l" indent="0" marL="0">
                         <a:buNone/>
                       </a:pPr>
                       <a:r>
@@ -34417,7 +34616,7 @@
                     <a:bodyPr/>
                     <a:lstStyle/>
                     <a:p>
-                      <a:pPr indent="0" marL="0">
+                      <a:pPr algn="l" indent="0" marL="0">
                         <a:buNone/>
                       </a:pPr>
                       <a:r>
@@ -34482,7 +34681,7 @@
                     <a:bodyPr/>
                     <a:lstStyle/>
                     <a:p>
-                      <a:pPr indent="0" marL="0">
+                      <a:pPr algn="l" indent="0" marL="0">
                         <a:buNone/>
                       </a:pPr>
                       <a:r>
@@ -34542,14 +34741,79 @@
                     </a:lnB>
                   </a:tcPr>
                 </a:tc>
-              </a:tr>
-              <a:tr h="502920">
                 <a:tc>
                   <a:txBody>
                     <a:bodyPr/>
                     <a:lstStyle/>
                     <a:p>
-                      <a:pPr indent="0" marL="0">
+                      <a:pPr algn="l" indent="0" marL="0">
+                        <a:buNone/>
+                      </a:pPr>
+                      <a:r>
+                        <a:rPr lang="en-US" sz="1300" dirty="0">
+                          <a:solidFill>
+                            <a:srgbClr val="1E2A35"/>
+                          </a:solidFill>
+                          <a:latin typeface="Calibri" pitchFamily="34" charset="0"/>
+                          <a:ea typeface="Calibri" pitchFamily="34" charset="-122"/>
+                          <a:cs typeface="Calibri" pitchFamily="34" charset="-120"/>
+                        </a:rPr>
+                        <a:t>Tabel fakta: 1.000 transaksi, 30 Des 2023 sampai 28 Des 2024</a:t>
+                      </a:r>
+                      <a:endParaRPr lang="en-US" sz="1300" dirty="0">
+                        <a:latin typeface="Calibri" charset="0"/>
+                        <a:ea typeface="Calibri" charset="0"/>
+                        <a:cs typeface="Calibri" charset="0"/>
+                      </a:endParaRPr>
+                    </a:p>
+                  </a:txBody>
+                  <a:tcPr marL="91440" marR="91440" marT="45720" marB="45720" anchor="ctr">
+                    <a:lnL w="9525" cap="flat" cmpd="sng" algn="ctr">
+                      <a:solidFill>
+                        <a:srgbClr val="D5DDE3"/>
+                      </a:solidFill>
+                      <a:prstDash val="solid"/>
+                      <a:round/>
+                      <a:headEnd type="none" w="med" len="med"/>
+                      <a:tailEnd type="none" w="med" len="med"/>
+                    </a:lnL>
+                    <a:lnR w="9525" cap="flat" cmpd="sng" algn="ctr">
+                      <a:solidFill>
+                        <a:srgbClr val="D5DDE3"/>
+                      </a:solidFill>
+                      <a:prstDash val="solid"/>
+                      <a:round/>
+                      <a:headEnd type="none" w="med" len="med"/>
+                      <a:tailEnd type="none" w="med" len="med"/>
+                    </a:lnR>
+                    <a:lnT w="9525" cap="flat" cmpd="sng" algn="ctr">
+                      <a:solidFill>
+                        <a:srgbClr val="D5DDE3"/>
+                      </a:solidFill>
+                      <a:prstDash val="solid"/>
+                      <a:round/>
+                      <a:headEnd type="none" w="med" len="med"/>
+                      <a:tailEnd type="none" w="med" len="med"/>
+                    </a:lnT>
+                    <a:lnB w="9525" cap="flat" cmpd="sng" algn="ctr">
+                      <a:solidFill>
+                        <a:srgbClr val="D5DDE3"/>
+                      </a:solidFill>
+                      <a:prstDash val="solid"/>
+                      <a:round/>
+                      <a:headEnd type="none" w="med" len="med"/>
+                      <a:tailEnd type="none" w="med" len="med"/>
+                    </a:lnB>
+                  </a:tcPr>
+                </a:tc>
+              </a:tr>
+              <a:tr h="566928">
+                <a:tc>
+                  <a:txBody>
+                    <a:bodyPr/>
+                    <a:lstStyle/>
+                    <a:p>
+                      <a:pPr algn="l" indent="0" marL="0">
                         <a:buNone/>
                       </a:pPr>
                       <a:r>
@@ -34614,7 +34878,7 @@
                     <a:bodyPr/>
                     <a:lstStyle/>
                     <a:p>
-                      <a:pPr indent="0" marL="0">
+                      <a:pPr algn="l" indent="0" marL="0">
                         <a:buNone/>
                       </a:pPr>
                       <a:r>
@@ -34679,7 +34943,7 @@
                     <a:bodyPr/>
                     <a:lstStyle/>
                     <a:p>
-                      <a:pPr indent="0" marL="0">
+                      <a:pPr algn="l" indent="0" marL="0">
                         <a:buNone/>
                       </a:pPr>
                       <a:r>
@@ -34744,7 +35008,7 @@
                     <a:bodyPr/>
                     <a:lstStyle/>
                     <a:p>
-                      <a:pPr indent="0" marL="0">
+                      <a:pPr algn="l" indent="0" marL="0">
                         <a:buNone/>
                       </a:pPr>
                       <a:r>
@@ -34756,7 +35020,7 @@
                           <a:ea typeface="Calibri" pitchFamily="34" charset="-122"/>
                           <a:cs typeface="Calibri" pitchFamily="34" charset="-120"/>
                         </a:rPr>
-                        <a:t>12 variabel unik (CustomerID, ProductID, Price muncul di dua tabel)</a:t>
+                        <a:t>12 variabel unik</a:t>
                       </a:r>
                       <a:endParaRPr lang="en-US" sz="1300" dirty="0">
                         <a:latin typeface="Calibri" charset="0"/>
@@ -34804,6 +35068,71 @@
                     </a:lnB>
                   </a:tcPr>
                 </a:tc>
+                <a:tc>
+                  <a:txBody>
+                    <a:bodyPr/>
+                    <a:lstStyle/>
+                    <a:p>
+                      <a:pPr algn="l" indent="0" marL="0">
+                        <a:buNone/>
+                      </a:pPr>
+                      <a:r>
+                        <a:rPr lang="en-US" sz="1300" b="1" dirty="0">
+                          <a:solidFill>
+                            <a:srgbClr val="1E2A35"/>
+                          </a:solidFill>
+                          <a:latin typeface="Calibri" pitchFamily="34" charset="0"/>
+                          <a:ea typeface="Calibri" pitchFamily="34" charset="-122"/>
+                          <a:cs typeface="Calibri" pitchFamily="34" charset="-120"/>
+                        </a:rPr>
+                        <a:t>3 tabel; CustomerID, ProductID, Price muncul di dua tabel</a:t>
+                      </a:r>
+                      <a:endParaRPr lang="en-US" sz="1300" dirty="0">
+                        <a:latin typeface="Calibri" charset="0"/>
+                        <a:ea typeface="Calibri" charset="0"/>
+                        <a:cs typeface="Calibri" charset="0"/>
+                      </a:endParaRPr>
+                    </a:p>
+                  </a:txBody>
+                  <a:tcPr marL="91440" marR="91440" marT="45720" marB="45720" anchor="ctr">
+                    <a:lnL w="9525" cap="flat" cmpd="sng" algn="ctr">
+                      <a:solidFill>
+                        <a:srgbClr val="D5DDE3"/>
+                      </a:solidFill>
+                      <a:prstDash val="solid"/>
+                      <a:round/>
+                      <a:headEnd type="none" w="med" len="med"/>
+                      <a:tailEnd type="none" w="med" len="med"/>
+                    </a:lnL>
+                    <a:lnR w="9525" cap="flat" cmpd="sng" algn="ctr">
+                      <a:solidFill>
+                        <a:srgbClr val="D5DDE3"/>
+                      </a:solidFill>
+                      <a:prstDash val="solid"/>
+                      <a:round/>
+                      <a:headEnd type="none" w="med" len="med"/>
+                      <a:tailEnd type="none" w="med" len="med"/>
+                    </a:lnR>
+                    <a:lnT w="9525" cap="flat" cmpd="sng" algn="ctr">
+                      <a:solidFill>
+                        <a:srgbClr val="D5DDE3"/>
+                      </a:solidFill>
+                      <a:prstDash val="solid"/>
+                      <a:round/>
+                      <a:headEnd type="none" w="med" len="med"/>
+                      <a:tailEnd type="none" w="med" len="med"/>
+                    </a:lnT>
+                    <a:lnB w="9525" cap="flat" cmpd="sng" algn="ctr">
+                      <a:solidFill>
+                        <a:srgbClr val="D5DDE3"/>
+                      </a:solidFill>
+                      <a:prstDash val="solid"/>
+                      <a:round/>
+                      <a:headEnd type="none" w="med" len="med"/>
+                      <a:tailEnd type="none" w="med" len="med"/>
+                    </a:lnB>
+                  </a:tcPr>
+                </a:tc>
               </a:tr>
             </a:tbl>
           </a:graphicData>
@@ -34811,14 +35140,66 @@
       </p:graphicFrame>
       <p:sp>
         <p:nvSpPr>
-          <p:cNvPr id="12" name="Text 7"/>
+          <p:cNvPr id="12" name="Shape 7"/>
+          <p:cNvSpPr/>
+          <p:nvPr/>
+        </p:nvSpPr>
+        <p:spPr>
+          <a:xfrm>
+            <a:off x="548640" y="4251960"/>
+            <a:ext cx="11064240" cy="2057400"/>
+          </a:xfrm>
+          <a:prstGeom prst="roundRect">
+            <a:avLst>
+              <a:gd name="adj" fmla="val 4444"/>
+            </a:avLst>
+          </a:prstGeom>
+          <a:solidFill>
+            <a:srgbClr val="E8F5F7"/>
+          </a:solidFill>
+          <a:ln w="12700">
+            <a:solidFill>
+              <a:srgbClr val="E8F5F7"/>
+            </a:solidFill>
+            <a:prstDash val="solid"/>
+          </a:ln>
+        </p:spPr>
+      </p:sp>
+      <p:sp>
+        <p:nvSpPr>
+          <p:cNvPr id="13" name="Shape 8"/>
+          <p:cNvSpPr/>
+          <p:nvPr/>
+        </p:nvSpPr>
+        <p:spPr>
+          <a:xfrm>
+            <a:off x="548640" y="4343400"/>
+            <a:ext cx="82296" cy="1874520"/>
+          </a:xfrm>
+          <a:prstGeom prst="rect">
+            <a:avLst/>
+          </a:prstGeom>
+          <a:solidFill>
+            <a:srgbClr val="1B9AAA"/>
+          </a:solidFill>
+          <a:ln w="12700">
+            <a:solidFill>
+              <a:srgbClr val="1B9AAA"/>
+            </a:solidFill>
+            <a:prstDash val="solid"/>
+          </a:ln>
+        </p:spPr>
+      </p:sp>
+      <p:sp>
+        <p:nvSpPr>
+          <p:cNvPr id="14" name="Text 9"/>
           <p:cNvSpPr txBox="1"/>
           <p:nvPr/>
         </p:nvSpPr>
         <p:spPr>
           <a:xfrm>
-            <a:off x="548640" y="4114800"/>
-            <a:ext cx="2103120" cy="731520"/>
+            <a:off x="777240" y="4389120"/>
+            <a:ext cx="10652760" cy="411480"/>
           </a:xfrm>
           <a:prstGeom prst="rect">
             <a:avLst/>
@@ -34834,7 +35215,7 @@
               <a:buNone/>
             </a:pPr>
             <a:r>
-              <a:rPr lang="en-US" sz="4000" b="1" dirty="0">
+              <a:rPr lang="en-US" sz="1700" b="1" dirty="0">
                 <a:solidFill>
                   <a:srgbClr val="1B9AAA"/>
                 </a:solidFill>
@@ -34842,22 +35223,22 @@
                 <a:ea typeface="Cambria" pitchFamily="34" charset="-122"/>
                 <a:cs typeface="Cambria" pitchFamily="34" charset="-120"/>
               </a:rPr>
-              <a:t>15</a:t>
-            </a:r>
-            <a:endParaRPr lang="en-US" sz="4000" dirty="0"/>
+              <a:t>Penjelasan</a:t>
+            </a:r>
+            <a:endParaRPr lang="en-US" sz="1700" dirty="0"/>
           </a:p>
         </p:txBody>
       </p:sp>
       <p:sp>
         <p:nvSpPr>
-          <p:cNvPr id="13" name="Text 8"/>
+          <p:cNvPr id="15" name="Text 10"/>
           <p:cNvSpPr txBox="1"/>
           <p:nvPr/>
         </p:nvSpPr>
         <p:spPr>
           <a:xfrm>
-            <a:off x="548640" y="4846320"/>
-            <a:ext cx="2103120" cy="457200"/>
+            <a:off x="777240" y="4892040"/>
+            <a:ext cx="10652760" cy="1280160"/>
           </a:xfrm>
           <a:prstGeom prst="rect">
             <a:avLst/>
@@ -34869,370 +35250,86 @@
           <a:bodyPr wrap="square" lIns="0" tIns="0" rIns="0" bIns="0" rtlCol="0" anchor="t"/>
           <a:lstStyle/>
           <a:p>
-            <a:pPr indent="0" marL="0">
-              <a:buNone/>
+            <a:pPr marL="177800" indent="-177800">
+              <a:spcAft>
+                <a:spcPts val="600"/>
+              </a:spcAft>
+              <a:buSzPct val="100000"/>
+              <a:buChar char="•"/>
             </a:pPr>
             <a:r>
               <a:rPr lang="en-US" sz="1300" dirty="0">
                 <a:solidFill>
-                  <a:srgbClr val="5B6B79"/>
+                  <a:srgbClr val="1E2A35"/>
                 </a:solidFill>
                 <a:latin typeface="Calibri" pitchFamily="34" charset="0"/>
                 <a:ea typeface="Calibri" pitchFamily="34" charset="-122"/>
                 <a:cs typeface="Calibri" pitchFamily="34" charset="-120"/>
               </a:rPr>
-              <a:t>kolom (12 variabel unik)</a:t>
+              <a:t>Dataset EverMart berbentuk model bintang: Transactions (pusat) terhubung ke Customers lewat CustomerID dan ke Products lewat ProductID.</a:t>
             </a:r>
             <a:endParaRPr lang="en-US" sz="1300" dirty="0"/>
           </a:p>
-        </p:txBody>
-      </p:sp>
-      <p:sp>
-        <p:nvSpPr>
-          <p:cNvPr id="14" name="Text 9"/>
-          <p:cNvSpPr txBox="1"/>
-          <p:nvPr/>
-        </p:nvSpPr>
-        <p:spPr>
-          <a:xfrm>
-            <a:off x="2834640" y="4114800"/>
-            <a:ext cx="2103120" cy="731520"/>
-          </a:xfrm>
-          <a:prstGeom prst="rect">
-            <a:avLst/>
-          </a:prstGeom>
-          <a:noFill/>
-          <a:ln/>
-        </p:spPr>
-        <p:txBody>
-          <a:bodyPr wrap="square" lIns="0" tIns="0" rIns="0" bIns="0" rtlCol="0" anchor="ctr"/>
-          <a:lstStyle/>
-          <a:p>
-            <a:pPr indent="0" marL="0">
-              <a:buNone/>
-            </a:pPr>
-            <a:r>
-              <a:rPr lang="en-US" sz="4000" b="1" dirty="0">
-                <a:solidFill>
-                  <a:srgbClr val="E8832B"/>
-                </a:solidFill>
-                <a:latin typeface="Cambria" pitchFamily="34" charset="0"/>
-                <a:ea typeface="Cambria" pitchFamily="34" charset="-122"/>
-                <a:cs typeface="Cambria" pitchFamily="34" charset="-120"/>
-              </a:rPr>
-              <a:t>1.000</a:t>
-            </a:r>
-            <a:endParaRPr lang="en-US" sz="4000" dirty="0"/>
-          </a:p>
-        </p:txBody>
-      </p:sp>
-      <p:sp>
-        <p:nvSpPr>
-          <p:cNvPr id="15" name="Text 10"/>
-          <p:cNvSpPr txBox="1"/>
-          <p:nvPr/>
-        </p:nvSpPr>
-        <p:spPr>
-          <a:xfrm>
-            <a:off x="2834640" y="4846320"/>
-            <a:ext cx="2103120" cy="457200"/>
-          </a:xfrm>
-          <a:prstGeom prst="rect">
-            <a:avLst/>
-          </a:prstGeom>
-          <a:noFill/>
-          <a:ln/>
-        </p:spPr>
-        <p:txBody>
-          <a:bodyPr wrap="square" lIns="0" tIns="0" rIns="0" bIns="0" rtlCol="0" anchor="t"/>
-          <a:lstStyle/>
-          <a:p>
-            <a:pPr indent="0" marL="0">
-              <a:buNone/>
+          <a:p>
+            <a:pPr marL="177800" indent="-177800">
+              <a:spcAft>
+                <a:spcPts val="600"/>
+              </a:spcAft>
+              <a:buSzPct val="100000"/>
+              <a:buChar char="•"/>
             </a:pPr>
             <a:r>
               <a:rPr lang="en-US" sz="1300" dirty="0">
                 <a:solidFill>
-                  <a:srgbClr val="5B6B79"/>
+                  <a:srgbClr val="1E2A35"/>
                 </a:solidFill>
                 <a:latin typeface="Calibri" pitchFamily="34" charset="0"/>
                 <a:ea typeface="Calibri" pitchFamily="34" charset="-122"/>
                 <a:cs typeface="Calibri" pitchFamily="34" charset="-120"/>
               </a:rPr>
-              <a:t>transaksi</a:t>
+              <a:t>Total 15 kolom (4 + 4 + 7); variabel unik 12 karena CustomerID, ProductID, dan Price muncul di dua tabel.</a:t>
             </a:r>
             <a:endParaRPr lang="en-US" sz="1300" dirty="0"/>
           </a:p>
-        </p:txBody>
-      </p:sp>
-      <p:sp>
-        <p:nvSpPr>
-          <p:cNvPr id="16" name="Text 11"/>
-          <p:cNvSpPr txBox="1"/>
-          <p:nvPr/>
-        </p:nvSpPr>
-        <p:spPr>
-          <a:xfrm>
-            <a:off x="5120640" y="4114800"/>
-            <a:ext cx="2103120" cy="731520"/>
-          </a:xfrm>
-          <a:prstGeom prst="rect">
-            <a:avLst/>
-          </a:prstGeom>
-          <a:noFill/>
-          <a:ln/>
-        </p:spPr>
-        <p:txBody>
-          <a:bodyPr wrap="square" lIns="0" tIns="0" rIns="0" bIns="0" rtlCol="0" anchor="ctr"/>
-          <a:lstStyle/>
-          <a:p>
-            <a:pPr indent="0" marL="0">
-              <a:buNone/>
-            </a:pPr>
-            <a:r>
-              <a:rPr lang="en-US" sz="4000" b="1" dirty="0">
-                <a:solidFill>
-                  <a:srgbClr val="1A0683"/>
-                </a:solidFill>
-                <a:latin typeface="Cambria" pitchFamily="34" charset="0"/>
-                <a:ea typeface="Cambria" pitchFamily="34" charset="-122"/>
-                <a:cs typeface="Cambria" pitchFamily="34" charset="-120"/>
-              </a:rPr>
-              <a:t>200</a:t>
-            </a:r>
-            <a:endParaRPr lang="en-US" sz="4000" dirty="0"/>
-          </a:p>
-        </p:txBody>
-      </p:sp>
-      <p:sp>
-        <p:nvSpPr>
-          <p:cNvPr id="17" name="Text 12"/>
-          <p:cNvSpPr txBox="1"/>
-          <p:nvPr/>
-        </p:nvSpPr>
-        <p:spPr>
-          <a:xfrm>
-            <a:off x="5120640" y="4846320"/>
-            <a:ext cx="2103120" cy="457200"/>
-          </a:xfrm>
-          <a:prstGeom prst="rect">
-            <a:avLst/>
-          </a:prstGeom>
-          <a:noFill/>
-          <a:ln/>
-        </p:spPr>
-        <p:txBody>
-          <a:bodyPr wrap="square" lIns="0" tIns="0" rIns="0" bIns="0" rtlCol="0" anchor="t"/>
-          <a:lstStyle/>
-          <a:p>
-            <a:pPr indent="0" marL="0">
-              <a:buNone/>
+          <a:p>
+            <a:pPr marL="177800" indent="-177800">
+              <a:spcAft>
+                <a:spcPts val="600"/>
+              </a:spcAft>
+              <a:buSzPct val="100000"/>
+              <a:buChar char="•"/>
             </a:pPr>
             <a:r>
               <a:rPr lang="en-US" sz="1300" dirty="0">
                 <a:solidFill>
-                  <a:srgbClr val="5B6B79"/>
+                  <a:srgbClr val="1E2A35"/>
                 </a:solidFill>
                 <a:latin typeface="Calibri" pitchFamily="34" charset="0"/>
                 <a:ea typeface="Calibri" pitchFamily="34" charset="-122"/>
                 <a:cs typeface="Calibri" pitchFamily="34" charset="-120"/>
               </a:rPr>
-              <a:t>pelanggan terdaftar</a:t>
+              <a:t>Pelanggan: 200 terdaftar, 199 bertransaksi, 1 terdaftar tetapi belum bertransaksi (C0180 Amy Carpenter, Asia).</a:t>
             </a:r>
             <a:endParaRPr lang="en-US" sz="1300" dirty="0"/>
           </a:p>
-        </p:txBody>
-      </p:sp>
-      <p:sp>
-        <p:nvSpPr>
-          <p:cNvPr id="18" name="Text 13"/>
-          <p:cNvSpPr txBox="1"/>
-          <p:nvPr/>
-        </p:nvSpPr>
-        <p:spPr>
-          <a:xfrm>
-            <a:off x="7406640" y="4114800"/>
-            <a:ext cx="2103120" cy="731520"/>
-          </a:xfrm>
-          <a:prstGeom prst="rect">
-            <a:avLst/>
-          </a:prstGeom>
-          <a:noFill/>
-          <a:ln/>
-        </p:spPr>
-        <p:txBody>
-          <a:bodyPr wrap="square" lIns="0" tIns="0" rIns="0" bIns="0" rtlCol="0" anchor="ctr"/>
-          <a:lstStyle/>
-          <a:p>
-            <a:pPr indent="0" marL="0">
-              <a:buNone/>
-            </a:pPr>
-            <a:r>
-              <a:rPr lang="en-US" sz="4000" b="1" dirty="0">
-                <a:solidFill>
-                  <a:srgbClr val="1B9AAA"/>
-                </a:solidFill>
-                <a:latin typeface="Cambria" pitchFamily="34" charset="0"/>
-                <a:ea typeface="Cambria" pitchFamily="34" charset="-122"/>
-                <a:cs typeface="Cambria" pitchFamily="34" charset="-120"/>
-              </a:rPr>
-              <a:t>199</a:t>
-            </a:r>
-            <a:endParaRPr lang="en-US" sz="4000" dirty="0"/>
-          </a:p>
-        </p:txBody>
-      </p:sp>
-      <p:sp>
-        <p:nvSpPr>
-          <p:cNvPr id="19" name="Text 14"/>
-          <p:cNvSpPr txBox="1"/>
-          <p:nvPr/>
-        </p:nvSpPr>
-        <p:spPr>
-          <a:xfrm>
-            <a:off x="7406640" y="4846320"/>
-            <a:ext cx="2103120" cy="457200"/>
-          </a:xfrm>
-          <a:prstGeom prst="rect">
-            <a:avLst/>
-          </a:prstGeom>
-          <a:noFill/>
-          <a:ln/>
-        </p:spPr>
-        <p:txBody>
-          <a:bodyPr wrap="square" lIns="0" tIns="0" rIns="0" bIns="0" rtlCol="0" anchor="t"/>
-          <a:lstStyle/>
-          <a:p>
-            <a:pPr indent="0" marL="0">
-              <a:buNone/>
+          <a:p>
+            <a:pPr marL="177800" indent="-177800">
+              <a:spcAft>
+                <a:spcPts val="600"/>
+              </a:spcAft>
+              <a:buSzPct val="100000"/>
+              <a:buChar char="•"/>
             </a:pPr>
             <a:r>
               <a:rPr lang="en-US" sz="1300" dirty="0">
                 <a:solidFill>
-                  <a:srgbClr val="5B6B79"/>
+                  <a:srgbClr val="1E2A35"/>
                 </a:solidFill>
                 <a:latin typeface="Calibri" pitchFamily="34" charset="0"/>
                 <a:ea typeface="Calibri" pitchFamily="34" charset="-122"/>
                 <a:cs typeface="Calibri" pitchFamily="34" charset="-120"/>
               </a:rPr>
-              <a:t>pelanggan bertransaksi</a:t>
-            </a:r>
-            <a:endParaRPr lang="en-US" sz="1300" dirty="0"/>
-          </a:p>
-        </p:txBody>
-      </p:sp>
-      <p:sp>
-        <p:nvSpPr>
-          <p:cNvPr id="20" name="Text 15"/>
-          <p:cNvSpPr txBox="1"/>
-          <p:nvPr/>
-        </p:nvSpPr>
-        <p:spPr>
-          <a:xfrm>
-            <a:off x="9692640" y="4114800"/>
-            <a:ext cx="2103120" cy="731520"/>
-          </a:xfrm>
-          <a:prstGeom prst="rect">
-            <a:avLst/>
-          </a:prstGeom>
-          <a:noFill/>
-          <a:ln/>
-        </p:spPr>
-        <p:txBody>
-          <a:bodyPr wrap="square" lIns="0" tIns="0" rIns="0" bIns="0" rtlCol="0" anchor="ctr"/>
-          <a:lstStyle/>
-          <a:p>
-            <a:pPr indent="0" marL="0">
-              <a:buNone/>
-            </a:pPr>
-            <a:r>
-              <a:rPr lang="en-US" sz="4000" b="1" dirty="0">
-                <a:solidFill>
-                  <a:srgbClr val="E8832B"/>
-                </a:solidFill>
-                <a:latin typeface="Cambria" pitchFamily="34" charset="0"/>
-                <a:ea typeface="Cambria" pitchFamily="34" charset="-122"/>
-                <a:cs typeface="Cambria" pitchFamily="34" charset="-120"/>
-              </a:rPr>
-              <a:t>1</a:t>
-            </a:r>
-            <a:endParaRPr lang="en-US" sz="4000" dirty="0"/>
-          </a:p>
-        </p:txBody>
-      </p:sp>
-      <p:sp>
-        <p:nvSpPr>
-          <p:cNvPr id="21" name="Text 16"/>
-          <p:cNvSpPr txBox="1"/>
-          <p:nvPr/>
-        </p:nvSpPr>
-        <p:spPr>
-          <a:xfrm>
-            <a:off x="9692640" y="4846320"/>
-            <a:ext cx="2103120" cy="457200"/>
-          </a:xfrm>
-          <a:prstGeom prst="rect">
-            <a:avLst/>
-          </a:prstGeom>
-          <a:noFill/>
-          <a:ln/>
-        </p:spPr>
-        <p:txBody>
-          <a:bodyPr wrap="square" lIns="0" tIns="0" rIns="0" bIns="0" rtlCol="0" anchor="t"/>
-          <a:lstStyle/>
-          <a:p>
-            <a:pPr indent="0" marL="0">
-              <a:buNone/>
-            </a:pPr>
-            <a:r>
-              <a:rPr lang="en-US" sz="1300" dirty="0">
-                <a:solidFill>
-                  <a:srgbClr val="5B6B79"/>
-                </a:solidFill>
-                <a:latin typeface="Calibri" pitchFamily="34" charset="0"/>
-                <a:ea typeface="Calibri" pitchFamily="34" charset="-122"/>
-                <a:cs typeface="Calibri" pitchFamily="34" charset="-120"/>
-              </a:rPr>
-              <a:t>terdaftar, belum bertransaksi</a:t>
-            </a:r>
-            <a:endParaRPr lang="en-US" sz="1300" dirty="0"/>
-          </a:p>
-        </p:txBody>
-      </p:sp>
-      <p:sp>
-        <p:nvSpPr>
-          <p:cNvPr id="22" name="Text 17"/>
-          <p:cNvSpPr txBox="1"/>
-          <p:nvPr/>
-        </p:nvSpPr>
-        <p:spPr>
-          <a:xfrm>
-            <a:off x="548640" y="5715000"/>
-            <a:ext cx="11064240" cy="640080"/>
-          </a:xfrm>
-          <a:prstGeom prst="rect">
-            <a:avLst/>
-          </a:prstGeom>
-          <a:noFill/>
-          <a:ln/>
-        </p:spPr>
-        <p:txBody>
-          <a:bodyPr wrap="square" lIns="0" tIns="0" rIns="0" bIns="0" rtlCol="0" anchor="t"/>
-          <a:lstStyle/>
-          <a:p>
-            <a:pPr indent="0" marL="0">
-              <a:buNone/>
-            </a:pPr>
-            <a:r>
-              <a:rPr lang="en-US" sz="1300" dirty="0">
-                <a:solidFill>
-                  <a:srgbClr val="5B6B79"/>
-                </a:solidFill>
-                <a:latin typeface="Calibri" pitchFamily="34" charset="0"/>
-                <a:ea typeface="Calibri" pitchFamily="34" charset="-122"/>
-                <a:cs typeface="Calibri" pitchFamily="34" charset="-120"/>
-              </a:rPr>
-              <a:t>Periode 30 Desember 2023 sampai 28 Desember 2024 (996 dari 1.000 transaksi berada di 2024). Model bintang: Transactions terhubung ke Customers (CustomerID) dan Products (ProductID).</a:t>
+              <a:t>Periode transaksi 30 Desember 2023 sampai 28 Desember 2024; 996 dari 1.000 transaksi berada di tahun 2024.</a:t>
             </a:r>
             <a:endParaRPr lang="en-US" sz="1300" dirty="0"/>
           </a:p>

</xml_diff>

<commit_message>
Slide 20: drawn star-schema diagram of model relationships
Co-Authored-By: Claude Sonnet 5.5 <noreply@anthropic.com>
Claude-Session: https://claude.ai/code/session_017RLvirTSx84UWnroqbbqTM
</commit_message>
<xml_diff>
--- a/output/EverMart_UTS_BDASC.pptx
+++ b/output/EverMart_UTS_BDASC.pptx
@@ -14155,33 +14155,60 @@
         </p:nvSpPr>
         <p:spPr>
           <a:xfrm>
-            <a:off x="548640" y="1280160"/>
-            <a:ext cx="6949440" cy="4114800"/>
-          </a:xfrm>
-          <a:prstGeom prst="rect">
-            <a:avLst/>
+            <a:off x="548640" y="1371600"/>
+            <a:ext cx="2103120" cy="2468880"/>
+          </a:xfrm>
+          <a:prstGeom prst="roundRect">
+            <a:avLst>
+              <a:gd name="adj" fmla="val 4348"/>
+            </a:avLst>
           </a:prstGeom>
           <a:solidFill>
             <a:srgbClr val="FFFFFF"/>
           </a:solidFill>
-          <a:ln w="22225">
+          <a:ln w="31750">
             <a:solidFill>
-              <a:srgbClr val="6A2C9C"/>
+              <a:srgbClr val="1B9AAA"/>
             </a:solidFill>
-            <a:prstDash val="dash"/>
+            <a:prstDash val="solid"/>
           </a:ln>
         </p:spPr>
       </p:sp>
       <p:sp>
         <p:nvSpPr>
-          <p:cNvPr id="12" name="Text 8"/>
+          <p:cNvPr id="12" name="Shape 8"/>
+          <p:cNvSpPr/>
+          <p:nvPr/>
+        </p:nvSpPr>
+        <p:spPr>
+          <a:xfrm>
+            <a:off x="548640" y="1371600"/>
+            <a:ext cx="2103120" cy="502920"/>
+          </a:xfrm>
+          <a:prstGeom prst="rect">
+            <a:avLst/>
+          </a:prstGeom>
+          <a:solidFill>
+            <a:srgbClr val="1B9AAA"/>
+          </a:solidFill>
+          <a:ln w="12700">
+            <a:solidFill>
+              <a:srgbClr val="1B9AAA"/>
+            </a:solidFill>
+            <a:prstDash val="solid"/>
+          </a:ln>
+        </p:spPr>
+      </p:sp>
+      <p:sp>
+        <p:nvSpPr>
+          <p:cNvPr id="13" name="Text 9"/>
           <p:cNvSpPr txBox="1"/>
           <p:nvPr/>
         </p:nvSpPr>
         <p:spPr>
           <a:xfrm>
-            <a:off x="822960" y="1280160"/>
-            <a:ext cx="6400800" cy="4114800"/>
+            <a:off x="548640" y="1371600"/>
+            <a:ext cx="2103120" cy="502920"/>
           </a:xfrm>
           <a:prstGeom prst="rect">
             <a:avLst/>
@@ -14197,64 +14224,696 @@
               <a:buNone/>
             </a:pPr>
             <a:r>
-              <a:rPr lang="en-US" sz="1200" b="1" dirty="0">
-                <a:solidFill>
-                  <a:srgbClr val="6A2C9C"/>
+              <a:rPr lang="en-US" sz="1500" b="1" dirty="0">
+                <a:solidFill>
+                  <a:srgbClr val="FFFFFF"/>
+                </a:solidFill>
+                <a:latin typeface="Cambria" pitchFamily="34" charset="0"/>
+                <a:ea typeface="Cambria" pitchFamily="34" charset="-122"/>
+                <a:cs typeface="Cambria" pitchFamily="34" charset="-120"/>
+              </a:rPr>
+              <a:t>Customers</a:t>
+            </a:r>
+            <a:endParaRPr lang="en-US" sz="1500" dirty="0"/>
+          </a:p>
+        </p:txBody>
+      </p:sp>
+      <p:sp>
+        <p:nvSpPr>
+          <p:cNvPr id="14" name="Text 10"/>
+          <p:cNvSpPr txBox="1"/>
+          <p:nvPr/>
+        </p:nvSpPr>
+        <p:spPr>
+          <a:xfrm>
+            <a:off x="685800" y="1965960"/>
+            <a:ext cx="1828800" cy="1783080"/>
+          </a:xfrm>
+          <a:prstGeom prst="rect">
+            <a:avLst/>
+          </a:prstGeom>
+          <a:noFill/>
+          <a:ln/>
+        </p:spPr>
+        <p:txBody>
+          <a:bodyPr wrap="square" lIns="0" tIns="0" rIns="0" bIns="0" rtlCol="0" anchor="t"/>
+          <a:lstStyle/>
+          <a:p>
+            <a:pPr indent="0" marL="0">
+              <a:buNone/>
+            </a:pPr>
+            <a:r>
+              <a:rPr lang="en-US" sz="1100" dirty="0">
+                <a:solidFill>
+                  <a:srgbClr val="1E2A35"/>
+                </a:solidFill>
+                <a:latin typeface="Courier New" pitchFamily="34" charset="0"/>
+                <a:ea typeface="Courier New" pitchFamily="34" charset="-122"/>
+                <a:cs typeface="Courier New" pitchFamily="34" charset="-120"/>
+              </a:rPr>
+              <a:t>CustomerID (PK)</a:t>
+            </a:r>
+            <a:endParaRPr lang="en-US" sz="1100" dirty="0"/>
+          </a:p>
+          <a:p>
+            <a:pPr indent="0" marL="0">
+              <a:buNone/>
+            </a:pPr>
+            <a:r>
+              <a:rPr lang="en-US" sz="1100" dirty="0">
+                <a:solidFill>
+                  <a:srgbClr val="1E2A35"/>
+                </a:solidFill>
+                <a:latin typeface="Courier New" pitchFamily="34" charset="0"/>
+                <a:ea typeface="Courier New" pitchFamily="34" charset="-122"/>
+                <a:cs typeface="Courier New" pitchFamily="34" charset="-120"/>
+              </a:rPr>
+              <a:t>CustomerName</a:t>
+            </a:r>
+            <a:endParaRPr lang="en-US" sz="1100" dirty="0"/>
+          </a:p>
+          <a:p>
+            <a:pPr indent="0" marL="0">
+              <a:buNone/>
+            </a:pPr>
+            <a:r>
+              <a:rPr lang="en-US" sz="1100" dirty="0">
+                <a:solidFill>
+                  <a:srgbClr val="1E2A35"/>
+                </a:solidFill>
+                <a:latin typeface="Courier New" pitchFamily="34" charset="0"/>
+                <a:ea typeface="Courier New" pitchFamily="34" charset="-122"/>
+                <a:cs typeface="Courier New" pitchFamily="34" charset="-120"/>
+              </a:rPr>
+              <a:t>Region</a:t>
+            </a:r>
+            <a:endParaRPr lang="en-US" sz="1100" dirty="0"/>
+          </a:p>
+          <a:p>
+            <a:pPr indent="0" marL="0">
+              <a:buNone/>
+            </a:pPr>
+            <a:r>
+              <a:rPr lang="en-US" sz="1100" dirty="0">
+                <a:solidFill>
+                  <a:srgbClr val="1E2A35"/>
+                </a:solidFill>
+                <a:latin typeface="Courier New" pitchFamily="34" charset="0"/>
+                <a:ea typeface="Courier New" pitchFamily="34" charset="-122"/>
+                <a:cs typeface="Courier New" pitchFamily="34" charset="-120"/>
+              </a:rPr>
+              <a:t>SignupDate</a:t>
+            </a:r>
+            <a:endParaRPr lang="en-US" sz="1100" dirty="0"/>
+          </a:p>
+        </p:txBody>
+      </p:sp>
+      <p:sp>
+        <p:nvSpPr>
+          <p:cNvPr id="15" name="Shape 11"/>
+          <p:cNvSpPr/>
+          <p:nvPr/>
+        </p:nvSpPr>
+        <p:spPr>
+          <a:xfrm>
+            <a:off x="3246120" y="1371600"/>
+            <a:ext cx="2286000" cy="3200400"/>
+          </a:xfrm>
+          <a:prstGeom prst="roundRect">
+            <a:avLst>
+              <a:gd name="adj" fmla="val 4000"/>
+            </a:avLst>
+          </a:prstGeom>
+          <a:solidFill>
+            <a:srgbClr val="FFFFFF"/>
+          </a:solidFill>
+          <a:ln w="31750">
+            <a:solidFill>
+              <a:srgbClr val="1A0683"/>
+            </a:solidFill>
+            <a:prstDash val="solid"/>
+          </a:ln>
+        </p:spPr>
+      </p:sp>
+      <p:sp>
+        <p:nvSpPr>
+          <p:cNvPr id="16" name="Shape 12"/>
+          <p:cNvSpPr/>
+          <p:nvPr/>
+        </p:nvSpPr>
+        <p:spPr>
+          <a:xfrm>
+            <a:off x="3246120" y="1371600"/>
+            <a:ext cx="2286000" cy="502920"/>
+          </a:xfrm>
+          <a:prstGeom prst="rect">
+            <a:avLst/>
+          </a:prstGeom>
+          <a:solidFill>
+            <a:srgbClr val="1A0683"/>
+          </a:solidFill>
+          <a:ln w="12700">
+            <a:solidFill>
+              <a:srgbClr val="1A0683"/>
+            </a:solidFill>
+            <a:prstDash val="solid"/>
+          </a:ln>
+        </p:spPr>
+      </p:sp>
+      <p:sp>
+        <p:nvSpPr>
+          <p:cNvPr id="17" name="Text 13"/>
+          <p:cNvSpPr txBox="1"/>
+          <p:nvPr/>
+        </p:nvSpPr>
+        <p:spPr>
+          <a:xfrm>
+            <a:off x="3246120" y="1371600"/>
+            <a:ext cx="2286000" cy="502920"/>
+          </a:xfrm>
+          <a:prstGeom prst="rect">
+            <a:avLst/>
+          </a:prstGeom>
+          <a:noFill/>
+          <a:ln/>
+        </p:spPr>
+        <p:txBody>
+          <a:bodyPr wrap="square" lIns="0" tIns="0" rIns="0" bIns="0" rtlCol="0" anchor="ctr"/>
+          <a:lstStyle/>
+          <a:p>
+            <a:pPr algn="ctr" indent="0" marL="0">
+              <a:buNone/>
+            </a:pPr>
+            <a:r>
+              <a:rPr lang="en-US" sz="1500" b="1" dirty="0">
+                <a:solidFill>
+                  <a:srgbClr val="FFFFFF"/>
+                </a:solidFill>
+                <a:latin typeface="Cambria" pitchFamily="34" charset="0"/>
+                <a:ea typeface="Cambria" pitchFamily="34" charset="-122"/>
+                <a:cs typeface="Cambria" pitchFamily="34" charset="-120"/>
+              </a:rPr>
+              <a:t>Transactions</a:t>
+            </a:r>
+            <a:endParaRPr lang="en-US" sz="1500" dirty="0"/>
+          </a:p>
+        </p:txBody>
+      </p:sp>
+      <p:sp>
+        <p:nvSpPr>
+          <p:cNvPr id="18" name="Text 14"/>
+          <p:cNvSpPr txBox="1"/>
+          <p:nvPr/>
+        </p:nvSpPr>
+        <p:spPr>
+          <a:xfrm>
+            <a:off x="3383280" y="1965960"/>
+            <a:ext cx="2011680" cy="2514600"/>
+          </a:xfrm>
+          <a:prstGeom prst="rect">
+            <a:avLst/>
+          </a:prstGeom>
+          <a:noFill/>
+          <a:ln/>
+        </p:spPr>
+        <p:txBody>
+          <a:bodyPr wrap="square" lIns="0" tIns="0" rIns="0" bIns="0" rtlCol="0" anchor="t"/>
+          <a:lstStyle/>
+          <a:p>
+            <a:pPr indent="0" marL="0">
+              <a:buNone/>
+            </a:pPr>
+            <a:r>
+              <a:rPr lang="en-US" sz="1100" dirty="0">
+                <a:solidFill>
+                  <a:srgbClr val="1E2A35"/>
+                </a:solidFill>
+                <a:latin typeface="Courier New" pitchFamily="34" charset="0"/>
+                <a:ea typeface="Courier New" pitchFamily="34" charset="-122"/>
+                <a:cs typeface="Courier New" pitchFamily="34" charset="-120"/>
+              </a:rPr>
+              <a:t>TransactionID (PK)</a:t>
+            </a:r>
+            <a:endParaRPr lang="en-US" sz="1100" dirty="0"/>
+          </a:p>
+          <a:p>
+            <a:pPr indent="0" marL="0">
+              <a:buNone/>
+            </a:pPr>
+            <a:r>
+              <a:rPr lang="en-US" sz="1100" dirty="0">
+                <a:solidFill>
+                  <a:srgbClr val="1E2A35"/>
+                </a:solidFill>
+                <a:latin typeface="Courier New" pitchFamily="34" charset="0"/>
+                <a:ea typeface="Courier New" pitchFamily="34" charset="-122"/>
+                <a:cs typeface="Courier New" pitchFamily="34" charset="-120"/>
+              </a:rPr>
+              <a:t>CustomerID (FK)</a:t>
+            </a:r>
+            <a:endParaRPr lang="en-US" sz="1100" dirty="0"/>
+          </a:p>
+          <a:p>
+            <a:pPr indent="0" marL="0">
+              <a:buNone/>
+            </a:pPr>
+            <a:r>
+              <a:rPr lang="en-US" sz="1100" dirty="0">
+                <a:solidFill>
+                  <a:srgbClr val="1E2A35"/>
+                </a:solidFill>
+                <a:latin typeface="Courier New" pitchFamily="34" charset="0"/>
+                <a:ea typeface="Courier New" pitchFamily="34" charset="-122"/>
+                <a:cs typeface="Courier New" pitchFamily="34" charset="-120"/>
+              </a:rPr>
+              <a:t>ProductID (FK)</a:t>
+            </a:r>
+            <a:endParaRPr lang="en-US" sz="1100" dirty="0"/>
+          </a:p>
+          <a:p>
+            <a:pPr indent="0" marL="0">
+              <a:buNone/>
+            </a:pPr>
+            <a:r>
+              <a:rPr lang="en-US" sz="1100" dirty="0">
+                <a:solidFill>
+                  <a:srgbClr val="1E2A35"/>
+                </a:solidFill>
+                <a:latin typeface="Courier New" pitchFamily="34" charset="0"/>
+                <a:ea typeface="Courier New" pitchFamily="34" charset="-122"/>
+                <a:cs typeface="Courier New" pitchFamily="34" charset="-120"/>
+              </a:rPr>
+              <a:t>TransactionDate</a:t>
+            </a:r>
+            <a:endParaRPr lang="en-US" sz="1100" dirty="0"/>
+          </a:p>
+          <a:p>
+            <a:pPr indent="0" marL="0">
+              <a:buNone/>
+            </a:pPr>
+            <a:r>
+              <a:rPr lang="en-US" sz="1100" dirty="0">
+                <a:solidFill>
+                  <a:srgbClr val="1E2A35"/>
+                </a:solidFill>
+                <a:latin typeface="Courier New" pitchFamily="34" charset="0"/>
+                <a:ea typeface="Courier New" pitchFamily="34" charset="-122"/>
+                <a:cs typeface="Courier New" pitchFamily="34" charset="-120"/>
+              </a:rPr>
+              <a:t>Quantity</a:t>
+            </a:r>
+            <a:endParaRPr lang="en-US" sz="1100" dirty="0"/>
+          </a:p>
+          <a:p>
+            <a:pPr indent="0" marL="0">
+              <a:buNone/>
+            </a:pPr>
+            <a:r>
+              <a:rPr lang="en-US" sz="1100" dirty="0">
+                <a:solidFill>
+                  <a:srgbClr val="1E2A35"/>
+                </a:solidFill>
+                <a:latin typeface="Courier New" pitchFamily="34" charset="0"/>
+                <a:ea typeface="Courier New" pitchFamily="34" charset="-122"/>
+                <a:cs typeface="Courier New" pitchFamily="34" charset="-120"/>
+              </a:rPr>
+              <a:t>TotalValue</a:t>
+            </a:r>
+            <a:endParaRPr lang="en-US" sz="1100" dirty="0"/>
+          </a:p>
+          <a:p>
+            <a:pPr indent="0" marL="0">
+              <a:buNone/>
+            </a:pPr>
+            <a:r>
+              <a:rPr lang="en-US" sz="1100" dirty="0">
+                <a:solidFill>
+                  <a:srgbClr val="1E2A35"/>
+                </a:solidFill>
+                <a:latin typeface="Courier New" pitchFamily="34" charset="0"/>
+                <a:ea typeface="Courier New" pitchFamily="34" charset="-122"/>
+                <a:cs typeface="Courier New" pitchFamily="34" charset="-120"/>
+              </a:rPr>
+              <a:t>Price</a:t>
+            </a:r>
+            <a:endParaRPr lang="en-US" sz="1100" dirty="0"/>
+          </a:p>
+        </p:txBody>
+      </p:sp>
+      <p:sp>
+        <p:nvSpPr>
+          <p:cNvPr id="19" name="Shape 15"/>
+          <p:cNvSpPr/>
+          <p:nvPr/>
+        </p:nvSpPr>
+        <p:spPr>
+          <a:xfrm>
+            <a:off x="6126480" y="1371600"/>
+            <a:ext cx="2103120" cy="2468880"/>
+          </a:xfrm>
+          <a:prstGeom prst="roundRect">
+            <a:avLst>
+              <a:gd name="adj" fmla="val 4348"/>
+            </a:avLst>
+          </a:prstGeom>
+          <a:solidFill>
+            <a:srgbClr val="FFFFFF"/>
+          </a:solidFill>
+          <a:ln w="31750">
+            <a:solidFill>
+              <a:srgbClr val="E8832B"/>
+            </a:solidFill>
+            <a:prstDash val="solid"/>
+          </a:ln>
+        </p:spPr>
+      </p:sp>
+      <p:sp>
+        <p:nvSpPr>
+          <p:cNvPr id="20" name="Shape 16"/>
+          <p:cNvSpPr/>
+          <p:nvPr/>
+        </p:nvSpPr>
+        <p:spPr>
+          <a:xfrm>
+            <a:off x="6126480" y="1371600"/>
+            <a:ext cx="2103120" cy="502920"/>
+          </a:xfrm>
+          <a:prstGeom prst="rect">
+            <a:avLst/>
+          </a:prstGeom>
+          <a:solidFill>
+            <a:srgbClr val="E8832B"/>
+          </a:solidFill>
+          <a:ln w="12700">
+            <a:solidFill>
+              <a:srgbClr val="E8832B"/>
+            </a:solidFill>
+            <a:prstDash val="solid"/>
+          </a:ln>
+        </p:spPr>
+      </p:sp>
+      <p:sp>
+        <p:nvSpPr>
+          <p:cNvPr id="21" name="Text 17"/>
+          <p:cNvSpPr txBox="1"/>
+          <p:nvPr/>
+        </p:nvSpPr>
+        <p:spPr>
+          <a:xfrm>
+            <a:off x="6126480" y="1371600"/>
+            <a:ext cx="2103120" cy="502920"/>
+          </a:xfrm>
+          <a:prstGeom prst="rect">
+            <a:avLst/>
+          </a:prstGeom>
+          <a:noFill/>
+          <a:ln/>
+        </p:spPr>
+        <p:txBody>
+          <a:bodyPr wrap="square" lIns="0" tIns="0" rIns="0" bIns="0" rtlCol="0" anchor="ctr"/>
+          <a:lstStyle/>
+          <a:p>
+            <a:pPr algn="ctr" indent="0" marL="0">
+              <a:buNone/>
+            </a:pPr>
+            <a:r>
+              <a:rPr lang="en-US" sz="1500" b="1" dirty="0">
+                <a:solidFill>
+                  <a:srgbClr val="FFFFFF"/>
+                </a:solidFill>
+                <a:latin typeface="Cambria" pitchFamily="34" charset="0"/>
+                <a:ea typeface="Cambria" pitchFamily="34" charset="-122"/>
+                <a:cs typeface="Cambria" pitchFamily="34" charset="-120"/>
+              </a:rPr>
+              <a:t>Products</a:t>
+            </a:r>
+            <a:endParaRPr lang="en-US" sz="1500" dirty="0"/>
+          </a:p>
+        </p:txBody>
+      </p:sp>
+      <p:sp>
+        <p:nvSpPr>
+          <p:cNvPr id="22" name="Text 18"/>
+          <p:cNvSpPr txBox="1"/>
+          <p:nvPr/>
+        </p:nvSpPr>
+        <p:spPr>
+          <a:xfrm>
+            <a:off x="6263640" y="1965960"/>
+            <a:ext cx="1828800" cy="1783080"/>
+          </a:xfrm>
+          <a:prstGeom prst="rect">
+            <a:avLst/>
+          </a:prstGeom>
+          <a:noFill/>
+          <a:ln/>
+        </p:spPr>
+        <p:txBody>
+          <a:bodyPr wrap="square" lIns="0" tIns="0" rIns="0" bIns="0" rtlCol="0" anchor="t"/>
+          <a:lstStyle/>
+          <a:p>
+            <a:pPr indent="0" marL="0">
+              <a:buNone/>
+            </a:pPr>
+            <a:r>
+              <a:rPr lang="en-US" sz="1100" dirty="0">
+                <a:solidFill>
+                  <a:srgbClr val="1E2A35"/>
+                </a:solidFill>
+                <a:latin typeface="Courier New" pitchFamily="34" charset="0"/>
+                <a:ea typeface="Courier New" pitchFamily="34" charset="-122"/>
+                <a:cs typeface="Courier New" pitchFamily="34" charset="-120"/>
+              </a:rPr>
+              <a:t>ProductID (PK)</a:t>
+            </a:r>
+            <a:endParaRPr lang="en-US" sz="1100" dirty="0"/>
+          </a:p>
+          <a:p>
+            <a:pPr indent="0" marL="0">
+              <a:buNone/>
+            </a:pPr>
+            <a:r>
+              <a:rPr lang="en-US" sz="1100" dirty="0">
+                <a:solidFill>
+                  <a:srgbClr val="1E2A35"/>
+                </a:solidFill>
+                <a:latin typeface="Courier New" pitchFamily="34" charset="0"/>
+                <a:ea typeface="Courier New" pitchFamily="34" charset="-122"/>
+                <a:cs typeface="Courier New" pitchFamily="34" charset="-120"/>
+              </a:rPr>
+              <a:t>ProductName</a:t>
+            </a:r>
+            <a:endParaRPr lang="en-US" sz="1100" dirty="0"/>
+          </a:p>
+          <a:p>
+            <a:pPr indent="0" marL="0">
+              <a:buNone/>
+            </a:pPr>
+            <a:r>
+              <a:rPr lang="en-US" sz="1100" dirty="0">
+                <a:solidFill>
+                  <a:srgbClr val="1E2A35"/>
+                </a:solidFill>
+                <a:latin typeface="Courier New" pitchFamily="34" charset="0"/>
+                <a:ea typeface="Courier New" pitchFamily="34" charset="-122"/>
+                <a:cs typeface="Courier New" pitchFamily="34" charset="-120"/>
+              </a:rPr>
+              <a:t>Category</a:t>
+            </a:r>
+            <a:endParaRPr lang="en-US" sz="1100" dirty="0"/>
+          </a:p>
+          <a:p>
+            <a:pPr indent="0" marL="0">
+              <a:buNone/>
+            </a:pPr>
+            <a:r>
+              <a:rPr lang="en-US" sz="1100" dirty="0">
+                <a:solidFill>
+                  <a:srgbClr val="1E2A35"/>
+                </a:solidFill>
+                <a:latin typeface="Courier New" pitchFamily="34" charset="0"/>
+                <a:ea typeface="Courier New" pitchFamily="34" charset="-122"/>
+                <a:cs typeface="Courier New" pitchFamily="34" charset="-120"/>
+              </a:rPr>
+              <a:t>Price</a:t>
+            </a:r>
+            <a:endParaRPr lang="en-US" sz="1100" dirty="0"/>
+          </a:p>
+        </p:txBody>
+      </p:sp>
+      <p:sp>
+        <p:nvSpPr>
+          <p:cNvPr id="23" name="Shape 19"/>
+          <p:cNvSpPr/>
+          <p:nvPr/>
+        </p:nvSpPr>
+        <p:spPr>
+          <a:xfrm>
+            <a:off x="2651760" y="2651760"/>
+            <a:ext cx="594360" cy="0"/>
+          </a:xfrm>
+          <a:prstGeom prst="line">
+            <a:avLst/>
+          </a:prstGeom>
+          <a:noFill/>
+          <a:ln w="38100">
+            <a:solidFill>
+              <a:srgbClr val="5B6B79"/>
+            </a:solidFill>
+            <a:prstDash val="solid"/>
+          </a:ln>
+        </p:spPr>
+      </p:sp>
+      <p:sp>
+        <p:nvSpPr>
+          <p:cNvPr id="24" name="Shape 20"/>
+          <p:cNvSpPr/>
+          <p:nvPr/>
+        </p:nvSpPr>
+        <p:spPr>
+          <a:xfrm>
+            <a:off x="5532120" y="2651760"/>
+            <a:ext cx="594360" cy="0"/>
+          </a:xfrm>
+          <a:prstGeom prst="line">
+            <a:avLst/>
+          </a:prstGeom>
+          <a:noFill/>
+          <a:ln w="38100">
+            <a:solidFill>
+              <a:srgbClr val="5B6B79"/>
+            </a:solidFill>
+            <a:prstDash val="solid"/>
+          </a:ln>
+        </p:spPr>
+      </p:sp>
+      <p:sp>
+        <p:nvSpPr>
+          <p:cNvPr id="25" name="Text 21"/>
+          <p:cNvSpPr txBox="1"/>
+          <p:nvPr/>
+        </p:nvSpPr>
+        <p:spPr>
+          <a:xfrm>
+            <a:off x="2670048" y="2286000"/>
+            <a:ext cx="274320" cy="320040"/>
+          </a:xfrm>
+          <a:prstGeom prst="rect">
+            <a:avLst/>
+          </a:prstGeom>
+          <a:noFill/>
+          <a:ln/>
+        </p:spPr>
+        <p:txBody>
+          <a:bodyPr wrap="square" lIns="0" tIns="0" rIns="0" bIns="0" rtlCol="0" anchor="ctr"/>
+          <a:lstStyle/>
+          <a:p>
+            <a:pPr indent="0" marL="0">
+              <a:buNone/>
+            </a:pPr>
+            <a:r>
+              <a:rPr lang="en-US" sz="1600" b="1" dirty="0">
+                <a:solidFill>
+                  <a:srgbClr val="E02F8A"/>
                 </a:solidFill>
                 <a:latin typeface="Calibri" pitchFamily="34" charset="0"/>
                 <a:ea typeface="Calibri" pitchFamily="34" charset="-122"/>
                 <a:cs typeface="Calibri" pitchFamily="34" charset="-120"/>
               </a:rPr>
-              <a:t>TEMPEL SCREENSHOT</a:t>
-            </a:r>
-            <a:endParaRPr lang="en-US" sz="1200" dirty="0"/>
-          </a:p>
-          <a:p>
-            <a:pPr algn="ctr" indent="0" marL="0">
+              <a:t>1</a:t>
+            </a:r>
+            <a:endParaRPr lang="en-US" sz="1600" dirty="0"/>
+          </a:p>
+        </p:txBody>
+      </p:sp>
+      <p:sp>
+        <p:nvSpPr>
+          <p:cNvPr id="26" name="Text 22"/>
+          <p:cNvSpPr txBox="1"/>
+          <p:nvPr/>
+        </p:nvSpPr>
+        <p:spPr>
+          <a:xfrm>
+            <a:off x="2999232" y="2240280"/>
+            <a:ext cx="274320" cy="320040"/>
+          </a:xfrm>
+          <a:prstGeom prst="rect">
+            <a:avLst/>
+          </a:prstGeom>
+          <a:noFill/>
+          <a:ln/>
+        </p:spPr>
+        <p:txBody>
+          <a:bodyPr wrap="square" lIns="0" tIns="0" rIns="0" bIns="0" rtlCol="0" anchor="ctr"/>
+          <a:lstStyle/>
+          <a:p>
+            <a:pPr indent="0" marL="0">
               <a:buNone/>
             </a:pPr>
             <a:r>
               <a:rPr lang="en-US" sz="1600" b="1" dirty="0">
                 <a:solidFill>
-                  <a:srgbClr val="1A0683"/>
+                  <a:srgbClr val="E02F8A"/>
                 </a:solidFill>
                 <a:latin typeface="Calibri" pitchFamily="34" charset="0"/>
                 <a:ea typeface="Calibri" pitchFamily="34" charset="-122"/>
                 <a:cs typeface="Calibri" pitchFamily="34" charset="-120"/>
               </a:rPr>
-              <a:t>Model view</a:t>
-            </a:r>
-            <a:endParaRPr lang="en-US" sz="1200" dirty="0"/>
-          </a:p>
-          <a:p>
-            <a:pPr algn="ctr" indent="0" marL="0">
+              <a:t>*</a:t>
+            </a:r>
+            <a:endParaRPr lang="en-US" sz="1600" dirty="0"/>
+          </a:p>
+        </p:txBody>
+      </p:sp>
+      <p:sp>
+        <p:nvSpPr>
+          <p:cNvPr id="27" name="Text 23"/>
+          <p:cNvSpPr txBox="1"/>
+          <p:nvPr/>
+        </p:nvSpPr>
+        <p:spPr>
+          <a:xfrm>
+            <a:off x="5577840" y="2240280"/>
+            <a:ext cx="274320" cy="320040"/>
+          </a:xfrm>
+          <a:prstGeom prst="rect">
+            <a:avLst/>
+          </a:prstGeom>
+          <a:noFill/>
+          <a:ln/>
+        </p:spPr>
+        <p:txBody>
+          <a:bodyPr wrap="square" lIns="0" tIns="0" rIns="0" bIns="0" rtlCol="0" anchor="ctr"/>
+          <a:lstStyle/>
+          <a:p>
+            <a:pPr indent="0" marL="0">
               <a:buNone/>
             </a:pPr>
             <a:r>
-              <a:rPr lang="en-US" sz="1200" dirty="0">
-                <a:solidFill>
-                  <a:srgbClr val="5B6B79"/>
+              <a:rPr lang="en-US" sz="1600" b="1" dirty="0">
+                <a:solidFill>
+                  <a:srgbClr val="E02F8A"/>
                 </a:solidFill>
                 <a:latin typeface="Calibri" pitchFamily="34" charset="0"/>
                 <a:ea typeface="Calibri" pitchFamily="34" charset="-122"/>
                 <a:cs typeface="Calibri" pitchFamily="34" charset="-120"/>
               </a:rPr>
-              <a:t>Power BI: ikon ketiga di bilah kiri (Model view), pastikan tiga tabel dan garis relasi terlihat</a:t>
-            </a:r>
-            <a:endParaRPr lang="en-US" sz="1200" dirty="0"/>
-          </a:p>
-        </p:txBody>
-      </p:sp>
-      <p:sp>
-        <p:nvSpPr>
-          <p:cNvPr id="13" name="Text 9"/>
+              <a:t>*</a:t>
+            </a:r>
+            <a:endParaRPr lang="en-US" sz="1600" dirty="0"/>
+          </a:p>
+        </p:txBody>
+      </p:sp>
+      <p:sp>
+        <p:nvSpPr>
+          <p:cNvPr id="28" name="Text 24"/>
           <p:cNvSpPr txBox="1"/>
           <p:nvPr/>
         </p:nvSpPr>
         <p:spPr>
           <a:xfrm>
-            <a:off x="548640" y="5532120"/>
-            <a:ext cx="6949440" cy="731520"/>
+            <a:off x="5897880" y="2286000"/>
+            <a:ext cx="274320" cy="320040"/>
           </a:xfrm>
           <a:prstGeom prst="rect">
             <a:avLst/>
@@ -14263,22 +14922,61 @@
           <a:ln/>
         </p:spPr>
         <p:txBody>
-          <a:bodyPr wrap="square" lIns="0" tIns="0" rIns="0" bIns="0" rtlCol="0" anchor="t"/>
+          <a:bodyPr wrap="square" lIns="0" tIns="0" rIns="0" bIns="0" rtlCol="0" anchor="ctr"/>
           <a:lstStyle/>
           <a:p>
             <a:pPr indent="0" marL="0">
               <a:buNone/>
             </a:pPr>
             <a:r>
-              <a:rPr lang="en-US" sz="1200" dirty="0">
-                <a:solidFill>
-                  <a:srgbClr val="5B6B79"/>
+              <a:rPr lang="en-US" sz="1600" b="1" dirty="0">
+                <a:solidFill>
+                  <a:srgbClr val="E02F8A"/>
                 </a:solidFill>
                 <a:latin typeface="Calibri" pitchFamily="34" charset="0"/>
                 <a:ea typeface="Calibri" pitchFamily="34" charset="-122"/>
                 <a:cs typeface="Calibri" pitchFamily="34" charset="-120"/>
               </a:rPr>
-              <a:t>Cara mengambil: klik ikon Model view, atur letak tabel hingga ketiga garis relasi terlihat, lalu screenshot.</a:t>
+              <a:t>1</a:t>
+            </a:r>
+            <a:endParaRPr lang="en-US" sz="1600" dirty="0"/>
+          </a:p>
+        </p:txBody>
+      </p:sp>
+      <p:sp>
+        <p:nvSpPr>
+          <p:cNvPr id="29" name="Text 25"/>
+          <p:cNvSpPr txBox="1"/>
+          <p:nvPr/>
+        </p:nvSpPr>
+        <p:spPr>
+          <a:xfrm>
+            <a:off x="548640" y="4800600"/>
+            <a:ext cx="7680960" cy="320040"/>
+          </a:xfrm>
+          <a:prstGeom prst="rect">
+            <a:avLst/>
+          </a:prstGeom>
+          <a:noFill/>
+          <a:ln/>
+        </p:spPr>
+        <p:txBody>
+          <a:bodyPr wrap="square" lIns="0" tIns="0" rIns="0" bIns="0" rtlCol="0" anchor="ctr"/>
+          <a:lstStyle/>
+          <a:p>
+            <a:pPr indent="0" marL="0">
+              <a:buNone/>
+            </a:pPr>
+            <a:r>
+              <a:rPr lang="en-US" sz="1200" dirty="0">
+                <a:solidFill>
+                  <a:srgbClr val="1E2A35"/>
+                </a:solidFill>
+                <a:latin typeface="Courier New" pitchFamily="34" charset="0"/>
+                <a:ea typeface="Courier New" pitchFamily="34" charset="-122"/>
+                <a:cs typeface="Courier New" pitchFamily="34" charset="-120"/>
+              </a:rPr>
+              <a:t>Customers[CustomerID] 1 ---- * Transactions[CustomerID]</a:t>
             </a:r>
             <a:endParaRPr lang="en-US" sz="1200" dirty="0"/>
           </a:p>
@@ -14286,18 +14984,96 @@
       </p:sp>
       <p:sp>
         <p:nvSpPr>
-          <p:cNvPr id="14" name="Shape 10"/>
+          <p:cNvPr id="30" name="Text 26"/>
+          <p:cNvSpPr txBox="1"/>
+          <p:nvPr/>
+        </p:nvSpPr>
+        <p:spPr>
+          <a:xfrm>
+            <a:off x="548640" y="5166360"/>
+            <a:ext cx="7680960" cy="320040"/>
+          </a:xfrm>
+          <a:prstGeom prst="rect">
+            <a:avLst/>
+          </a:prstGeom>
+          <a:noFill/>
+          <a:ln/>
+        </p:spPr>
+        <p:txBody>
+          <a:bodyPr wrap="square" lIns="0" tIns="0" rIns="0" bIns="0" rtlCol="0" anchor="ctr"/>
+          <a:lstStyle/>
+          <a:p>
+            <a:pPr indent="0" marL="0">
+              <a:buNone/>
+            </a:pPr>
+            <a:r>
+              <a:rPr lang="en-US" sz="1200" dirty="0">
+                <a:solidFill>
+                  <a:srgbClr val="1E2A35"/>
+                </a:solidFill>
+                <a:latin typeface="Courier New" pitchFamily="34" charset="0"/>
+                <a:ea typeface="Courier New" pitchFamily="34" charset="-122"/>
+                <a:cs typeface="Courier New" pitchFamily="34" charset="-120"/>
+              </a:rPr>
+              <a:t>Products[ProductID] 1 ---- * Transactions[ProductID]</a:t>
+            </a:r>
+            <a:endParaRPr lang="en-US" sz="1200" dirty="0"/>
+          </a:p>
+        </p:txBody>
+      </p:sp>
+      <p:sp>
+        <p:nvSpPr>
+          <p:cNvPr id="31" name="Text 27"/>
+          <p:cNvSpPr txBox="1"/>
+          <p:nvPr/>
+        </p:nvSpPr>
+        <p:spPr>
+          <a:xfrm>
+            <a:off x="548640" y="5623560"/>
+            <a:ext cx="7680960" cy="548640"/>
+          </a:xfrm>
+          <a:prstGeom prst="rect">
+            <a:avLst/>
+          </a:prstGeom>
+          <a:noFill/>
+          <a:ln/>
+        </p:spPr>
+        <p:txBody>
+          <a:bodyPr wrap="square" lIns="0" tIns="0" rIns="0" bIns="0" rtlCol="0" anchor="t"/>
+          <a:lstStyle/>
+          <a:p>
+            <a:pPr indent="0" marL="0">
+              <a:buNone/>
+            </a:pPr>
+            <a:r>
+              <a:rPr lang="en-US" sz="1200" dirty="0">
+                <a:solidFill>
+                  <a:srgbClr val="5B6B79"/>
+                </a:solidFill>
+                <a:latin typeface="Calibri" pitchFamily="34" charset="0"/>
+                <a:ea typeface="Calibri" pitchFamily="34" charset="-122"/>
+                <a:cs typeface="Calibri" pitchFamily="34" charset="-120"/>
+              </a:rPr>
+              <a:t>Kedua relasi: aktif, banyak-ke-satu, arah filter tunggal (dari dimensi ke fakta). PK = kunci utama, FK = kunci tamu.</a:t>
+            </a:r>
+            <a:endParaRPr lang="en-US" sz="1200" dirty="0"/>
+          </a:p>
+        </p:txBody>
+      </p:sp>
+      <p:sp>
+        <p:nvSpPr>
+          <p:cNvPr id="32" name="Shape 28"/>
           <p:cNvSpPr/>
           <p:nvPr/>
         </p:nvSpPr>
         <p:spPr>
           <a:xfrm>
-            <a:off x="7680960" y="1280160"/>
-            <a:ext cx="3931920" cy="5029200"/>
+            <a:off x="8503920" y="1280160"/>
+            <a:ext cx="3108960" cy="5029200"/>
           </a:xfrm>
           <a:prstGeom prst="roundRect">
             <a:avLst>
-              <a:gd name="adj" fmla="val 2326"/>
+              <a:gd name="adj" fmla="val 2941"/>
             </a:avLst>
           </a:prstGeom>
           <a:solidFill>
@@ -14313,13 +15089,13 @@
       </p:sp>
       <p:sp>
         <p:nvSpPr>
-          <p:cNvPr id="15" name="Shape 11"/>
+          <p:cNvPr id="33" name="Shape 29"/>
           <p:cNvSpPr/>
           <p:nvPr/>
         </p:nvSpPr>
         <p:spPr>
           <a:xfrm>
-            <a:off x="7680960" y="1371600"/>
+            <a:off x="8503920" y="1371600"/>
             <a:ext cx="82296" cy="4846320"/>
           </a:xfrm>
           <a:prstGeom prst="rect">
@@ -14338,14 +15114,14 @@
       </p:sp>
       <p:sp>
         <p:nvSpPr>
-          <p:cNvPr id="16" name="Text 12"/>
+          <p:cNvPr id="34" name="Text 30"/>
           <p:cNvSpPr txBox="1"/>
           <p:nvPr/>
         </p:nvSpPr>
         <p:spPr>
           <a:xfrm>
-            <a:off x="7909560" y="1417320"/>
-            <a:ext cx="3520440" cy="411480"/>
+            <a:off x="8732520" y="1417320"/>
+            <a:ext cx="2697480" cy="411480"/>
           </a:xfrm>
           <a:prstGeom prst="rect">
             <a:avLst/>
@@ -14377,14 +15153,14 @@
       </p:sp>
       <p:sp>
         <p:nvSpPr>
-          <p:cNvPr id="17" name="Text 13"/>
+          <p:cNvPr id="35" name="Text 31"/>
           <p:cNvSpPr txBox="1"/>
           <p:nvPr/>
         </p:nvSpPr>
         <p:spPr>
           <a:xfrm>
-            <a:off x="7909560" y="1920240"/>
-            <a:ext cx="3520440" cy="4251960"/>
+            <a:off x="8732520" y="1920240"/>
+            <a:ext cx="2697480" cy="4251960"/>
           </a:xfrm>
           <a:prstGeom prst="rect">
             <a:avLst/>

</xml_diff>